<commit_message>
Committee round 2: style, chart data, layout fixes and rebuilt outputs
Co-Authored-By: Claude Opus 5.5 <noreply@anthropic.com>
Claude-Session: https://claude.ai/code/session_011SJZihQQoizcK7ApWgRNEa
</commit_message>
<xml_diff>
--- a/outputs/LLC_AI_Infrastructure_Case_Study.pptx
+++ b/outputs/LLC_AI_Infrastructure_Case_Study.pptx
@@ -107,6 +107,809 @@
     </a:lvl9pPr>
   </p:defaultTextStyle>
 </p:presentation>
+</file>
+
+<file path=ppt/charts/chart1.xml><?xml version="1.0" encoding="utf-8"?>
+<c:chartSpace xmlns:c="http://schemas.openxmlformats.org/drawingml/2006/chart" xmlns:a="http://schemas.openxmlformats.org/drawingml/2006/main" xmlns:r="http://schemas.openxmlformats.org/officeDocument/2006/relationships">
+  <c:date1904 val="0"/>
+  <c:roundedCorners val="1"/>
+  <c:chart>
+    <c:autoTitleDeleted val="1"/>
+    <c:plotArea>
+      <c:layout/>
+      <c:barChart>
+        <c:barDir val="col"/>
+        <c:grouping val="clustered"/>
+        <c:varyColors val="0"/>
+        <c:ser>
+          <c:idx val="0"/>
+          <c:order val="0"/>
+          <c:tx>
+            <c:strRef>
+              <c:f>Sheet1!$B$1</c:f>
+              <c:strCache>
+                <c:ptCount val="1"/>
+                <c:pt idx="0">
+                  <c:v>2026 Capex Versus Debt Funding ($bn)</c:v>
+                </c:pt>
+              </c:strCache>
+            </c:strRef>
+          </c:tx>
+          <c:spPr>
+            <a:solidFill>
+              <a:srgbClr val="9A3839"/>
+            </a:solidFill>
+            <a:effectLst/>
+          </c:spPr>
+          <c:invertIfNegative val="0"/>
+          <c:dLbls>
+            <c:numFmt formatCode="0" sourceLinked="0"/>
+            <c:txPr>
+              <a:bodyPr/>
+              <a:lstStyle/>
+              <a:p>
+                <a:pPr>
+                  <a:defRPr b="0" i="0" strike="noStrike" sz="800" u="none">
+                    <a:solidFill>
+                      <a:srgbClr val="000000"/>
+                    </a:solidFill>
+                    <a:latin typeface="Times New Roman"/>
+                  </a:defRPr>
+                </a:pPr>
+              </a:p>
+            </c:txPr>
+            <c:showLegendKey val="0"/>
+            <c:showVal val="1"/>
+            <c:showCatName val="0"/>
+            <c:showSerName val="0"/>
+            <c:showPercent val="0"/>
+            <c:showBubbleSize val="0"/>
+            <c:showLeaderLines val="0"/>
+          </c:dLbls>
+          <c:dPt>
+            <c:idx val="0"/>
+            <c:invertIfNegative val="0"/>
+            <c:bubble3D val="0"/>
+            <c:spPr>
+              <a:solidFill>
+                <a:srgbClr val="9A3839"/>
+              </a:solidFill>
+              <a:effectLst/>
+            </c:spPr>
+          </c:dPt>
+          <c:dPt>
+            <c:idx val="1"/>
+            <c:invertIfNegative val="0"/>
+            <c:bubble3D val="0"/>
+            <c:spPr>
+              <a:solidFill>
+                <a:srgbClr val="4F1D1B"/>
+              </a:solidFill>
+              <a:effectLst/>
+            </c:spPr>
+          </c:dPt>
+          <c:cat>
+            <c:multiLvlStrRef>
+              <c:f>Sheet1!$A$2:$A$3</c:f>
+              <c:multiLvlStrCache>
+                <c:ptCount val="2"/>
+                <c:lvl>
+                  <c:pt idx="0">
+                    <c:v>2026 capex</c:v>
+                  </c:pt>
+                  <c:pt idx="1">
+                    <c:v>2026 debt issuance estimate</c:v>
+                  </c:pt>
+                </c:lvl>
+              </c:multiLvlStrCache>
+            </c:multiLvlStrRef>
+          </c:cat>
+          <c:val>
+            <c:numRef>
+              <c:f>Sheet1!$B$2:$B$3</c:f>
+              <c:numCache>
+                <c:formatCode>General</c:formatCode>
+                <c:ptCount val="2"/>
+                <c:pt idx="0">
+                  <c:v>750</c:v>
+                </c:pt>
+                <c:pt idx="1">
+                  <c:v>250</c:v>
+                </c:pt>
+              </c:numCache>
+            </c:numRef>
+          </c:val>
+        </c:ser>
+        <c:dLbls>
+          <c:numFmt formatCode="0" sourceLinked="0"/>
+          <c:txPr>
+            <a:bodyPr/>
+            <a:lstStyle/>
+            <a:p>
+              <a:pPr>
+                <a:defRPr b="0" i="0" strike="noStrike" sz="800" u="none">
+                  <a:solidFill>
+                    <a:srgbClr val="000000"/>
+                  </a:solidFill>
+                  <a:latin typeface="Times New Roman"/>
+                </a:defRPr>
+              </a:pPr>
+            </a:p>
+          </c:txPr>
+          <c:showLegendKey val="0"/>
+          <c:showVal val="1"/>
+          <c:showCatName val="0"/>
+          <c:showSerName val="0"/>
+          <c:showPercent val="0"/>
+          <c:showBubbleSize val="0"/>
+          <c:showLeaderLines val="0"/>
+        </c:dLbls>
+        <c:gapWidth val="60"/>
+        <c:overlap val="0"/>
+        <c:axId val="2094734554"/>
+        <c:axId val="2094734552"/>
+        <c:axId val="2094734556"/>
+      </c:barChart>
+      <c:catAx>
+        <c:axId val="2094734554"/>
+        <c:scaling>
+          <c:orientation val="minMax"/>
+        </c:scaling>
+        <c:delete val="0"/>
+        <c:axPos val="b"/>
+        <c:numFmt formatCode="General" sourceLinked="1"/>
+        <c:majorTickMark val="out"/>
+        <c:minorTickMark val="none"/>
+        <c:tickLblPos val="low"/>
+        <c:spPr>
+          <a:ln w="12700" cap="flat">
+            <a:solidFill>
+              <a:srgbClr val="888888"/>
+            </a:solidFill>
+            <a:prstDash val="solid"/>
+            <a:round/>
+          </a:ln>
+        </c:spPr>
+        <c:txPr>
+          <a:bodyPr/>
+          <a:lstStyle/>
+          <a:p>
+            <a:pPr>
+              <a:defRPr sz="800" b="0" i="0" u="none" strike="noStrike">
+                <a:solidFill>
+                  <a:srgbClr val="000000"/>
+                </a:solidFill>
+                <a:latin typeface="Times New Roman"/>
+              </a:defRPr>
+            </a:pPr>
+            <a:endParaRPr lang="en-US"/>
+          </a:p>
+        </c:txPr>
+        <c:crossAx val="2094734552"/>
+        <c:crosses val="autoZero"/>
+        <c:auto val="1"/>
+        <c:lblAlgn val="ctr"/>
+        <c:noMultiLvlLbl val="1"/>
+      </c:catAx>
+      <c:valAx>
+        <c:axId val="2094734552"/>
+        <c:scaling>
+          <c:orientation val="minMax"/>
+        </c:scaling>
+        <c:delete val="1"/>
+        <c:axPos val="l"/>
+        <c:numFmt formatCode="General" sourceLinked="0"/>
+        <c:majorTickMark val="out"/>
+        <c:minorTickMark val="none"/>
+        <c:tickLblPos val="nextTo"/>
+        <c:spPr>
+          <a:ln w="12700" cap="flat">
+            <a:solidFill>
+              <a:srgbClr val="888888"/>
+            </a:solidFill>
+            <a:prstDash val="solid"/>
+            <a:round/>
+          </a:ln>
+        </c:spPr>
+        <c:txPr>
+          <a:bodyPr/>
+          <a:lstStyle/>
+          <a:p>
+            <a:pPr>
+              <a:defRPr sz="800" b="0" i="0" u="none" strike="noStrike">
+                <a:solidFill>
+                  <a:srgbClr val="000000"/>
+                </a:solidFill>
+                <a:latin typeface="Times New Roman"/>
+              </a:defRPr>
+            </a:pPr>
+            <a:endParaRPr lang="en-US"/>
+          </a:p>
+        </c:txPr>
+        <c:crossAx val="2094734554"/>
+        <c:crosses val="autoZero"/>
+        <c:crossBetween val="between"/>
+      </c:valAx>
+      <c:spPr>
+        <a:noFill/>
+        <a:ln>
+          <a:noFill/>
+        </a:ln>
+        <a:effectLst/>
+      </c:spPr>
+    </c:plotArea>
+    <c:plotVisOnly val="1"/>
+    <c:dispBlanksAs val="span"/>
+  </c:chart>
+  <c:spPr>
+    <a:noFill/>
+    <a:ln>
+      <a:noFill/>
+    </a:ln>
+    <a:effectLst/>
+  </c:spPr>
+  <c:externalData r:id="rId1">
+    <c:autoUpdate val="0"/>
+  </c:externalData>
+</c:chartSpace>
+</file>
+
+<file path=ppt/charts/chart2.xml><?xml version="1.0" encoding="utf-8"?>
+<c:chartSpace xmlns:c="http://schemas.openxmlformats.org/drawingml/2006/chart" xmlns:a="http://schemas.openxmlformats.org/drawingml/2006/main" xmlns:r="http://schemas.openxmlformats.org/officeDocument/2006/relationships">
+  <c:date1904 val="0"/>
+  <c:roundedCorners val="1"/>
+  <c:chart>
+    <c:autoTitleDeleted val="1"/>
+    <c:plotArea>
+      <c:layout/>
+      <c:barChart>
+        <c:barDir val="bar"/>
+        <c:grouping val="clustered"/>
+        <c:varyColors val="0"/>
+        <c:ser>
+          <c:idx val="0"/>
+          <c:order val="0"/>
+          <c:tx>
+            <c:strRef>
+              <c:f>Sheet1!$B$1</c:f>
+              <c:strCache>
+                <c:ptCount val="1"/>
+                <c:pt idx="0">
+                  <c:v>Asset Life Versus Debt Maturity (years)</c:v>
+                </c:pt>
+              </c:strCache>
+            </c:strRef>
+          </c:tx>
+          <c:spPr>
+            <a:solidFill>
+              <a:srgbClr val="9A3839"/>
+            </a:solidFill>
+            <a:effectLst/>
+          </c:spPr>
+          <c:invertIfNegative val="0"/>
+          <c:dLbls>
+            <c:numFmt formatCode="0" sourceLinked="0"/>
+            <c:txPr>
+              <a:bodyPr/>
+              <a:lstStyle/>
+              <a:p>
+                <a:pPr>
+                  <a:defRPr b="0" i="0" strike="noStrike" sz="800" u="none">
+                    <a:solidFill>
+                      <a:srgbClr val="000000"/>
+                    </a:solidFill>
+                    <a:latin typeface="Times New Roman"/>
+                  </a:defRPr>
+                </a:pPr>
+              </a:p>
+            </c:txPr>
+            <c:showLegendKey val="0"/>
+            <c:showVal val="1"/>
+            <c:showCatName val="0"/>
+            <c:showSerName val="0"/>
+            <c:showPercent val="0"/>
+            <c:showBubbleSize val="0"/>
+            <c:showLeaderLines val="0"/>
+          </c:dLbls>
+          <c:dPt>
+            <c:idx val="0"/>
+            <c:invertIfNegative val="0"/>
+            <c:bubble3D val="0"/>
+            <c:spPr>
+              <a:solidFill>
+                <a:srgbClr val="9A3839"/>
+              </a:solidFill>
+              <a:effectLst/>
+            </c:spPr>
+          </c:dPt>
+          <c:dPt>
+            <c:idx val="1"/>
+            <c:invertIfNegative val="0"/>
+            <c:bubble3D val="0"/>
+            <c:spPr>
+              <a:solidFill>
+                <a:srgbClr val="4F1D1B"/>
+              </a:solidFill>
+              <a:effectLst/>
+            </c:spPr>
+          </c:dPt>
+          <c:dPt>
+            <c:idx val="2"/>
+            <c:invertIfNegative val="0"/>
+            <c:bubble3D val="0"/>
+            <c:spPr>
+              <a:solidFill>
+                <a:srgbClr val="CD6661"/>
+              </a:solidFill>
+              <a:effectLst/>
+            </c:spPr>
+          </c:dPt>
+          <c:dPt>
+            <c:idx val="3"/>
+            <c:invertIfNegative val="0"/>
+            <c:bubble3D val="0"/>
+            <c:spPr>
+              <a:solidFill>
+                <a:srgbClr val="E0BCBC"/>
+              </a:solidFill>
+              <a:effectLst/>
+            </c:spPr>
+          </c:dPt>
+          <c:cat>
+            <c:multiLvlStrRef>
+              <c:f>Sheet1!$A$2:$A$5</c:f>
+              <c:multiLvlStrCache>
+                <c:ptCount val="4"/>
+                <c:lvl>
+                  <c:pt idx="0">
+                    <c:v>Hyperion initial lease</c:v>
+                  </c:pt>
+                  <c:pt idx="1">
+                    <c:v>El Paso lease</c:v>
+                  </c:pt>
+                  <c:pt idx="2">
+                    <c:v>El Paso bond maturity</c:v>
+                  </c:pt>
+                  <c:pt idx="3">
+                    <c:v>Hyperion bond maturity</c:v>
+                  </c:pt>
+                </c:lvl>
+              </c:multiLvlStrCache>
+            </c:multiLvlStrRef>
+          </c:cat>
+          <c:val>
+            <c:numRef>
+              <c:f>Sheet1!$B$2:$B$5</c:f>
+              <c:numCache>
+                <c:formatCode>General</c:formatCode>
+                <c:ptCount val="4"/>
+                <c:pt idx="0">
+                  <c:v>4</c:v>
+                </c:pt>
+                <c:pt idx="1">
+                  <c:v>20</c:v>
+                </c:pt>
+                <c:pt idx="2">
+                  <c:v>22</c:v>
+                </c:pt>
+                <c:pt idx="3">
+                  <c:v>24</c:v>
+                </c:pt>
+              </c:numCache>
+            </c:numRef>
+          </c:val>
+        </c:ser>
+        <c:dLbls>
+          <c:numFmt formatCode="0" sourceLinked="0"/>
+          <c:txPr>
+            <a:bodyPr/>
+            <a:lstStyle/>
+            <a:p>
+              <a:pPr>
+                <a:defRPr b="0" i="0" strike="noStrike" sz="800" u="none">
+                  <a:solidFill>
+                    <a:srgbClr val="000000"/>
+                  </a:solidFill>
+                  <a:latin typeface="Times New Roman"/>
+                </a:defRPr>
+              </a:pPr>
+            </a:p>
+          </c:txPr>
+          <c:showLegendKey val="0"/>
+          <c:showVal val="1"/>
+          <c:showCatName val="0"/>
+          <c:showSerName val="0"/>
+          <c:showPercent val="0"/>
+          <c:showBubbleSize val="0"/>
+          <c:showLeaderLines val="0"/>
+        </c:dLbls>
+        <c:gapWidth val="60"/>
+        <c:overlap val="0"/>
+        <c:axId val="2094734554"/>
+        <c:axId val="2094734552"/>
+        <c:axId val="2094734556"/>
+      </c:barChart>
+      <c:catAx>
+        <c:axId val="2094734554"/>
+        <c:scaling>
+          <c:orientation val="maxMin"/>
+        </c:scaling>
+        <c:delete val="0"/>
+        <c:axPos val="l"/>
+        <c:numFmt formatCode="General" sourceLinked="1"/>
+        <c:majorTickMark val="out"/>
+        <c:minorTickMark val="none"/>
+        <c:tickLblPos val="nextTo"/>
+        <c:spPr>
+          <a:ln w="12700" cap="flat">
+            <a:solidFill>
+              <a:srgbClr val="888888"/>
+            </a:solidFill>
+            <a:prstDash val="solid"/>
+            <a:round/>
+          </a:ln>
+        </c:spPr>
+        <c:txPr>
+          <a:bodyPr/>
+          <a:lstStyle/>
+          <a:p>
+            <a:pPr>
+              <a:defRPr sz="800" b="0" i="0" u="none" strike="noStrike">
+                <a:solidFill>
+                  <a:srgbClr val="000000"/>
+                </a:solidFill>
+                <a:latin typeface="Times New Roman"/>
+              </a:defRPr>
+            </a:pPr>
+            <a:endParaRPr lang="en-US"/>
+          </a:p>
+        </c:txPr>
+        <c:crossAx val="2094734552"/>
+        <c:crosses val="autoZero"/>
+        <c:auto val="1"/>
+        <c:lblAlgn val="ctr"/>
+        <c:noMultiLvlLbl val="1"/>
+      </c:catAx>
+      <c:valAx>
+        <c:axId val="2094734552"/>
+        <c:scaling>
+          <c:orientation val="minMax"/>
+        </c:scaling>
+        <c:delete val="1"/>
+        <c:axPos val="b"/>
+        <c:numFmt formatCode="General" sourceLinked="0"/>
+        <c:majorTickMark val="out"/>
+        <c:minorTickMark val="none"/>
+        <c:tickLblPos val="low"/>
+        <c:spPr>
+          <a:ln w="12700" cap="flat">
+            <a:solidFill>
+              <a:srgbClr val="888888"/>
+            </a:solidFill>
+            <a:prstDash val="solid"/>
+            <a:round/>
+          </a:ln>
+        </c:spPr>
+        <c:txPr>
+          <a:bodyPr/>
+          <a:lstStyle/>
+          <a:p>
+            <a:pPr>
+              <a:defRPr sz="800" b="0" i="0" u="none" strike="noStrike">
+                <a:solidFill>
+                  <a:srgbClr val="000000"/>
+                </a:solidFill>
+                <a:latin typeface="Times New Roman"/>
+              </a:defRPr>
+            </a:pPr>
+            <a:endParaRPr lang="en-US"/>
+          </a:p>
+        </c:txPr>
+        <c:crossAx val="2094734554"/>
+        <c:crosses val="autoZero"/>
+        <c:crossBetween val="between"/>
+      </c:valAx>
+      <c:spPr>
+        <a:noFill/>
+        <a:ln>
+          <a:noFill/>
+        </a:ln>
+        <a:effectLst/>
+      </c:spPr>
+    </c:plotArea>
+    <c:plotVisOnly val="1"/>
+    <c:dispBlanksAs val="span"/>
+  </c:chart>
+  <c:spPr>
+    <a:noFill/>
+    <a:ln>
+      <a:noFill/>
+    </a:ln>
+    <a:effectLst/>
+  </c:spPr>
+  <c:externalData r:id="rId1">
+    <c:autoUpdate val="0"/>
+  </c:externalData>
+</c:chartSpace>
+</file>
+
+<file path=ppt/charts/chart3.xml><?xml version="1.0" encoding="utf-8"?>
+<c:chartSpace xmlns:c="http://schemas.openxmlformats.org/drawingml/2006/chart" xmlns:a="http://schemas.openxmlformats.org/drawingml/2006/main" xmlns:r="http://schemas.openxmlformats.org/officeDocument/2006/relationships">
+  <c:date1904 val="0"/>
+  <c:roundedCorners val="1"/>
+  <c:chart>
+    <c:autoTitleDeleted val="1"/>
+    <c:plotArea>
+      <c:layout/>
+      <c:barChart>
+        <c:barDir val="col"/>
+        <c:grouping val="clustered"/>
+        <c:varyColors val="0"/>
+        <c:ser>
+          <c:idx val="0"/>
+          <c:order val="0"/>
+          <c:tx>
+            <c:strRef>
+              <c:f>Sheet1!$B$1</c:f>
+              <c:strCache>
+                <c:ptCount val="1"/>
+                <c:pt idx="0">
+                  <c:v>Hyperscaler Bond Issuance ($bn)</c:v>
+                </c:pt>
+              </c:strCache>
+            </c:strRef>
+          </c:tx>
+          <c:spPr>
+            <a:solidFill>
+              <a:srgbClr val="9A3839"/>
+            </a:solidFill>
+            <a:effectLst/>
+          </c:spPr>
+          <c:invertIfNegative val="0"/>
+          <c:dLbls>
+            <c:numFmt formatCode="0" sourceLinked="0"/>
+            <c:txPr>
+              <a:bodyPr/>
+              <a:lstStyle/>
+              <a:p>
+                <a:pPr>
+                  <a:defRPr b="0" i="0" strike="noStrike" sz="800" u="none">
+                    <a:solidFill>
+                      <a:srgbClr val="000000"/>
+                    </a:solidFill>
+                    <a:latin typeface="Times New Roman"/>
+                  </a:defRPr>
+                </a:pPr>
+              </a:p>
+            </c:txPr>
+            <c:showLegendKey val="0"/>
+            <c:showVal val="1"/>
+            <c:showCatName val="0"/>
+            <c:showSerName val="0"/>
+            <c:showPercent val="0"/>
+            <c:showBubbleSize val="0"/>
+            <c:showLeaderLines val="0"/>
+          </c:dLbls>
+          <c:dPt>
+            <c:idx val="0"/>
+            <c:invertIfNegative val="0"/>
+            <c:bubble3D val="0"/>
+            <c:spPr>
+              <a:solidFill>
+                <a:srgbClr val="9A3839"/>
+              </a:solidFill>
+              <a:effectLst/>
+            </c:spPr>
+          </c:dPt>
+          <c:dPt>
+            <c:idx val="1"/>
+            <c:invertIfNegative val="0"/>
+            <c:bubble3D val="0"/>
+            <c:spPr>
+              <a:solidFill>
+                <a:srgbClr val="4F1D1B"/>
+              </a:solidFill>
+              <a:effectLst/>
+            </c:spPr>
+          </c:dPt>
+          <c:dPt>
+            <c:idx val="2"/>
+            <c:invertIfNegative val="0"/>
+            <c:bubble3D val="0"/>
+            <c:spPr>
+              <a:solidFill>
+                <a:srgbClr val="CD6661"/>
+              </a:solidFill>
+              <a:effectLst/>
+            </c:spPr>
+          </c:dPt>
+          <c:dPt>
+            <c:idx val="3"/>
+            <c:invertIfNegative val="0"/>
+            <c:bubble3D val="0"/>
+            <c:spPr>
+              <a:solidFill>
+                <a:srgbClr val="E0BCBC"/>
+              </a:solidFill>
+              <a:effectLst/>
+            </c:spPr>
+          </c:dPt>
+          <c:cat>
+            <c:multiLvlStrRef>
+              <c:f>Sheet1!$A$2:$A$5</c:f>
+              <c:multiLvlStrCache>
+                <c:ptCount val="4"/>
+                <c:lvl>
+                  <c:pt idx="0">
+                    <c:v>2025</c:v>
+                  </c:pt>
+                  <c:pt idx="1">
+                    <c:v>2026 to Jul 7</c:v>
+                  </c:pt>
+                  <c:pt idx="2">
+                    <c:v>2026E</c:v>
+                  </c:pt>
+                  <c:pt idx="3">
+                    <c:v>2027E</c:v>
+                  </c:pt>
+                </c:lvl>
+              </c:multiLvlStrCache>
+            </c:multiLvlStrRef>
+          </c:cat>
+          <c:val>
+            <c:numRef>
+              <c:f>Sheet1!$B$2:$B$5</c:f>
+              <c:numCache>
+                <c:formatCode>General</c:formatCode>
+                <c:ptCount val="4"/>
+                <c:pt idx="0">
+                  <c:v>108</c:v>
+                </c:pt>
+                <c:pt idx="1">
+                  <c:v>194</c:v>
+                </c:pt>
+                <c:pt idx="2">
+                  <c:v>250</c:v>
+                </c:pt>
+                <c:pt idx="3">
+                  <c:v>400</c:v>
+                </c:pt>
+              </c:numCache>
+            </c:numRef>
+          </c:val>
+        </c:ser>
+        <c:dLbls>
+          <c:numFmt formatCode="0" sourceLinked="0"/>
+          <c:txPr>
+            <a:bodyPr/>
+            <a:lstStyle/>
+            <a:p>
+              <a:pPr>
+                <a:defRPr b="0" i="0" strike="noStrike" sz="800" u="none">
+                  <a:solidFill>
+                    <a:srgbClr val="000000"/>
+                  </a:solidFill>
+                  <a:latin typeface="Times New Roman"/>
+                </a:defRPr>
+              </a:pPr>
+            </a:p>
+          </c:txPr>
+          <c:showLegendKey val="0"/>
+          <c:showVal val="1"/>
+          <c:showCatName val="0"/>
+          <c:showSerName val="0"/>
+          <c:showPercent val="0"/>
+          <c:showBubbleSize val="0"/>
+          <c:showLeaderLines val="0"/>
+        </c:dLbls>
+        <c:gapWidth val="60"/>
+        <c:overlap val="0"/>
+        <c:axId val="2094734554"/>
+        <c:axId val="2094734552"/>
+        <c:axId val="2094734556"/>
+      </c:barChart>
+      <c:catAx>
+        <c:axId val="2094734554"/>
+        <c:scaling>
+          <c:orientation val="minMax"/>
+        </c:scaling>
+        <c:delete val="0"/>
+        <c:axPos val="b"/>
+        <c:numFmt formatCode="General" sourceLinked="1"/>
+        <c:majorTickMark val="out"/>
+        <c:minorTickMark val="none"/>
+        <c:tickLblPos val="low"/>
+        <c:spPr>
+          <a:ln w="12700" cap="flat">
+            <a:solidFill>
+              <a:srgbClr val="888888"/>
+            </a:solidFill>
+            <a:prstDash val="solid"/>
+            <a:round/>
+          </a:ln>
+        </c:spPr>
+        <c:txPr>
+          <a:bodyPr/>
+          <a:lstStyle/>
+          <a:p>
+            <a:pPr>
+              <a:defRPr sz="800" b="0" i="0" u="none" strike="noStrike">
+                <a:solidFill>
+                  <a:srgbClr val="000000"/>
+                </a:solidFill>
+                <a:latin typeface="Times New Roman"/>
+              </a:defRPr>
+            </a:pPr>
+            <a:endParaRPr lang="en-US"/>
+          </a:p>
+        </c:txPr>
+        <c:crossAx val="2094734552"/>
+        <c:crosses val="autoZero"/>
+        <c:auto val="1"/>
+        <c:lblAlgn val="ctr"/>
+        <c:noMultiLvlLbl val="1"/>
+      </c:catAx>
+      <c:valAx>
+        <c:axId val="2094734552"/>
+        <c:scaling>
+          <c:orientation val="minMax"/>
+        </c:scaling>
+        <c:delete val="1"/>
+        <c:axPos val="l"/>
+        <c:numFmt formatCode="General" sourceLinked="0"/>
+        <c:majorTickMark val="out"/>
+        <c:minorTickMark val="none"/>
+        <c:tickLblPos val="nextTo"/>
+        <c:spPr>
+          <a:ln w="12700" cap="flat">
+            <a:solidFill>
+              <a:srgbClr val="888888"/>
+            </a:solidFill>
+            <a:prstDash val="solid"/>
+            <a:round/>
+          </a:ln>
+        </c:spPr>
+        <c:txPr>
+          <a:bodyPr/>
+          <a:lstStyle/>
+          <a:p>
+            <a:pPr>
+              <a:defRPr sz="800" b="0" i="0" u="none" strike="noStrike">
+                <a:solidFill>
+                  <a:srgbClr val="000000"/>
+                </a:solidFill>
+                <a:latin typeface="Times New Roman"/>
+              </a:defRPr>
+            </a:pPr>
+            <a:endParaRPr lang="en-US"/>
+          </a:p>
+        </c:txPr>
+        <c:crossAx val="2094734554"/>
+        <c:crosses val="autoZero"/>
+        <c:crossBetween val="between"/>
+      </c:valAx>
+      <c:spPr>
+        <a:noFill/>
+        <a:ln>
+          <a:noFill/>
+        </a:ln>
+        <a:effectLst/>
+      </c:spPr>
+    </c:plotArea>
+    <c:plotVisOnly val="1"/>
+    <c:dispBlanksAs val="span"/>
+  </c:chart>
+  <c:spPr>
+    <a:noFill/>
+    <a:ln>
+      <a:noFill/>
+    </a:ln>
+    <a:effectLst/>
+  </c:spPr>
+  <c:externalData r:id="rId1">
+    <c:autoUpdate val="0"/>
+  </c:externalData>
+</c:chartSpace>
 </file>
 
 <file path=ppt/notesMasters/notesMaster1.xml><?xml version="1.0" encoding="utf-8"?>
@@ -960,7 +1763,7 @@
       </p:sp>
       <p:pic>
         <p:nvPicPr>
-          <p:cNvPr id="4" name="Image 0" descr="/home/claude/scaffold/case-study/assets/footer_bar.png">    </p:cNvPr>
+          <p:cNvPr id="4" name="Image 0" descr="/home/user/LLC-Research-Monthly-File/assets/footer_bar.png">    </p:cNvPr>
           <p:cNvPicPr>
             <a:picLocks noChangeAspect="1"/>
           </p:cNvPicPr>
@@ -1741,7 +2544,7 @@
                 <a:ea typeface="Times New Roman" pitchFamily="34" charset="-122"/>
                 <a:cs typeface="Times New Roman" pitchFamily="34" charset="-120"/>
               </a:rPr>
-              <a:t>AI infrastructure financing is the debt and structured capital used to build data centers and the compute inside them, and it has shifted from hyperscaler cash flow to the credit markets. The defining structure is the off balance sheet joint venture. A hyperscaler contributes a campus to a special purpose vehicle, a private capital partner takes majority equity, and the vehicle issues long dated bonds or loans secured by a lease back to the hyperscaler. The debt sits at the project level, which keeps leverage off the tenant's balance sheet in exchange for a higher borrowing cost. Meta's $27bn Hyperion campus in Louisiana set the template in October 2025, with Blue Owl holding 80%, Meta holding 20%, and A+ rated bonds priced at 6.58% versus roughly 5.5% on Meta's own corporate debt. It remains the largest private credit transaction ever. Oracle has taken the opposite route by borrowing directly on its own balance sheet.</a:t>
+              <a:t>AI infrastructure financing is the debt and structured capital used to build data centers and the compute inside them, and it has shifted from hyperscaler cash flow to the credit markets. The defining structure is the joint venture. A hyperscaler contributes a campus to a special purpose vehicle, the building block of last month's ABS case study. A private capital partner takes majority equity, and the vehicle issues long dated bonds secured by a lease back to the hyperscaler. The debt sits at the project level, which keeps leverage off the tenant's reported balance sheet in exchange for a higher borrowing cost. Meta's $27bn Hyperion campus in Louisiana set the template in October 2025, with Blue Owl holding 80%, Meta holding 20%, and A+ rated bonds priced at 6.58%, about 225bps over Treasuries, against roughly 5.5% on a comparable Meta corporate bond. Oracle has leaned more on its own balance sheet while also leasing campuses financed at the project level.</a:t>
             </a:r>
             <a:endParaRPr lang="en-US" sz="1050" dirty="0"/>
           </a:p>
@@ -1822,7 +2625,7 @@
                 <a:ea typeface="Times New Roman" pitchFamily="34" charset="-122"/>
                 <a:cs typeface="Times New Roman" pitchFamily="34" charset="-120"/>
               </a:rPr>
-              <a:t>The scale of the buildout is what ties this theme to credit. Goldman Sachs expects the largest hyperscalers to spend about $750bn on capital expenditure in 2026 against operating cash flow of roughly $778bn, with debt issuance covering about one third of that spending. Amazon, Alphabet, Meta and Oracle issued about $194bn of bonds through July 7, up 79% from all of 2025, and Goldman expects issuance across the five largest hyperscalers to reach roughly $250bn this year and $400bn in 2027. US investment grade supply set a record $145.2bn in August, the third straight monthly record, as hyperscalers rose from roughly 2% of dollar issuance in 2022 through 2024 to a projected 9% in 2026. Private capital is filling the rest of the gap, with Morgan Stanley estimating that tech companies and related parties could need up to $800bn of private credit through asset specific structures by 2028. The debt behind these structures is long dated, with bonds reaching 2048 and 2049 against GPUs that last three to five years.</a:t>
+              <a:t>The scale of the buildout is what ties this theme to credit. Goldman Sachs expects the five largest hyperscalers to spend about $750bn on capital expenditure in 2026 and to fund about one third of it with debt. Amazon, Alphabet, Meta and Oracle issued about $194bn of bonds through July 7, up 79% from all of 2025, and Goldman expects issuance across the five, adding Microsoft, to reach roughly $250bn this year and $400bn in 2027. That supply has landed in investment grade, while the August recap showed high yield issuance at a one year low of $12bn. Private capital is filling the rest of the gap, with Morgan Stanley estimating that private credit could supply more than $800bn of data center financing through 2028, led by asset based finance. Several of those lenders, Blue Owl among them, halted fund redemptions in March, as covered in that month's recap. The debt is long dated, with bonds maturing in 2048 and 2049, far beyond Hyperion's four year initial lease term.</a:t>
             </a:r>
             <a:endParaRPr lang="en-US" sz="1050" dirty="0"/>
           </a:p>
@@ -1836,7 +2639,7 @@
         </p:nvSpPr>
         <p:spPr>
           <a:xfrm>
-            <a:off x="557784" y="5193792"/>
+            <a:off x="557784" y="5056632"/>
             <a:ext cx="5742432" cy="347472"/>
           </a:xfrm>
           <a:prstGeom prst="rect">
@@ -1875,7 +2678,7 @@
         </p:nvSpPr>
         <p:spPr>
           <a:xfrm>
-            <a:off x="557784" y="5577840"/>
+            <a:off x="557784" y="5440680"/>
             <a:ext cx="5742432" cy="1097280"/>
           </a:xfrm>
           <a:prstGeom prst="rect">
@@ -1903,7 +2706,7 @@
                 <a:ea typeface="Times New Roman" pitchFamily="34" charset="-122"/>
                 <a:cs typeface="Times New Roman" pitchFamily="34" charset="-120"/>
               </a:rPr>
-              <a:t>For credit investors, the question is who holds the risk. In the joint venture structure, the hyperscaler's lease supports the bonds, but the project still carries power, permitting, and construction risk that the tenant's rating does not remove. Pricing has started to reflect this, with the El Paso bonds priced at a higher yield than Hyperion. At the same time, Oracle's move to BBB- shows that borrowing directly puts the hyperscaler itself on the credit watchlist. Both paths point to the same place, which is that AI infrastructure is becoming a distinct credit sector with its own spread behavior.</a:t>
+              <a:t>For credit investors, the question is who holds the risk. In the joint venture structure, the hyperscaler's lease supports the bonds, but the project still carries power, permitting, and construction risk that the tenant's rating does not remove. Pricing has started to reflect this, with the El Paso bonds priced at a wider spread than Hyperion. Oracle's cut to BBB- shows that heavy borrowing can put a hyperscaler itself under ratings pressure. The divergence is that capital remains abundant while the risk concentrates in single tenant projects and a short list of tenants.</a:t>
             </a:r>
             <a:endParaRPr lang="en-US" sz="1050" dirty="0"/>
           </a:p>
@@ -1942,49 +2745,38 @@
                 <a:ea typeface="Times New Roman" pitchFamily="34" charset="-122"/>
                 <a:cs typeface="Times New Roman" pitchFamily="34" charset="-120"/>
               </a:rPr>
-              <a:t>Capex Versus Operating Cash Flow ($bn)</a:t>
+              <a:t>2026 Capex Versus Debt Funding ($bn)</a:t>
             </a:r>
             <a:endParaRPr lang="en-US" sz="1100" dirty="0"/>
           </a:p>
         </p:txBody>
       </p:sp>
-      <p:sp>
-        <p:nvSpPr>
-          <p:cNvPr id="12" name="Chart placeholder C"/>
-          <p:cNvSpPr/>
-          <p:nvPr/>
-        </p:nvSpPr>
-        <p:spPr>
-          <a:xfrm>
-            <a:off x="557784" y="7104888"/>
-            <a:ext cx="2798064" cy="1993392"/>
-          </a:xfrm>
-          <a:prstGeom prst="rect">
-            <a:avLst/>
-          </a:prstGeom>
-          <a:solidFill>
-            <a:srgbClr val="FFFFFF">
-              <a:alpha val="65000"/>
-            </a:srgbClr>
-          </a:solidFill>
-          <a:ln w="12700">
-            <a:solidFill>
-              <a:srgbClr val="9B3739"/>
-            </a:solidFill>
-            <a:prstDash val="dash"/>
-          </a:ln>
-        </p:spPr>
-      </p:sp>
-      <p:sp>
-        <p:nvSpPr>
-          <p:cNvPr id="13" name="Chart placeholder text C"/>
+      <p:graphicFrame>
+        <p:nvGraphicFramePr>
+          <p:cNvPr id="12" name="Chart 0" descr=""/>
+          <p:cNvGraphicFramePr/>
+          <p:nvPr/>
+        </p:nvGraphicFramePr>
+        <p:xfrm>
+          <a:off x="557784" y="7104888"/>
+          <a:ext cx="2798064" cy="1719072"/>
+        </p:xfrm>
+        <a:graphic xmlns:a="http://schemas.openxmlformats.org/drawingml/2006/main">
+          <a:graphicData uri="http://schemas.openxmlformats.org/drawingml/2006/chart">
+            <c:chart xmlns:c="http://schemas.openxmlformats.org/drawingml/2006/chart" r:id="rId1"/>
+          </a:graphicData>
+        </a:graphic>
+      </p:graphicFrame>
+      <p:sp>
+        <p:nvSpPr>
+          <p:cNvPr id="13" name="Chart footnote C"/>
           <p:cNvSpPr txBox="1"/>
           <p:nvPr/>
         </p:nvSpPr>
         <p:spPr>
           <a:xfrm>
-            <a:off x="694944" y="7104888"/>
-            <a:ext cx="2523744" cy="1993392"/>
+            <a:off x="557784" y="8842248"/>
+            <a:ext cx="2798064" cy="237744"/>
           </a:xfrm>
           <a:prstGeom prst="rect">
             <a:avLst/>
@@ -1993,54 +2785,92 @@
           <a:ln/>
         </p:spPr>
         <p:txBody>
-          <a:bodyPr wrap="square" lIns="0" tIns="0" rIns="0" bIns="0" rtlCol="0" anchor="ctr"/>
-          <a:lstStyle/>
-          <a:p>
-            <a:pPr algn="ctr" indent="0" marL="0">
+          <a:bodyPr wrap="square" lIns="0" tIns="0" rIns="0" bIns="0" rtlCol="0" anchor="t"/>
+          <a:lstStyle/>
+          <a:p>
+            <a:pPr indent="0" marL="0">
               <a:buNone/>
             </a:pPr>
             <a:r>
-              <a:rPr lang="en-US" sz="1100" b="1" dirty="0">
-                <a:solidFill>
-                  <a:srgbClr val="9B3739"/>
+              <a:rPr lang="en-US" sz="700" i="1" dirty="0">
+                <a:solidFill>
+                  <a:srgbClr val="000000"/>
                 </a:solidFill>
                 <a:latin typeface="Times New Roman" pitchFamily="34" charset="0"/>
                 <a:ea typeface="Times New Roman" pitchFamily="34" charset="-122"/>
                 <a:cs typeface="Times New Roman" pitchFamily="34" charset="-120"/>
               </a:rPr>
-              <a:t>Insert chart</a:t>
-            </a:r>
-            <a:endParaRPr lang="en-US" sz="1100" dirty="0"/>
-          </a:p>
+              <a:t>Goldman Sachs estimates for five hyperscalers (Meta, Microsoft, Alphabet, Amazon, Oracle). Debt issuance is about one third of capex.</a:t>
+            </a:r>
+            <a:endParaRPr lang="en-US" sz="700" dirty="0"/>
+          </a:p>
+        </p:txBody>
+      </p:sp>
+      <p:sp>
+        <p:nvSpPr>
+          <p:cNvPr id="14" name="Chart title D"/>
+          <p:cNvSpPr txBox="1"/>
+          <p:nvPr/>
+        </p:nvSpPr>
+        <p:spPr>
+          <a:xfrm>
+            <a:off x="3502152" y="6812280"/>
+            <a:ext cx="2798064" cy="256032"/>
+          </a:xfrm>
+          <a:prstGeom prst="rect">
+            <a:avLst/>
+          </a:prstGeom>
+          <a:noFill/>
+          <a:ln/>
+        </p:spPr>
+        <p:txBody>
+          <a:bodyPr wrap="square" lIns="0" tIns="0" rIns="0" bIns="0" rtlCol="0" anchor="ctr"/>
+          <a:lstStyle/>
           <a:p>
             <a:pPr algn="ctr" indent="0" marL="0">
               <a:buNone/>
             </a:pPr>
             <a:r>
-              <a:rPr lang="en-US" sz="900" i="1" dirty="0">
-                <a:solidFill>
-                  <a:srgbClr val="9B3739"/>
+              <a:rPr lang="en-US" sz="1100" b="1" dirty="0">
+                <a:solidFill>
+                  <a:srgbClr val="000000"/>
                 </a:solidFill>
                 <a:latin typeface="Times New Roman" pitchFamily="34" charset="0"/>
                 <a:ea typeface="Times New Roman" pitchFamily="34" charset="-122"/>
                 <a:cs typeface="Times New Roman" pitchFamily="34" charset="-120"/>
               </a:rPr>
-              <a:t>2026 capex and operating cash flow</a:t>
+              <a:t>Lease Term Versus Debt Maturity (years)</a:t>
             </a:r>
             <a:endParaRPr lang="en-US" sz="1100" dirty="0"/>
           </a:p>
         </p:txBody>
       </p:sp>
-      <p:sp>
-        <p:nvSpPr>
-          <p:cNvPr id="14" name="Chart title D"/>
+      <p:graphicFrame>
+        <p:nvGraphicFramePr>
+          <p:cNvPr id="15" name="Chart 1" descr=""/>
+          <p:cNvGraphicFramePr/>
+          <p:nvPr/>
+        </p:nvGraphicFramePr>
+        <p:xfrm>
+          <a:off x="3502152" y="7104888"/>
+          <a:ext cx="2798064" cy="1719072"/>
+        </p:xfrm>
+        <a:graphic xmlns:a="http://schemas.openxmlformats.org/drawingml/2006/main">
+          <a:graphicData uri="http://schemas.openxmlformats.org/drawingml/2006/chart">
+            <c:chart xmlns:c="http://schemas.openxmlformats.org/drawingml/2006/chart" r:id="rId2"/>
+          </a:graphicData>
+        </a:graphic>
+      </p:graphicFrame>
+      <p:sp>
+        <p:nvSpPr>
+          <p:cNvPr id="16" name="Chart footnote D"/>
           <p:cNvSpPr txBox="1"/>
           <p:nvPr/>
         </p:nvSpPr>
         <p:spPr>
           <a:xfrm>
-            <a:off x="3502152" y="6812280"/>
-            <a:ext cx="2798064" cy="256032"/>
+            <a:off x="3502152" y="8842248"/>
+            <a:ext cx="2798064" cy="237744"/>
           </a:xfrm>
           <a:prstGeom prst="rect">
             <a:avLst/>
@@ -2049,14 +2879,14 @@
           <a:ln/>
         </p:spPr>
         <p:txBody>
-          <a:bodyPr wrap="square" lIns="0" tIns="0" rIns="0" bIns="0" rtlCol="0" anchor="ctr"/>
-          <a:lstStyle/>
-          <a:p>
-            <a:pPr algn="ctr" indent="0" marL="0">
+          <a:bodyPr wrap="square" lIns="0" tIns="0" rIns="0" bIns="0" rtlCol="0" anchor="t"/>
+          <a:lstStyle/>
+          <a:p>
+            <a:pPr indent="0" marL="0">
               <a:buNone/>
             </a:pPr>
             <a:r>
-              <a:rPr lang="en-US" sz="1100" b="1" dirty="0">
+              <a:rPr lang="en-US" sz="700" i="1" dirty="0">
                 <a:solidFill>
                   <a:srgbClr val="000000"/>
                 </a:solidFill>
@@ -2064,49 +2894,22 @@
                 <a:ea typeface="Times New Roman" pitchFamily="34" charset="-122"/>
                 <a:cs typeface="Times New Roman" pitchFamily="34" charset="-120"/>
               </a:rPr>
-              <a:t>Asset Life Versus Debt Maturity (years)</a:t>
-            </a:r>
-            <a:endParaRPr lang="en-US" sz="1100" dirty="0"/>
-          </a:p>
-        </p:txBody>
-      </p:sp>
-      <p:sp>
-        <p:nvSpPr>
-          <p:cNvPr id="15" name="Chart placeholder D"/>
-          <p:cNvSpPr/>
-          <p:nvPr/>
-        </p:nvSpPr>
-        <p:spPr>
-          <a:xfrm>
-            <a:off x="3502152" y="7104888"/>
-            <a:ext cx="2798064" cy="1993392"/>
-          </a:xfrm>
-          <a:prstGeom prst="rect">
-            <a:avLst/>
-          </a:prstGeom>
-          <a:solidFill>
-            <a:srgbClr val="FFFFFF">
-              <a:alpha val="65000"/>
-            </a:srgbClr>
-          </a:solidFill>
-          <a:ln w="12700">
-            <a:solidFill>
-              <a:srgbClr val="9B3739"/>
-            </a:solidFill>
-            <a:prstDash val="dash"/>
-          </a:ln>
-        </p:spPr>
-      </p:sp>
-      <p:sp>
-        <p:nvSpPr>
-          <p:cNvPr id="16" name="Chart placeholder text D"/>
+              <a:t>Bond maturities are approximate years from pricing.</a:t>
+            </a:r>
+            <a:endParaRPr lang="en-US" sz="700" dirty="0"/>
+          </a:p>
+        </p:txBody>
+      </p:sp>
+      <p:sp>
+        <p:nvSpPr>
+          <p:cNvPr id="17" name="Sources"/>
           <p:cNvSpPr txBox="1"/>
           <p:nvPr/>
         </p:nvSpPr>
         <p:spPr>
           <a:xfrm>
-            <a:off x="3639312" y="7104888"/>
-            <a:ext cx="2523744" cy="1993392"/>
+            <a:off x="457200" y="9381744"/>
+            <a:ext cx="5943600" cy="201168"/>
           </a:xfrm>
           <a:prstGeom prst="rect">
             <a:avLst/>
@@ -2115,78 +2918,22 @@
           <a:ln/>
         </p:spPr>
         <p:txBody>
-          <a:bodyPr wrap="square" lIns="0" tIns="0" rIns="0" bIns="0" rtlCol="0" anchor="ctr"/>
-          <a:lstStyle/>
-          <a:p>
-            <a:pPr algn="ctr" indent="0" marL="0">
+          <a:bodyPr wrap="square" lIns="0" tIns="0" rIns="0" bIns="0" rtlCol="0" anchor="t"/>
+          <a:lstStyle/>
+          <a:p>
+            <a:pPr indent="0" marL="0">
               <a:buNone/>
             </a:pPr>
             <a:r>
-              <a:rPr lang="en-US" sz="1100" b="1" dirty="0">
-                <a:solidFill>
-                  <a:srgbClr val="9B3739"/>
+              <a:rPr lang="en-US" sz="750" dirty="0">
+                <a:solidFill>
+                  <a:srgbClr val="000000"/>
                 </a:solidFill>
                 <a:latin typeface="Times New Roman" pitchFamily="34" charset="0"/>
                 <a:ea typeface="Times New Roman" pitchFamily="34" charset="-122"/>
                 <a:cs typeface="Times New Roman" pitchFamily="34" charset="-120"/>
               </a:rPr>
-              <a:t>Insert chart</a:t>
-            </a:r>
-            <a:endParaRPr lang="en-US" sz="1100" dirty="0"/>
-          </a:p>
-          <a:p>
-            <a:pPr algn="ctr" indent="0" marL="0">
-              <a:buNone/>
-            </a:pPr>
-            <a:r>
-              <a:rPr lang="en-US" sz="900" i="1" dirty="0">
-                <a:solidFill>
-                  <a:srgbClr val="9B3739"/>
-                </a:solidFill>
-                <a:latin typeface="Times New Roman" pitchFamily="34" charset="0"/>
-                <a:ea typeface="Times New Roman" pitchFamily="34" charset="-122"/>
-                <a:cs typeface="Times New Roman" pitchFamily="34" charset="-120"/>
-              </a:rPr>
-              <a:t>GPU life, lease terms, bond maturities</a:t>
-            </a:r>
-            <a:endParaRPr lang="en-US" sz="1100" dirty="0"/>
-          </a:p>
-        </p:txBody>
-      </p:sp>
-      <p:sp>
-        <p:nvSpPr>
-          <p:cNvPr id="17" name="Sources"/>
-          <p:cNvSpPr txBox="1"/>
-          <p:nvPr/>
-        </p:nvSpPr>
-        <p:spPr>
-          <a:xfrm>
-            <a:off x="457200" y="9381744"/>
-            <a:ext cx="5943600" cy="201168"/>
-          </a:xfrm>
-          <a:prstGeom prst="rect">
-            <a:avLst/>
-          </a:prstGeom>
-          <a:noFill/>
-          <a:ln/>
-        </p:spPr>
-        <p:txBody>
-          <a:bodyPr wrap="square" lIns="0" tIns="0" rIns="0" bIns="0" rtlCol="0" anchor="t"/>
-          <a:lstStyle/>
-          <a:p>
-            <a:pPr indent="0" marL="0">
-              <a:buNone/>
-            </a:pPr>
-            <a:r>
-              <a:rPr lang="en-US" sz="750" dirty="0">
-                <a:solidFill>
-                  <a:srgbClr val="000000"/>
-                </a:solidFill>
-                <a:latin typeface="Times New Roman" pitchFamily="34" charset="0"/>
-                <a:ea typeface="Times New Roman" pitchFamily="34" charset="-122"/>
-                <a:cs typeface="Times New Roman" pitchFamily="34" charset="-120"/>
-              </a:rPr>
-              <a:t>Sources: Reuters, LSEG, Goldman Sachs, Bloomberg, Morgan Stanley, S&amp;P Global Ratings, The Asset</a:t>
+              <a:t>Sources: Meta, Bloomberg, Reuters, LSEG, Goldman Sachs, Morgan Stanley, S&amp;P Global Ratings</a:t>
             </a:r>
             <a:endParaRPr lang="en-US" sz="750" dirty="0"/>
           </a:p>
@@ -2397,7 +3144,7 @@
                 <a:ea typeface="Times New Roman" pitchFamily="34" charset="-122"/>
                 <a:cs typeface="Times New Roman" pitchFamily="34" charset="-120"/>
               </a:rPr>
-              <a:t>Hyperscaler borrowing is now carrying a cost. Of 91 hyperscaler bonds issued in 2026 with comparable pricing data, 78 traded at higher yields on July 28 than at issuance, with a median increase of about 22bps. The median new issue concession widened to 12bps from 2.25bps in 2025, and Amazon's $25bn deal pushed its existing 30 year bond about 20bps wider. Pressure is greater in project level debt. Meta's El Paso bonds priced in July at a 7.534% yield, about 287.5bps over 10 year Treasuries, and drew roughly $17bn of orders for a $12.55bn deal. In September, a Blue Owl sponsored data center leased entirely to CoreWeave sold $1.1bn of five year notes at 9.25%, roughly 270bps above similarly rated debt.</a:t>
+              <a:t>Hyperscaler borrowing is getting more expensive. Of 91 hyperscaler bonds issued in 2026 with comparable pricing data, 78 traded at higher yields on July 28 than at issuance, with a median increase of about 22bps, a move that blends rates and spread. The cleaner credit signal is the median new issue concession, which widened to 12bps from 2.25bps in 2025, and Amazon's $25bn deal pushed its existing 30 year bond about 20bps wider. Meta's El Paso bonds priced in July at about 7.5%, roughly 287.5bps over Treasuries, and drew roughly $20bn of orders, about 1.6 times the deal. In September, a Blue Owl sponsored data center leased to CoreWeave reportedly sold $1.1bn of five year high yield notes at 9.25%, about 270bps above similarly rated debt.</a:t>
             </a:r>
             <a:endParaRPr lang="en-US" sz="1050" dirty="0"/>
           </a:p>
@@ -2564,43 +3311,32 @@
           </a:p>
         </p:txBody>
       </p:sp>
-      <p:sp>
-        <p:nvSpPr>
-          <p:cNvPr id="11" name="Chart placeholder B"/>
-          <p:cNvSpPr/>
-          <p:nvPr/>
-        </p:nvSpPr>
-        <p:spPr>
-          <a:xfrm>
-            <a:off x="3502152" y="2962656"/>
-            <a:ext cx="2798064" cy="1947672"/>
-          </a:xfrm>
-          <a:prstGeom prst="rect">
-            <a:avLst/>
-          </a:prstGeom>
-          <a:solidFill>
-            <a:srgbClr val="FFFFFF">
-              <a:alpha val="65000"/>
-            </a:srgbClr>
-          </a:solidFill>
-          <a:ln w="12700">
-            <a:solidFill>
-              <a:srgbClr val="9B3739"/>
-            </a:solidFill>
-            <a:prstDash val="dash"/>
-          </a:ln>
-        </p:spPr>
-      </p:sp>
-      <p:sp>
-        <p:nvSpPr>
-          <p:cNvPr id="12" name="Chart placeholder text B"/>
+      <p:graphicFrame>
+        <p:nvGraphicFramePr>
+          <p:cNvPr id="11" name="Chart 0" descr=""/>
+          <p:cNvGraphicFramePr/>
+          <p:nvPr/>
+        </p:nvGraphicFramePr>
+        <p:xfrm>
+          <a:off x="3502152" y="2962656"/>
+          <a:ext cx="2798064" cy="1673352"/>
+        </p:xfrm>
+        <a:graphic xmlns:a="http://schemas.openxmlformats.org/drawingml/2006/main">
+          <a:graphicData uri="http://schemas.openxmlformats.org/drawingml/2006/chart">
+            <c:chart xmlns:c="http://schemas.openxmlformats.org/drawingml/2006/chart" r:id="rId1"/>
+          </a:graphicData>
+        </a:graphic>
+      </p:graphicFrame>
+      <p:sp>
+        <p:nvSpPr>
+          <p:cNvPr id="12" name="Chart footnote B"/>
           <p:cNvSpPr txBox="1"/>
           <p:nvPr/>
         </p:nvSpPr>
         <p:spPr>
           <a:xfrm>
-            <a:off x="3639312" y="2962656"/>
-            <a:ext cx="2523744" cy="1947672"/>
+            <a:off x="3502152" y="4654296"/>
+            <a:ext cx="2798064" cy="237744"/>
           </a:xfrm>
           <a:prstGeom prst="rect">
             <a:avLst/>
@@ -2609,41 +3345,24 @@
           <a:ln/>
         </p:spPr>
         <p:txBody>
-          <a:bodyPr wrap="square" lIns="0" tIns="0" rIns="0" bIns="0" rtlCol="0" anchor="ctr"/>
-          <a:lstStyle/>
-          <a:p>
-            <a:pPr algn="ctr" indent="0" marL="0">
+          <a:bodyPr wrap="square" lIns="0" tIns="0" rIns="0" bIns="0" rtlCol="0" anchor="t"/>
+          <a:lstStyle/>
+          <a:p>
+            <a:pPr indent="0" marL="0">
               <a:buNone/>
             </a:pPr>
             <a:r>
-              <a:rPr lang="en-US" sz="1100" b="1" dirty="0">
-                <a:solidFill>
-                  <a:srgbClr val="9B3739"/>
+              <a:rPr lang="en-US" sz="700" i="1" dirty="0">
+                <a:solidFill>
+                  <a:srgbClr val="000000"/>
                 </a:solidFill>
                 <a:latin typeface="Times New Roman" pitchFamily="34" charset="0"/>
                 <a:ea typeface="Times New Roman" pitchFamily="34" charset="-122"/>
                 <a:cs typeface="Times New Roman" pitchFamily="34" charset="-120"/>
               </a:rPr>
-              <a:t>Insert chart</a:t>
-            </a:r>
-            <a:endParaRPr lang="en-US" sz="1100" dirty="0"/>
-          </a:p>
-          <a:p>
-            <a:pPr algn="ctr" indent="0" marL="0">
-              <a:buNone/>
-            </a:pPr>
-            <a:r>
-              <a:rPr lang="en-US" sz="900" i="1" dirty="0">
-                <a:solidFill>
-                  <a:srgbClr val="9B3739"/>
-                </a:solidFill>
-                <a:latin typeface="Times New Roman" pitchFamily="34" charset="0"/>
-                <a:ea typeface="Times New Roman" pitchFamily="34" charset="-122"/>
-                <a:cs typeface="Times New Roman" pitchFamily="34" charset="-120"/>
-              </a:rPr>
-              <a:t>2025 actual, 2026 YTD, 2026E, 2027E</a:t>
-            </a:r>
-            <a:endParaRPr lang="en-US" sz="1100" dirty="0"/>
+              <a:t>2025 and 2026 to Jul 7 cover four issuers (Amazon, Alphabet, Meta, Oracle). 2026E and 2027E are Goldman Sachs estimates for five hyperscalers, adding Microsoft.</a:t>
+            </a:r>
+            <a:endParaRPr lang="en-US" sz="700" dirty="0"/>
           </a:p>
         </p:txBody>
       </p:sp>
@@ -2655,7 +3374,7 @@
         </p:nvSpPr>
         <p:spPr>
           <a:xfrm>
-            <a:off x="557784" y="5001768"/>
+            <a:off x="557784" y="5074920"/>
             <a:ext cx="5742432" cy="347472"/>
           </a:xfrm>
           <a:prstGeom prst="rect">
@@ -2694,7 +3413,7 @@
         </p:nvSpPr>
         <p:spPr>
           <a:xfrm>
-            <a:off x="557784" y="5385816"/>
+            <a:off x="557784" y="5458968"/>
             <a:ext cx="5742432" cy="1097280"/>
           </a:xfrm>
           <a:prstGeom prst="rect">
@@ -2722,7 +3441,7 @@
                 <a:ea typeface="Times New Roman" pitchFamily="34" charset="-122"/>
                 <a:cs typeface="Times New Roman" pitchFamily="34" charset="-120"/>
               </a:rPr>
-              <a:t>The structural risks are familiar to credit investors. Long dated bonds rest on leases to a single tenant, while the equipment inside the buildings turns over every three to five years, and Hyperion's lease has a four year initial term backed by a residual value guarantee from Meta. Before a campus operates, execution risk sits with lenders, as power, permitting, and local opposition can delay rent. Disclosure is limited, since the BIS notes much of this borrowing sits in private placement vehicles, and Moody's has flagged that short lease terms and residual value guarantees can understate effective obligations. The key divergence is between abundant capital and its rising price.</a:t>
+              <a:t>Long dated bonds rest on leases to a single tenant, and Hyperion's leases carry a four year initial term, so repayment after year four depends on Meta renewing or on its residual value guarantee, which covers the first 16 years. The chips inside, which Moody's says can become obsolete within four to six years, turn over far faster. Before a campus operates, power, permitting, and local opposition can delay rent. The BIS notes this borrowing increasingly sits in vehicles funded through private placements, and Moody's has flagged that short leases can understate effective obligations. The key divergence is between abundant capital and its rising price.</a:t>
             </a:r>
             <a:endParaRPr lang="en-US" sz="1050" dirty="0"/>
           </a:p>
@@ -2736,7 +3455,7 @@
         </p:nvSpPr>
         <p:spPr>
           <a:xfrm>
-            <a:off x="557784" y="6583680"/>
+            <a:off x="557784" y="6656832"/>
             <a:ext cx="2743200" cy="347472"/>
           </a:xfrm>
           <a:prstGeom prst="rect">
@@ -2775,7 +3494,7 @@
         </p:nvSpPr>
         <p:spPr>
           <a:xfrm>
-            <a:off x="3557016" y="6583680"/>
+            <a:off x="3557016" y="6656832"/>
             <a:ext cx="2743200" cy="347472"/>
           </a:xfrm>
           <a:prstGeom prst="rect">
@@ -2814,8 +3533,8 @@
         </p:nvSpPr>
         <p:spPr>
           <a:xfrm>
-            <a:off x="557784" y="6995160"/>
-            <a:ext cx="2743200" cy="2286000"/>
+            <a:off x="557784" y="7068312"/>
+            <a:ext cx="2743200" cy="2212848"/>
           </a:xfrm>
           <a:prstGeom prst="rect">
             <a:avLst/>
@@ -2842,7 +3561,7 @@
                 <a:ea typeface="Times New Roman" pitchFamily="34" charset="-122"/>
                 <a:cs typeface="Times New Roman" pitchFamily="34" charset="-120"/>
               </a:rPr>
-              <a:t>Meta has funded two campuses through joint ventures with private capital. Hyperion in Louisiana raised $27bn in October 2025 with A+ rated bonds priced at 6.58%. El Paso, a one gigawatt campus due online in 2028, followed in July with $12.55bn of A+ rated bonds due 2048 priced at 7.534%. Both place the debt at the project level behind a long lease to Meta. The higher cost on the same rating and the same tenant shows investors now charge for structure, supply, and duration.</a:t>
+              <a:t>Meta has funded two campuses through joint ventures with private capital. Hyperion in Louisiana raised $27bn in October 2025 with A+ rated bonds due 2049 priced at 6.58%, about 225bps over Treasuries. El Paso, a one gigawatt campus due online in 2028, followed in July with about $12.5bn of amortizing bonds due 2048, also rated A+ by S&amp;P, at about 7.5%. Both rest on leases to Meta. Higher Treasury yields explain part of the gap, but a spread roughly 60bps wider on the same S&amp;P rating and tenant suggests investors now charge more for structure, supply, and duration.</a:t>
             </a:r>
             <a:endParaRPr lang="en-US" sz="1050" dirty="0"/>
           </a:p>
@@ -2856,8 +3575,8 @@
         </p:nvSpPr>
         <p:spPr>
           <a:xfrm>
-            <a:off x="3557016" y="6995160"/>
-            <a:ext cx="2743200" cy="2286000"/>
+            <a:off x="3557016" y="7068312"/>
+            <a:ext cx="2743200" cy="2212848"/>
           </a:xfrm>
           <a:prstGeom prst="rect">
             <a:avLst/>
@@ -2884,7 +3603,7 @@
                 <a:ea typeface="Times New Roman" pitchFamily="34" charset="-122"/>
                 <a:cs typeface="Times New Roman" pitchFamily="34" charset="-120"/>
               </a:rPr>
-              <a:t>S&amp;P cut Oracle to BBB- on July 9, citing cash burn from its AI buildout, and said another downgrade is possible if leverage stays above 4.5x. Oracle raised roughly $43bn of debt in fiscal 2026. In September, about $18bn of bank loans tied to its Project Jupiter campus in New Mexico were quoted at 89 to 91 cents on the dollar, and Oracle sent a force majeure notice to the developer, a Blue Owl unit, citing power delays. A source told Reuters Oracle cannot terminate the lease and remains responsible for debt costs, and Oracle says the project is on schedule.</a:t>
+              <a:t>S&amp;P cut Oracle to BBB- on July 9, citing a widening cash flow deficit from its AI buildout, and said another downgrade is possible if leverage stays above 4.5x. In September, about $18bn of bank loans tied to its Project Jupiter campus in New Mexico were quoted at 89 to 91 cents, and Oracle sent a force majeure notice to the developer, a Blue Owl unit, citing power delays. Reuters reported that Oracle is not seeking to terminate the lease, could defer rent for up to three years, and would still owe rent for the full term. Oracle says the project is on schedule.</a:t>
             </a:r>
             <a:endParaRPr lang="en-US" sz="1050" dirty="0"/>
           </a:p>
@@ -2923,7 +3642,7 @@
                 <a:ea typeface="Times New Roman" pitchFamily="34" charset="-122"/>
                 <a:cs typeface="Times New Roman" pitchFamily="34" charset="-120"/>
               </a:rPr>
-              <a:t>Sources: Bloomberg, Reuters, LSEG, S&amp;P Global Ratings, Financial Times, BIS, Moody's, Capacity</a:t>
+              <a:t>Sources: Bloomberg, Reuters, LSEG, Meta, S&amp;P Global Ratings, Financial Times, BIS, Moody's</a:t>
             </a:r>
             <a:endParaRPr lang="en-US" sz="750" dirty="0"/>
           </a:p>

</xml_diff>

<commit_message>
Committee final: 2 rounds complete, fact check rerun fixes, chart D held, layout pass
Round count: 2 (round 1 review and merge, round 2 style, charts, build,
layout; fact checker rerun followed by a second round 2 pass).

Co-Authored-By: Claude Opus 5.5 <noreply@anthropic.com>
Claude-Session: https://claude.ai/code/session_011SJZihQQoizcK7ApWgRNEa
</commit_message>
<xml_diff>
--- a/outputs/LLC_AI_Infrastructure_Case_Study.pptx
+++ b/outputs/LLC_AI_Infrastructure_Case_Study.pptx
@@ -355,285 +355,6 @@
 </file>
 
 <file path=ppt/charts/chart2.xml><?xml version="1.0" encoding="utf-8"?>
-<c:chartSpace xmlns:c="http://schemas.openxmlformats.org/drawingml/2006/chart" xmlns:a="http://schemas.openxmlformats.org/drawingml/2006/main" xmlns:r="http://schemas.openxmlformats.org/officeDocument/2006/relationships">
-  <c:date1904 val="0"/>
-  <c:roundedCorners val="1"/>
-  <c:chart>
-    <c:autoTitleDeleted val="1"/>
-    <c:plotArea>
-      <c:layout/>
-      <c:barChart>
-        <c:barDir val="bar"/>
-        <c:grouping val="clustered"/>
-        <c:varyColors val="0"/>
-        <c:ser>
-          <c:idx val="0"/>
-          <c:order val="0"/>
-          <c:tx>
-            <c:strRef>
-              <c:f>Sheet1!$B$1</c:f>
-              <c:strCache>
-                <c:ptCount val="1"/>
-                <c:pt idx="0">
-                  <c:v>Asset Life Versus Debt Maturity (years)</c:v>
-                </c:pt>
-              </c:strCache>
-            </c:strRef>
-          </c:tx>
-          <c:spPr>
-            <a:solidFill>
-              <a:srgbClr val="9A3839"/>
-            </a:solidFill>
-            <a:effectLst/>
-          </c:spPr>
-          <c:invertIfNegative val="0"/>
-          <c:dLbls>
-            <c:numFmt formatCode="0" sourceLinked="0"/>
-            <c:txPr>
-              <a:bodyPr/>
-              <a:lstStyle/>
-              <a:p>
-                <a:pPr>
-                  <a:defRPr b="0" i="0" strike="noStrike" sz="800" u="none">
-                    <a:solidFill>
-                      <a:srgbClr val="000000"/>
-                    </a:solidFill>
-                    <a:latin typeface="Times New Roman"/>
-                  </a:defRPr>
-                </a:pPr>
-              </a:p>
-            </c:txPr>
-            <c:showLegendKey val="0"/>
-            <c:showVal val="1"/>
-            <c:showCatName val="0"/>
-            <c:showSerName val="0"/>
-            <c:showPercent val="0"/>
-            <c:showBubbleSize val="0"/>
-            <c:showLeaderLines val="0"/>
-          </c:dLbls>
-          <c:dPt>
-            <c:idx val="0"/>
-            <c:invertIfNegative val="0"/>
-            <c:bubble3D val="0"/>
-            <c:spPr>
-              <a:solidFill>
-                <a:srgbClr val="9A3839"/>
-              </a:solidFill>
-              <a:effectLst/>
-            </c:spPr>
-          </c:dPt>
-          <c:dPt>
-            <c:idx val="1"/>
-            <c:invertIfNegative val="0"/>
-            <c:bubble3D val="0"/>
-            <c:spPr>
-              <a:solidFill>
-                <a:srgbClr val="4F1D1B"/>
-              </a:solidFill>
-              <a:effectLst/>
-            </c:spPr>
-          </c:dPt>
-          <c:dPt>
-            <c:idx val="2"/>
-            <c:invertIfNegative val="0"/>
-            <c:bubble3D val="0"/>
-            <c:spPr>
-              <a:solidFill>
-                <a:srgbClr val="CD6661"/>
-              </a:solidFill>
-              <a:effectLst/>
-            </c:spPr>
-          </c:dPt>
-          <c:dPt>
-            <c:idx val="3"/>
-            <c:invertIfNegative val="0"/>
-            <c:bubble3D val="0"/>
-            <c:spPr>
-              <a:solidFill>
-                <a:srgbClr val="E0BCBC"/>
-              </a:solidFill>
-              <a:effectLst/>
-            </c:spPr>
-          </c:dPt>
-          <c:cat>
-            <c:multiLvlStrRef>
-              <c:f>Sheet1!$A$2:$A$5</c:f>
-              <c:multiLvlStrCache>
-                <c:ptCount val="4"/>
-                <c:lvl>
-                  <c:pt idx="0">
-                    <c:v>Hyperion initial lease</c:v>
-                  </c:pt>
-                  <c:pt idx="1">
-                    <c:v>El Paso lease</c:v>
-                  </c:pt>
-                  <c:pt idx="2">
-                    <c:v>El Paso bond maturity</c:v>
-                  </c:pt>
-                  <c:pt idx="3">
-                    <c:v>Hyperion bond maturity</c:v>
-                  </c:pt>
-                </c:lvl>
-              </c:multiLvlStrCache>
-            </c:multiLvlStrRef>
-          </c:cat>
-          <c:val>
-            <c:numRef>
-              <c:f>Sheet1!$B$2:$B$5</c:f>
-              <c:numCache>
-                <c:formatCode>General</c:formatCode>
-                <c:ptCount val="4"/>
-                <c:pt idx="0">
-                  <c:v>4</c:v>
-                </c:pt>
-                <c:pt idx="1">
-                  <c:v>20</c:v>
-                </c:pt>
-                <c:pt idx="2">
-                  <c:v>22</c:v>
-                </c:pt>
-                <c:pt idx="3">
-                  <c:v>24</c:v>
-                </c:pt>
-              </c:numCache>
-            </c:numRef>
-          </c:val>
-        </c:ser>
-        <c:dLbls>
-          <c:numFmt formatCode="0" sourceLinked="0"/>
-          <c:txPr>
-            <a:bodyPr/>
-            <a:lstStyle/>
-            <a:p>
-              <a:pPr>
-                <a:defRPr b="0" i="0" strike="noStrike" sz="800" u="none">
-                  <a:solidFill>
-                    <a:srgbClr val="000000"/>
-                  </a:solidFill>
-                  <a:latin typeface="Times New Roman"/>
-                </a:defRPr>
-              </a:pPr>
-            </a:p>
-          </c:txPr>
-          <c:showLegendKey val="0"/>
-          <c:showVal val="1"/>
-          <c:showCatName val="0"/>
-          <c:showSerName val="0"/>
-          <c:showPercent val="0"/>
-          <c:showBubbleSize val="0"/>
-          <c:showLeaderLines val="0"/>
-        </c:dLbls>
-        <c:gapWidth val="60"/>
-        <c:overlap val="0"/>
-        <c:axId val="2094734554"/>
-        <c:axId val="2094734552"/>
-        <c:axId val="2094734556"/>
-      </c:barChart>
-      <c:catAx>
-        <c:axId val="2094734554"/>
-        <c:scaling>
-          <c:orientation val="maxMin"/>
-        </c:scaling>
-        <c:delete val="0"/>
-        <c:axPos val="l"/>
-        <c:numFmt formatCode="General" sourceLinked="1"/>
-        <c:majorTickMark val="out"/>
-        <c:minorTickMark val="none"/>
-        <c:tickLblPos val="nextTo"/>
-        <c:spPr>
-          <a:ln w="12700" cap="flat">
-            <a:solidFill>
-              <a:srgbClr val="888888"/>
-            </a:solidFill>
-            <a:prstDash val="solid"/>
-            <a:round/>
-          </a:ln>
-        </c:spPr>
-        <c:txPr>
-          <a:bodyPr/>
-          <a:lstStyle/>
-          <a:p>
-            <a:pPr>
-              <a:defRPr sz="800" b="0" i="0" u="none" strike="noStrike">
-                <a:solidFill>
-                  <a:srgbClr val="000000"/>
-                </a:solidFill>
-                <a:latin typeface="Times New Roman"/>
-              </a:defRPr>
-            </a:pPr>
-            <a:endParaRPr lang="en-US"/>
-          </a:p>
-        </c:txPr>
-        <c:crossAx val="2094734552"/>
-        <c:crosses val="autoZero"/>
-        <c:auto val="1"/>
-        <c:lblAlgn val="ctr"/>
-        <c:noMultiLvlLbl val="1"/>
-      </c:catAx>
-      <c:valAx>
-        <c:axId val="2094734552"/>
-        <c:scaling>
-          <c:orientation val="minMax"/>
-        </c:scaling>
-        <c:delete val="1"/>
-        <c:axPos val="b"/>
-        <c:numFmt formatCode="General" sourceLinked="0"/>
-        <c:majorTickMark val="out"/>
-        <c:minorTickMark val="none"/>
-        <c:tickLblPos val="low"/>
-        <c:spPr>
-          <a:ln w="12700" cap="flat">
-            <a:solidFill>
-              <a:srgbClr val="888888"/>
-            </a:solidFill>
-            <a:prstDash val="solid"/>
-            <a:round/>
-          </a:ln>
-        </c:spPr>
-        <c:txPr>
-          <a:bodyPr/>
-          <a:lstStyle/>
-          <a:p>
-            <a:pPr>
-              <a:defRPr sz="800" b="0" i="0" u="none" strike="noStrike">
-                <a:solidFill>
-                  <a:srgbClr val="000000"/>
-                </a:solidFill>
-                <a:latin typeface="Times New Roman"/>
-              </a:defRPr>
-            </a:pPr>
-            <a:endParaRPr lang="en-US"/>
-          </a:p>
-        </c:txPr>
-        <c:crossAx val="2094734554"/>
-        <c:crosses val="autoZero"/>
-        <c:crossBetween val="between"/>
-      </c:valAx>
-      <c:spPr>
-        <a:noFill/>
-        <a:ln>
-          <a:noFill/>
-        </a:ln>
-        <a:effectLst/>
-      </c:spPr>
-    </c:plotArea>
-    <c:plotVisOnly val="1"/>
-    <c:dispBlanksAs val="span"/>
-  </c:chart>
-  <c:spPr>
-    <a:noFill/>
-    <a:ln>
-      <a:noFill/>
-    </a:ln>
-    <a:effectLst/>
-  </c:spPr>
-  <c:externalData r:id="rId1">
-    <c:autoUpdate val="0"/>
-  </c:externalData>
-</c:chartSpace>
-</file>
-
-<file path=ppt/charts/chart3.xml><?xml version="1.0" encoding="utf-8"?>
 <c:chartSpace xmlns:c="http://schemas.openxmlformats.org/drawingml/2006/chart" xmlns:a="http://schemas.openxmlformats.org/drawingml/2006/main" xmlns:r="http://schemas.openxmlformats.org/officeDocument/2006/relationships">
   <c:date1904 val="0"/>
   <c:roundedCorners val="1"/>
@@ -2625,7 +2346,7 @@
                 <a:ea typeface="Times New Roman" pitchFamily="34" charset="-122"/>
                 <a:cs typeface="Times New Roman" pitchFamily="34" charset="-120"/>
               </a:rPr>
-              <a:t>The scale of the buildout is what ties this theme to credit. Goldman Sachs expects the five largest hyperscalers to spend about $750bn on capital expenditure in 2026 and to fund about one third of it with debt. Amazon, Alphabet, Meta and Oracle issued about $194bn of bonds through July 7, up 79% from all of 2025, and Goldman expects issuance across the five, adding Microsoft, to reach roughly $250bn this year and $400bn in 2027. That supply has landed in investment grade, while the August recap showed high yield issuance at a one year low of $12bn. Private capital is filling the rest of the gap, with Morgan Stanley estimating that private credit could supply more than $800bn of data center financing through 2028, led by asset based finance. Several of those lenders, Blue Owl among them, halted fund redemptions in March, as covered in that month's recap. The debt is long dated, with bonds maturing in 2048 and 2049, far beyond Hyperion's four year initial lease term.</a:t>
+              <a:t>The scale of the buildout is what ties this theme to credit. Goldman Sachs expects the five largest hyperscalers to spend about $750bn on capital expenditure in 2026 and to fund about one third of it with debt. Amazon, Alphabet, Meta and Oracle issued about $194bn of bonds through July 7, up 79% from all of 2025, and Goldman expects issuance across the five, adding Microsoft, to reach roughly $250bn this year and $400bn in 2027. Goldman's 2027 figure equals about 35% of that year's expected capex. Private capital is filling the rest of the gap, with Morgan Stanley estimating that private credit could supply more than $800bn of global data center financing through 2028, led by asset based finance. Several of those lenders halted or capped fund redemptions early this year, Blue Owl among them, as covered in the March recap. The debt is long dated, with bonds maturing in 2048 and 2049, far beyond the four year initial lease terms at both Hyperion and El Paso.</a:t>
             </a:r>
             <a:endParaRPr lang="en-US" sz="1050" dirty="0"/>
           </a:p>
@@ -2720,7 +2441,7 @@
         </p:nvSpPr>
         <p:spPr>
           <a:xfrm>
-            <a:off x="557784" y="6812280"/>
+            <a:off x="557784" y="6629400"/>
             <a:ext cx="2798064" cy="256032"/>
           </a:xfrm>
           <a:prstGeom prst="rect">
@@ -2758,7 +2479,7 @@
           <p:nvPr/>
         </p:nvGraphicFramePr>
         <p:xfrm>
-          <a:off x="557784" y="7104888"/>
+          <a:off x="557784" y="6922008"/>
           <a:ext cx="2798064" cy="1719072"/>
         </p:xfrm>
         <a:graphic xmlns:a="http://schemas.openxmlformats.org/drawingml/2006/main">
@@ -2775,7 +2496,7 @@
         </p:nvSpPr>
         <p:spPr>
           <a:xfrm>
-            <a:off x="557784" y="8842248"/>
+            <a:off x="557784" y="8659368"/>
             <a:ext cx="2798064" cy="237744"/>
           </a:xfrm>
           <a:prstGeom prst="rect">
@@ -2814,7 +2535,7 @@
         </p:nvSpPr>
         <p:spPr>
           <a:xfrm>
-            <a:off x="3502152" y="6812280"/>
+            <a:off x="3502152" y="6629400"/>
             <a:ext cx="2798064" cy="256032"/>
           </a:xfrm>
           <a:prstGeom prst="rect">
@@ -2845,32 +2566,43 @@
           </a:p>
         </p:txBody>
       </p:sp>
-      <p:graphicFrame>
-        <p:nvGraphicFramePr>
-          <p:cNvPr id="15" name="Chart 1" descr=""/>
-          <p:cNvGraphicFramePr/>
-          <p:nvPr/>
-        </p:nvGraphicFramePr>
-        <p:xfrm>
-          <a:off x="3502152" y="7104888"/>
-          <a:ext cx="2798064" cy="1719072"/>
-        </p:xfrm>
-        <a:graphic xmlns:a="http://schemas.openxmlformats.org/drawingml/2006/main">
-          <a:graphicData uri="http://schemas.openxmlformats.org/drawingml/2006/chart">
-            <c:chart xmlns:c="http://schemas.openxmlformats.org/drawingml/2006/chart" r:id="rId2"/>
-          </a:graphicData>
-        </a:graphic>
-      </p:graphicFrame>
-      <p:sp>
-        <p:nvSpPr>
-          <p:cNvPr id="16" name="Chart footnote D"/>
+      <p:sp>
+        <p:nvSpPr>
+          <p:cNvPr id="15" name="Chart placeholder D"/>
+          <p:cNvSpPr/>
+          <p:nvPr/>
+        </p:nvSpPr>
+        <p:spPr>
+          <a:xfrm>
+            <a:off x="3502152" y="6922008"/>
+            <a:ext cx="2798064" cy="1993392"/>
+          </a:xfrm>
+          <a:prstGeom prst="rect">
+            <a:avLst/>
+          </a:prstGeom>
+          <a:solidFill>
+            <a:srgbClr val="FFFFFF">
+              <a:alpha val="65000"/>
+            </a:srgbClr>
+          </a:solidFill>
+          <a:ln w="12700">
+            <a:solidFill>
+              <a:srgbClr val="9B3739"/>
+            </a:solidFill>
+            <a:prstDash val="dash"/>
+          </a:ln>
+        </p:spPr>
+      </p:sp>
+      <p:sp>
+        <p:nvSpPr>
+          <p:cNvPr id="16" name="Chart placeholder text D"/>
           <p:cNvSpPr txBox="1"/>
           <p:nvPr/>
         </p:nvSpPr>
         <p:spPr>
           <a:xfrm>
-            <a:off x="3502152" y="8842248"/>
-            <a:ext cx="2798064" cy="237744"/>
+            <a:off x="3639312" y="6922008"/>
+            <a:ext cx="2523744" cy="1993392"/>
           </a:xfrm>
           <a:prstGeom prst="rect">
             <a:avLst/>
@@ -2879,24 +2611,41 @@
           <a:ln/>
         </p:spPr>
         <p:txBody>
-          <a:bodyPr wrap="square" lIns="0" tIns="0" rIns="0" bIns="0" rtlCol="0" anchor="t"/>
-          <a:lstStyle/>
-          <a:p>
-            <a:pPr indent="0" marL="0">
+          <a:bodyPr wrap="square" lIns="0" tIns="0" rIns="0" bIns="0" rtlCol="0" anchor="ctr"/>
+          <a:lstStyle/>
+          <a:p>
+            <a:pPr algn="ctr" indent="0" marL="0">
               <a:buNone/>
             </a:pPr>
             <a:r>
-              <a:rPr lang="en-US" sz="700" i="1" dirty="0">
-                <a:solidFill>
-                  <a:srgbClr val="000000"/>
+              <a:rPr lang="en-US" sz="1100" b="1" dirty="0">
+                <a:solidFill>
+                  <a:srgbClr val="9B3739"/>
                 </a:solidFill>
                 <a:latin typeface="Times New Roman" pitchFamily="34" charset="0"/>
                 <a:ea typeface="Times New Roman" pitchFamily="34" charset="-122"/>
                 <a:cs typeface="Times New Roman" pitchFamily="34" charset="-120"/>
               </a:rPr>
-              <a:t>Bond maturities are approximate years from pricing.</a:t>
-            </a:r>
-            <a:endParaRPr lang="en-US" sz="700" dirty="0"/>
+              <a:t>Insert chart</a:t>
+            </a:r>
+            <a:endParaRPr lang="en-US" sz="1100" dirty="0"/>
+          </a:p>
+          <a:p>
+            <a:pPr algn="ctr" indent="0" marL="0">
+              <a:buNone/>
+            </a:pPr>
+            <a:r>
+              <a:rPr lang="en-US" sz="900" i="1" dirty="0">
+                <a:solidFill>
+                  <a:srgbClr val="9B3739"/>
+                </a:solidFill>
+                <a:latin typeface="Times New Roman" pitchFamily="34" charset="0"/>
+                <a:ea typeface="Times New Roman" pitchFamily="34" charset="-122"/>
+                <a:cs typeface="Times New Roman" pitchFamily="34" charset="-120"/>
+              </a:rPr>
+              <a:t>Lease terms and bond maturities</a:t>
+            </a:r>
+            <a:endParaRPr lang="en-US" sz="1100" dirty="0"/>
           </a:p>
         </p:txBody>
       </p:sp>
@@ -3144,7 +2893,7 @@
                 <a:ea typeface="Times New Roman" pitchFamily="34" charset="-122"/>
                 <a:cs typeface="Times New Roman" pitchFamily="34" charset="-120"/>
               </a:rPr>
-              <a:t>Hyperscaler borrowing is getting more expensive. Of 91 hyperscaler bonds issued in 2026 with comparable pricing data, 78 traded at higher yields on July 28 than at issuance, with a median increase of about 22bps, a move that blends rates and spread. The cleaner credit signal is the median new issue concession, which widened to 12bps from 2.25bps in 2025, and Amazon's $25bn deal pushed its existing 30 year bond about 20bps wider. Meta's El Paso bonds priced in July at about 7.5%, roughly 287.5bps over Treasuries, and drew roughly $20bn of orders, about 1.6 times the deal. In September, a Blue Owl sponsored data center leased to CoreWeave reportedly sold $1.1bn of five year high yield notes at 9.25%, about 270bps above similarly rated debt.</a:t>
+              <a:t>Hyperscaler borrowing is getting more expensive. Of 91 hyperscaler bonds issued in 2026 with comparable pricing data, 78 traded at higher yields on July 28 than at issuance, with a median increase of about 22bps, a move that blends rates and spread. The cleaner credit signal is the median new issue concession, which widened to 12bps from 2.25bps in 2025, and Amazon's $25bn deal pushed its existing 30 year bond about 20bps wider. The El Paso joint venture bonds priced in July at about 7.5%, roughly 287.5bps over Treasuries, with orders peaking near $20bn, about 1.6 times the deal. In September, a Blue Owl sponsored data center leased to CoreWeave sold $1.1bn of BB- rated five year notes at 9.25%, about 270bps above the average yield on similarly rated debt.</a:t>
             </a:r>
             <a:endParaRPr lang="en-US" sz="1050" dirty="0"/>
           </a:p>
@@ -3158,7 +2907,7 @@
         </p:nvSpPr>
         <p:spPr>
           <a:xfrm>
-            <a:off x="557784" y="2670048"/>
+            <a:off x="557784" y="2761488"/>
             <a:ext cx="2798064" cy="256032"/>
           </a:xfrm>
           <a:prstGeom prst="rect">
@@ -3197,8 +2946,8 @@
         </p:nvSpPr>
         <p:spPr>
           <a:xfrm>
-            <a:off x="557784" y="2962656"/>
-            <a:ext cx="2798064" cy="1947672"/>
+            <a:off x="557784" y="3054096"/>
+            <a:ext cx="2798064" cy="1865376"/>
           </a:xfrm>
           <a:prstGeom prst="rect">
             <a:avLst/>
@@ -3224,8 +2973,8 @@
         </p:nvSpPr>
         <p:spPr>
           <a:xfrm>
-            <a:off x="694944" y="2962656"/>
-            <a:ext cx="2523744" cy="1947672"/>
+            <a:off x="694944" y="3054096"/>
+            <a:ext cx="2523744" cy="1865376"/>
           </a:xfrm>
           <a:prstGeom prst="rect">
             <a:avLst/>
@@ -3280,7 +3029,7 @@
         </p:nvSpPr>
         <p:spPr>
           <a:xfrm>
-            <a:off x="3502152" y="2670048"/>
+            <a:off x="3502152" y="2761488"/>
             <a:ext cx="2798064" cy="256032"/>
           </a:xfrm>
           <a:prstGeom prst="rect">
@@ -3318,8 +3067,8 @@
           <p:nvPr/>
         </p:nvGraphicFramePr>
         <p:xfrm>
-          <a:off x="3502152" y="2962656"/>
-          <a:ext cx="2798064" cy="1673352"/>
+          <a:off x="3502152" y="3054096"/>
+          <a:ext cx="2798064" cy="1591056"/>
         </p:xfrm>
         <a:graphic xmlns:a="http://schemas.openxmlformats.org/drawingml/2006/main">
           <a:graphicData uri="http://schemas.openxmlformats.org/drawingml/2006/chart">
@@ -3335,7 +3084,7 @@
         </p:nvSpPr>
         <p:spPr>
           <a:xfrm>
-            <a:off x="3502152" y="4654296"/>
+            <a:off x="3502152" y="4663440"/>
             <a:ext cx="2798064" cy="237744"/>
           </a:xfrm>
           <a:prstGeom prst="rect">
@@ -3441,7 +3190,7 @@
                 <a:ea typeface="Times New Roman" pitchFamily="34" charset="-122"/>
                 <a:cs typeface="Times New Roman" pitchFamily="34" charset="-120"/>
               </a:rPr>
-              <a:t>Long dated bonds rest on leases to a single tenant, and Hyperion's leases carry a four year initial term, so repayment after year four depends on Meta renewing or on its residual value guarantee, which covers the first 16 years. The chips inside, which Moody's says can become obsolete within four to six years, turn over far faster. Before a campus operates, power, permitting, and local opposition can delay rent. The BIS notes this borrowing increasingly sits in vehicles funded through private placements, and Moody's has flagged that short leases can understate effective obligations. The key divergence is between abundant capital and its rising price.</a:t>
+              <a:t>Long dated bonds rest on leases to a single tenant, and Hyperion's leases carry a four year initial term, so repayment after year four depends on Meta renewing or on its capped residual value guarantee, which covers the first 16 years. The chips inside, which Moody's says can become obsolete within four to six years, turn over far faster. Before a campus operates, power, permitting, and local opposition can delay rent. The BIS notes this borrowing increasingly sits in vehicles funded through private placements, and Moody's has flagged that short leases can understate effective obligations. The key divergence is between abundant capital and its rising price.</a:t>
             </a:r>
             <a:endParaRPr lang="en-US" sz="1050" dirty="0"/>
           </a:p>
@@ -3561,7 +3310,7 @@
                 <a:ea typeface="Times New Roman" pitchFamily="34" charset="-122"/>
                 <a:cs typeface="Times New Roman" pitchFamily="34" charset="-120"/>
               </a:rPr>
-              <a:t>Meta has funded two campuses through joint ventures with private capital. Hyperion in Louisiana raised $27bn in October 2025 with A+ rated bonds due 2049 priced at 6.58%, about 225bps over Treasuries. El Paso, a one gigawatt campus due online in 2028, followed in July with about $12.5bn of amortizing bonds due 2048, also rated A+ by S&amp;P, at about 7.5%. Both rest on leases to Meta. Higher Treasury yields explain part of the gap, but a spread roughly 60bps wider on the same S&amp;P rating and tenant suggests investors now charge more for structure, supply, and duration.</a:t>
+              <a:t>Meta has funded two campuses through joint ventures with private capital. Hyperion in Louisiana raised $27bn in October 2025 with A+ rated bonds due 2049 priced at 6.58%, about 225bps over Treasuries. El Paso, a one gigawatt campus due online in 2028, followed in July with about $12.5bn of amortizing bonds due 2048, also rated A+ by S&amp;P, at about 7.5%. Both rest on leases to Meta. Higher Treasury yields explain part of the gap, but a spread roughly 60bps wider on the same S&amp;P rating and tenant suggests investors now charge more for structure and supply.</a:t>
             </a:r>
             <a:endParaRPr lang="en-US" sz="1050" dirty="0"/>
           </a:p>

</xml_diff>

<commit_message>
Committee v2 round 1: merge fact check, skeptic and continuity findings
Co-Authored-By: Claude Opus 5.5 <noreply@anthropic.com>
Claude-Session: https://claude.ai/code/session_011SJZihQQoizcK7ApWgRNEa
</commit_message>
<xml_diff>
--- a/outputs/LLC_AI_Infrastructure_Case_Study.pptx
+++ b/outputs/LLC_AI_Infrastructure_Case_Study.pptx
@@ -1798,7 +1798,7 @@
                 <a:ea typeface="Times New Roman" pitchFamily="34" charset="-122"/>
                 <a:cs typeface="Times New Roman" pitchFamily="34" charset="-120"/>
               </a:rPr>
-              <a:t>AI infrastructure financing is the debt raised to build data centers and the computing equipment inside them, and in 2026 it has become one of the largest sources of new supply in credit. Lenders reach the same assets through five routes. Hyperscalers borrow directly in the investment grade bond market. Joint ventures issue project bonds secured by a lease to a hyperscaler, as with Meta's $27.3bn Hyperion financing, where Blue Owl owns 80% of the vehicle, Meta owns 20%, and the A+ rated bonds amortize to 2049. Developers take construction loans against leases to Oracle and OpenAI. Neoclouds such as CoreWeave borrow against GPUs and the customer contracts that pay for them. Stabilized campuses are refinanced through data center ABS and CMBS. In every route the lender is underwriting the tenant. Rating agencies start from the tenant's rating and subtract notches for construction, lease length, and operator risk, so the same type of building can support A+ debt or BB- debt depending on who signs the lease.</a:t>
+              <a:t>AI infrastructure financing is the debt raised to build data centers and the computing equipment inside them, and in 2026 it has become one of the largest sources of new supply in credit. Lenders reach the same assets through five routes. Hyperscalers borrow directly in the investment grade market. Joint ventures issue project bonds secured by a lease to a hyperscaler, as with Meta's $27.3bn Hyperion financing, where Blue Owl owns 80% of the vehicle and the A+ rated bonds amortize to 2049. Developers take construction loans against leases to Oracle and OpenAI. Neoclouds such as CoreWeave borrow against GPUs and the customer contracts that pay for them. Stabilized campuses are refinanced through data center ABS and CMBS. In every route the lender is underwriting the tenant, and agencies start from the tenant's rating and subtract notches for construction, lease length, and operator risk.</a:t>
             </a:r>
             <a:endParaRPr lang="en-US" sz="1050" dirty="0"/>
           </a:p>
@@ -1812,7 +1812,7 @@
         </p:nvSpPr>
         <p:spPr>
           <a:xfrm>
-            <a:off x="557784" y="3090672"/>
+            <a:off x="557784" y="2852928"/>
             <a:ext cx="5742432" cy="347472"/>
           </a:xfrm>
           <a:prstGeom prst="rect">
@@ -1851,8 +1851,8 @@
         </p:nvSpPr>
         <p:spPr>
           <a:xfrm>
-            <a:off x="557784" y="3456432"/>
-            <a:ext cx="5742432" cy="1508760"/>
+            <a:off x="557784" y="3218688"/>
+            <a:ext cx="5742432" cy="1783080"/>
           </a:xfrm>
           <a:prstGeom prst="rect">
             <a:avLst/>
@@ -1879,7 +1879,7 @@
                 <a:ea typeface="Times New Roman" pitchFamily="34" charset="-122"/>
                 <a:cs typeface="Times New Roman" pitchFamily="34" charset="-120"/>
               </a:rPr>
-              <a:t>Leverage rises with the strength of the lease. Hut 8's $4.25bn Beacon Point bonds, backed by a tenant rated AA- or better, financed 95% of project cost at T+165, the highest loan to cost on record for a data center bond. Oracle's Saline Township campus in Michigan raised about $14bn of bonds against $16.3bn of cost, leaving roughly 15% equity. Bank construction loans run lower, with $9.6bn of JPMorgan loans on Stargate Abilene equal to about two thirds of cost. Stabilized campuses are sized on appraised value, and Aligned's $1.18bn ABS in July priced at a 70% loan to value with an A- senior class. GPU lenders advance less because the collateral depreciates, and Apollo's $3.5bn for the vehicle that leases chips to xAI covers about 65% of a $5.4bn purchase. Agencies cut these numbers hard. KBRA valued the single tenant Ohio campus behind BX 2026 VLT10 27.2% below appraisal, lifting leverage on the $1.26bn loan to 108.4%.</a:t>
+              <a:t>Lease backed debt is sized so that contracted rent covers debt service with a thin cushion and the bonds amortize before the lease and its renewals run out, so leverage rises with the strength of the tenant. Hut 8's $4.25bn Beacon Point bonds, backed by a tenant rated AA- or better, financed 95% of project cost at T+165, which Hut 8 calls the highest loan to cost for an HPC data center bond. Oracle's Saline Township campus in Michigan raised about $14bn of bonds against $16.3bn of cost, leaving roughly 15% equity. Stabilized campuses are sized on appraised value, and Aligned's ABS master trust, which added $1.18bn in July, caps its senior notes at 70% of appraised value. GPU lenders lend less because the collateral depreciates, and Apollo's $3.5bn for the vehicle that leases chips to xAI equals about 65% of a $5.4bn purchase. Agencies stress all of these. KBRA cut the cash flow on the single tenant Ohio campus behind BX 2026 VLT10 to 18.9% below the issuer's figure and its value to 27.2% below appraisal, lifting leverage on the $1.26bn loan to 108.4%.</a:t>
             </a:r>
             <a:endParaRPr lang="en-US" sz="1050" dirty="0"/>
           </a:p>
@@ -1893,7 +1893,7 @@
         </p:nvSpPr>
         <p:spPr>
           <a:xfrm>
-            <a:off x="557784" y="5029200"/>
+            <a:off x="557784" y="5074920"/>
             <a:ext cx="5742432" cy="347472"/>
           </a:xfrm>
           <a:prstGeom prst="rect">
@@ -1932,8 +1932,8 @@
         </p:nvSpPr>
         <p:spPr>
           <a:xfrm>
-            <a:off x="557784" y="5394960"/>
-            <a:ext cx="5742432" cy="1188720"/>
+            <a:off x="557784" y="5440680"/>
+            <a:ext cx="5742432" cy="1234440"/>
           </a:xfrm>
           <a:prstGeom prst="rect">
             <a:avLst/>
@@ -1960,7 +1960,7 @@
                 <a:ea typeface="Times New Roman" pitchFamily="34" charset="-122"/>
                 <a:cs typeface="Times New Roman" pitchFamily="34" charset="-120"/>
               </a:rPr>
-              <a:t>The debt is only as long as the lease behind it, and hyperscaler leases are short. Hyperion and El Paso both carry four year initial terms against bonds amortizing to 2049 and 2048, with Meta's capped residual value guarantee covering the gap for 16 years. Moody's counts $662bn of hyperscaler data center leases not yet commenced and held off balance sheet, equal to 113% of their adjusted debt, and says it will treat part of them as debt, while S&amp;P accepted Hyperion as off balance sheet for Meta. The divergence is that one obligation is a lease to one agency and debt to another, and any tenant downgrade passes straight through to the structures built on it.</a:t>
+              <a:t>The debt is only as long as the lease behind it, and hyperscaler leases are short. Hyperion and El Paso both carry four year initial terms against bonds amortizing to 2049 and 2048, and Meta's residual value guarantee on Hyperion, about $28bn and covering the first 16 years, is what bridges the gap. Moody's counted $662bn of hyperscaler data center leases not yet commenced at the end of 2025, held off balance sheet and equal to 113% of their adjusted debt, and says it will treat part of them as debt, while S&amp;P accepted Hyperion as off balance sheet for Meta. The divergence is that one obligation is a lease to one agency and debt to another, and any tenant downgrade passes straight through to the structures built on it.</a:t>
             </a:r>
             <a:endParaRPr lang="en-US" sz="1050" dirty="0"/>
           </a:p>
@@ -2082,7 +2082,7 @@
                 <a:ea typeface="Times New Roman" pitchFamily="34" charset="-122"/>
                 <a:cs typeface="Times New Roman" pitchFamily="34" charset="-120"/>
               </a:rPr>
-              <a:t>Beacon Point, Saline, Aligned ABS, Abilene, xAI chip vehicle</a:t>
+              <a:t>Beacon Point, Saline, Aligned ABS, xAI chip vehicle</a:t>
             </a:r>
             <a:endParaRPr lang="en-US" sz="1100" dirty="0"/>
           </a:p>
@@ -2454,7 +2454,7 @@
                 <a:ea typeface="Times New Roman" pitchFamily="34" charset="-122"/>
                 <a:cs typeface="Times New Roman" pitchFamily="34" charset="-120"/>
               </a:rPr>
-              <a:t>Investors are still funding the buildout, but they are charging more for it. Meta's El Paso joint venture priced $12.5bn of A+ rated amortizing notes on July 27 at 7.534%, or T+287.5, with orders peaking near $20bn, about 1.6 times the deal, against an average book of close to four times for large 2026 deals. Hyperion's 6.581% bonds, issued at par in October 2025, traded in the low 90s by late September without any change in Meta's credit. On September 23 a Blue Owl affiliated campus in Virginia leased to CoreWeave sold $1.1bn of BB- rated five year notes at 98.5 to yield 9.25%, about 270bps above similarly rated debt. GPU loans show the same split. CoreWeave borrowed at SOFR plus 225 in March on an A3 rated facility backed by its Meta contract, then paid SOFR plus 550 in August on a Ba2 facility backed by shorter contracts, 100bps wider than its May loan at the same ratings.</a:t>
+              <a:t>Investors are still funding the buildout, but they are charging more for it. Apollo estimates that order cover on hyperscaler bonds fell from about five times in February to below two times by July. Meta's El Paso joint venture priced $12.5bn of A+ rated amortizing notes on July 27 at 7.534%, or T+287.5, with orders peaking near $20bn, about 1.6 times the deal, while the average bond sale this year drew close to four times. That was 62.5bps wider than Hyperion's T+225 in October 2025 on the same tenant, rating, and template. On September 23 a Blue Owl affiliated campus in Virginia leased to CoreWeave sold $1.1bn of BB- rated five year notes at 98.5 to yield 9.25%, about 270bps above similarly rated debt. GPU loans show the same split. CoreWeave borrowed at SOFR plus 225 in March on an A3 rated facility backed by its Meta contract, then paid SOFR plus 550 in August on a Ba2 facility, 100bps wider than its May loan at the same ratings.</a:t>
             </a:r>
             <a:endParaRPr lang="en-US" sz="1050" dirty="0"/>
           </a:p>
@@ -2522,14 +2522,15 @@
             <a:tbl>
               <a:tblPr/>
               <a:tblGrid>
-                <a:gridCol w="1517904"/>
-                <a:gridCol w="603504"/>
-                <a:gridCol w="603504"/>
-                <a:gridCol w="786384"/>
-                <a:gridCol w="987552"/>
-                <a:gridCol w="1243584"/>
+                <a:gridCol w="1371600"/>
+                <a:gridCol w="548640"/>
+                <a:gridCol w="548640"/>
+                <a:gridCol w="713232"/>
+                <a:gridCol w="914400"/>
+                <a:gridCol w="566928"/>
+                <a:gridCol w="1078992"/>
               </a:tblGrid>
-              <a:tr h="274320">
+              <a:tr h="256032">
                 <a:tc>
                   <a:txBody>
                     <a:bodyPr/>
@@ -2539,7 +2540,7 @@
                         <a:buNone/>
                       </a:pPr>
                       <a:r>
-                        <a:rPr lang="en-US" sz="850" b="1" dirty="0">
+                        <a:rPr lang="en-US" sz="800" b="1" dirty="0">
                           <a:solidFill>
                             <a:srgbClr val="FFFFFF"/>
                           </a:solidFill>
@@ -2549,7 +2550,7 @@
                         </a:rPr>
                         <a:t>Deal</a:t>
                       </a:r>
-                      <a:endParaRPr lang="en-US" sz="850" dirty="0">
+                      <a:endParaRPr lang="en-US" sz="800" dirty="0">
                         <a:latin typeface="Times New Roman" charset="0"/>
                         <a:ea typeface="Times New Roman" charset="0"/>
                         <a:cs typeface="Times New Roman" charset="0"/>
@@ -2607,7 +2608,7 @@
                         <a:buNone/>
                       </a:pPr>
                       <a:r>
-                        <a:rPr lang="en-US" sz="850" b="1" dirty="0">
+                        <a:rPr lang="en-US" sz="800" b="1" dirty="0">
                           <a:solidFill>
                             <a:srgbClr val="FFFFFF"/>
                           </a:solidFill>
@@ -2617,7 +2618,7 @@
                         </a:rPr>
                         <a:t>Priced</a:t>
                       </a:r>
-                      <a:endParaRPr lang="en-US" sz="850" dirty="0">
+                      <a:endParaRPr lang="en-US" sz="800" dirty="0">
                         <a:latin typeface="Times New Roman" charset="0"/>
                         <a:ea typeface="Times New Roman" charset="0"/>
                         <a:cs typeface="Times New Roman" charset="0"/>
@@ -2675,7 +2676,7 @@
                         <a:buNone/>
                       </a:pPr>
                       <a:r>
-                        <a:rPr lang="en-US" sz="850" b="1" dirty="0">
+                        <a:rPr lang="en-US" sz="800" b="1" dirty="0">
                           <a:solidFill>
                             <a:srgbClr val="FFFFFF"/>
                           </a:solidFill>
@@ -2685,7 +2686,7 @@
                         </a:rPr>
                         <a:t>Size</a:t>
                       </a:r>
-                      <a:endParaRPr lang="en-US" sz="850" dirty="0">
+                      <a:endParaRPr lang="en-US" sz="800" dirty="0">
                         <a:latin typeface="Times New Roman" charset="0"/>
                         <a:ea typeface="Times New Roman" charset="0"/>
                         <a:cs typeface="Times New Roman" charset="0"/>
@@ -2743,7 +2744,7 @@
                         <a:buNone/>
                       </a:pPr>
                       <a:r>
-                        <a:rPr lang="en-US" sz="850" b="1" dirty="0">
+                        <a:rPr lang="en-US" sz="800" b="1" dirty="0">
                           <a:solidFill>
                             <a:srgbClr val="FFFFFF"/>
                           </a:solidFill>
@@ -2753,7 +2754,7 @@
                         </a:rPr>
                         <a:t>Rating</a:t>
                       </a:r>
-                      <a:endParaRPr lang="en-US" sz="850" dirty="0">
+                      <a:endParaRPr lang="en-US" sz="800" dirty="0">
                         <a:latin typeface="Times New Roman" charset="0"/>
                         <a:ea typeface="Times New Roman" charset="0"/>
                         <a:cs typeface="Times New Roman" charset="0"/>
@@ -2811,7 +2812,7 @@
                         <a:buNone/>
                       </a:pPr>
                       <a:r>
-                        <a:rPr lang="en-US" sz="850" b="1" dirty="0">
+                        <a:rPr lang="en-US" sz="800" b="1" dirty="0">
                           <a:solidFill>
                             <a:srgbClr val="FFFFFF"/>
                           </a:solidFill>
@@ -2821,7 +2822,7 @@
                         </a:rPr>
                         <a:t>Pricing</a:t>
                       </a:r>
-                      <a:endParaRPr lang="en-US" sz="850" dirty="0">
+                      <a:endParaRPr lang="en-US" sz="800" dirty="0">
                         <a:latin typeface="Times New Roman" charset="0"/>
                         <a:ea typeface="Times New Roman" charset="0"/>
                         <a:cs typeface="Times New Roman" charset="0"/>
@@ -2879,7 +2880,75 @@
                         <a:buNone/>
                       </a:pPr>
                       <a:r>
-                        <a:rPr lang="en-US" sz="850" b="1" dirty="0">
+                        <a:rPr lang="en-US" sz="800" b="1" dirty="0">
+                          <a:solidFill>
+                            <a:srgbClr val="FFFFFF"/>
+                          </a:solidFill>
+                          <a:latin typeface="Times New Roman" pitchFamily="34" charset="0"/>
+                          <a:ea typeface="Times New Roman" pitchFamily="34" charset="-122"/>
+                          <a:cs typeface="Times New Roman" pitchFamily="34" charset="-120"/>
+                        </a:rPr>
+                        <a:t>Final</a:t>
+                      </a:r>
+                      <a:endParaRPr lang="en-US" sz="800" dirty="0">
+                        <a:latin typeface="Times New Roman" charset="0"/>
+                        <a:ea typeface="Times New Roman" charset="0"/>
+                        <a:cs typeface="Times New Roman" charset="0"/>
+                      </a:endParaRPr>
+                    </a:p>
+                  </a:txBody>
+                  <a:tcPr marL="38100" marR="38100" marT="12700" marB="12700" anchor="ctr">
+                    <a:lnL w="6350" cap="flat" cmpd="sng" algn="ctr">
+                      <a:solidFill>
+                        <a:srgbClr val="C9B3B0"/>
+                      </a:solidFill>
+                      <a:prstDash val="solid"/>
+                      <a:round/>
+                      <a:headEnd type="none" w="med" len="med"/>
+                      <a:tailEnd type="none" w="med" len="med"/>
+                    </a:lnL>
+                    <a:lnR w="6350" cap="flat" cmpd="sng" algn="ctr">
+                      <a:solidFill>
+                        <a:srgbClr val="C9B3B0"/>
+                      </a:solidFill>
+                      <a:prstDash val="solid"/>
+                      <a:round/>
+                      <a:headEnd type="none" w="med" len="med"/>
+                      <a:tailEnd type="none" w="med" len="med"/>
+                    </a:lnR>
+                    <a:lnT w="6350" cap="flat" cmpd="sng" algn="ctr">
+                      <a:solidFill>
+                        <a:srgbClr val="C9B3B0"/>
+                      </a:solidFill>
+                      <a:prstDash val="solid"/>
+                      <a:round/>
+                      <a:headEnd type="none" w="med" len="med"/>
+                      <a:tailEnd type="none" w="med" len="med"/>
+                    </a:lnT>
+                    <a:lnB w="6350" cap="flat" cmpd="sng" algn="ctr">
+                      <a:solidFill>
+                        <a:srgbClr val="C9B3B0"/>
+                      </a:solidFill>
+                      <a:prstDash val="solid"/>
+                      <a:round/>
+                      <a:headEnd type="none" w="med" len="med"/>
+                      <a:tailEnd type="none" w="med" len="med"/>
+                    </a:lnB>
+                    <a:solidFill>
+                      <a:srgbClr val="4F1D1B"/>
+                    </a:solidFill>
+                  </a:tcPr>
+                </a:tc>
+                <a:tc>
+                  <a:txBody>
+                    <a:bodyPr/>
+                    <a:lstStyle/>
+                    <a:p>
+                      <a:pPr algn="ctr" indent="0" marL="0">
+                        <a:buNone/>
+                      </a:pPr>
+                      <a:r>
+                        <a:rPr lang="en-US" sz="800" b="1" dirty="0">
                           <a:solidFill>
                             <a:srgbClr val="FFFFFF"/>
                           </a:solidFill>
@@ -2889,7 +2958,7 @@
                         </a:rPr>
                         <a:t>Leverage or collateral</a:t>
                       </a:r>
-                      <a:endParaRPr lang="en-US" sz="850" dirty="0">
+                      <a:endParaRPr lang="en-US" sz="800" dirty="0">
                         <a:latin typeface="Times New Roman" charset="0"/>
                         <a:ea typeface="Times New Roman" charset="0"/>
                         <a:cs typeface="Times New Roman" charset="0"/>
@@ -2939,7 +3008,7 @@
                   </a:tcPr>
                 </a:tc>
               </a:tr>
-              <a:tr h="274320">
+              <a:tr h="256032">
                 <a:tc>
                   <a:txBody>
                     <a:bodyPr/>
@@ -2949,7 +3018,7 @@
                         <a:buNone/>
                       </a:pPr>
                       <a:r>
-                        <a:rPr lang="en-US" sz="850" b="1" dirty="0">
+                        <a:rPr lang="en-US" sz="800" b="1" dirty="0">
                           <a:solidFill>
                             <a:srgbClr val="000000"/>
                           </a:solidFill>
@@ -2959,7 +3028,7 @@
                         </a:rPr>
                         <a:t>Hut 8 Beacon Point bonds</a:t>
                       </a:r>
-                      <a:endParaRPr lang="en-US" sz="850" dirty="0">
+                      <a:endParaRPr lang="en-US" sz="800" dirty="0">
                         <a:latin typeface="Times New Roman" charset="0"/>
                         <a:ea typeface="Times New Roman" charset="0"/>
                         <a:cs typeface="Times New Roman" charset="0"/>
@@ -3017,7 +3086,7 @@
                         <a:buNone/>
                       </a:pPr>
                       <a:r>
-                        <a:rPr lang="en-US" sz="850" dirty="0">
+                        <a:rPr lang="en-US" sz="800" dirty="0">
                           <a:solidFill>
                             <a:srgbClr val="000000"/>
                           </a:solidFill>
@@ -3027,7 +3096,7 @@
                         </a:rPr>
                         <a:t>Jun 2026</a:t>
                       </a:r>
-                      <a:endParaRPr lang="en-US" sz="850" dirty="0">
+                      <a:endParaRPr lang="en-US" sz="800" dirty="0">
                         <a:latin typeface="Times New Roman" charset="0"/>
                         <a:ea typeface="Times New Roman" charset="0"/>
                         <a:cs typeface="Times New Roman" charset="0"/>
@@ -3085,7 +3154,7 @@
                         <a:buNone/>
                       </a:pPr>
                       <a:r>
-                        <a:rPr lang="en-US" sz="850" dirty="0">
+                        <a:rPr lang="en-US" sz="800" dirty="0">
                           <a:solidFill>
                             <a:srgbClr val="000000"/>
                           </a:solidFill>
@@ -3095,7 +3164,7 @@
                         </a:rPr>
                         <a:t>$4.25bn</a:t>
                       </a:r>
-                      <a:endParaRPr lang="en-US" sz="850" dirty="0">
+                      <a:endParaRPr lang="en-US" sz="800" dirty="0">
                         <a:latin typeface="Times New Roman" charset="0"/>
                         <a:ea typeface="Times New Roman" charset="0"/>
                         <a:cs typeface="Times New Roman" charset="0"/>
@@ -3153,7 +3222,7 @@
                         <a:buNone/>
                       </a:pPr>
                       <a:r>
-                        <a:rPr lang="en-US" sz="850" dirty="0">
+                        <a:rPr lang="en-US" sz="800" dirty="0">
                           <a:solidFill>
                             <a:srgbClr val="000000"/>
                           </a:solidFill>
@@ -3163,7 +3232,7 @@
                         </a:rPr>
                         <a:t>Baa2</a:t>
                       </a:r>
-                      <a:endParaRPr lang="en-US" sz="850" dirty="0">
+                      <a:endParaRPr lang="en-US" sz="800" dirty="0">
                         <a:latin typeface="Times New Roman" charset="0"/>
                         <a:ea typeface="Times New Roman" charset="0"/>
                         <a:cs typeface="Times New Roman" charset="0"/>
@@ -3221,7 +3290,7 @@
                         <a:buNone/>
                       </a:pPr>
                       <a:r>
-                        <a:rPr lang="en-US" sz="850" dirty="0">
+                        <a:rPr lang="en-US" sz="800" dirty="0">
                           <a:solidFill>
                             <a:srgbClr val="000000"/>
                           </a:solidFill>
@@ -3231,7 +3300,7 @@
                         </a:rPr>
                         <a:t>6.129%, T+165</a:t>
                       </a:r>
-                      <a:endParaRPr lang="en-US" sz="850" dirty="0">
+                      <a:endParaRPr lang="en-US" sz="800" dirty="0">
                         <a:latin typeface="Times New Roman" charset="0"/>
                         <a:ea typeface="Times New Roman" charset="0"/>
                         <a:cs typeface="Times New Roman" charset="0"/>
@@ -3289,7 +3358,75 @@
                         <a:buNone/>
                       </a:pPr>
                       <a:r>
-                        <a:rPr lang="en-US" sz="850" dirty="0">
+                        <a:rPr lang="en-US" sz="800" dirty="0">
+                          <a:solidFill>
+                            <a:srgbClr val="000000"/>
+                          </a:solidFill>
+                          <a:latin typeface="Times New Roman" pitchFamily="34" charset="0"/>
+                          <a:ea typeface="Times New Roman" pitchFamily="34" charset="-122"/>
+                          <a:cs typeface="Times New Roman" pitchFamily="34" charset="-120"/>
+                        </a:rPr>
+                        <a:t>2042</a:t>
+                      </a:r>
+                      <a:endParaRPr lang="en-US" sz="800" dirty="0">
+                        <a:latin typeface="Times New Roman" charset="0"/>
+                        <a:ea typeface="Times New Roman" charset="0"/>
+                        <a:cs typeface="Times New Roman" charset="0"/>
+                      </a:endParaRPr>
+                    </a:p>
+                  </a:txBody>
+                  <a:tcPr marL="38100" marR="38100" marT="12700" marB="12700" anchor="ctr">
+                    <a:lnL w="6350" cap="flat" cmpd="sng" algn="ctr">
+                      <a:solidFill>
+                        <a:srgbClr val="C9B3B0"/>
+                      </a:solidFill>
+                      <a:prstDash val="solid"/>
+                      <a:round/>
+                      <a:headEnd type="none" w="med" len="med"/>
+                      <a:tailEnd type="none" w="med" len="med"/>
+                    </a:lnL>
+                    <a:lnR w="6350" cap="flat" cmpd="sng" algn="ctr">
+                      <a:solidFill>
+                        <a:srgbClr val="C9B3B0"/>
+                      </a:solidFill>
+                      <a:prstDash val="solid"/>
+                      <a:round/>
+                      <a:headEnd type="none" w="med" len="med"/>
+                      <a:tailEnd type="none" w="med" len="med"/>
+                    </a:lnR>
+                    <a:lnT w="6350" cap="flat" cmpd="sng" algn="ctr">
+                      <a:solidFill>
+                        <a:srgbClr val="C9B3B0"/>
+                      </a:solidFill>
+                      <a:prstDash val="solid"/>
+                      <a:round/>
+                      <a:headEnd type="none" w="med" len="med"/>
+                      <a:tailEnd type="none" w="med" len="med"/>
+                    </a:lnT>
+                    <a:lnB w="6350" cap="flat" cmpd="sng" algn="ctr">
+                      <a:solidFill>
+                        <a:srgbClr val="C9B3B0"/>
+                      </a:solidFill>
+                      <a:prstDash val="solid"/>
+                      <a:round/>
+                      <a:headEnd type="none" w="med" len="med"/>
+                      <a:tailEnd type="none" w="med" len="med"/>
+                    </a:lnB>
+                    <a:solidFill>
+                      <a:srgbClr val="FFFFFF"/>
+                    </a:solidFill>
+                  </a:tcPr>
+                </a:tc>
+                <a:tc>
+                  <a:txBody>
+                    <a:bodyPr/>
+                    <a:lstStyle/>
+                    <a:p>
+                      <a:pPr algn="ctr" indent="0" marL="0">
+                        <a:buNone/>
+                      </a:pPr>
+                      <a:r>
+                        <a:rPr lang="en-US" sz="800" dirty="0">
                           <a:solidFill>
                             <a:srgbClr val="000000"/>
                           </a:solidFill>
@@ -3299,7 +3436,7 @@
                         </a:rPr>
                         <a:t>95% LTC</a:t>
                       </a:r>
-                      <a:endParaRPr lang="en-US" sz="850" dirty="0">
+                      <a:endParaRPr lang="en-US" sz="800" dirty="0">
                         <a:latin typeface="Times New Roman" charset="0"/>
                         <a:ea typeface="Times New Roman" charset="0"/>
                         <a:cs typeface="Times New Roman" charset="0"/>
@@ -3349,7 +3486,7 @@
                   </a:tcPr>
                 </a:tc>
               </a:tr>
-              <a:tr h="274320">
+              <a:tr h="256032">
                 <a:tc>
                   <a:txBody>
                     <a:bodyPr/>
@@ -3359,7 +3496,7 @@
                         <a:buNone/>
                       </a:pPr>
                       <a:r>
-                        <a:rPr lang="en-US" sz="850" b="1" dirty="0">
+                        <a:rPr lang="en-US" sz="800" b="1" dirty="0">
                           <a:solidFill>
                             <a:srgbClr val="000000"/>
                           </a:solidFill>
@@ -3369,7 +3506,7 @@
                         </a:rPr>
                         <a:t>Oracle Saline SPV bonds</a:t>
                       </a:r>
-                      <a:endParaRPr lang="en-US" sz="850" dirty="0">
+                      <a:endParaRPr lang="en-US" sz="800" dirty="0">
                         <a:latin typeface="Times New Roman" charset="0"/>
                         <a:ea typeface="Times New Roman" charset="0"/>
                         <a:cs typeface="Times New Roman" charset="0"/>
@@ -3427,7 +3564,7 @@
                         <a:buNone/>
                       </a:pPr>
                       <a:r>
-                        <a:rPr lang="en-US" sz="850" dirty="0">
+                        <a:rPr lang="en-US" sz="800" dirty="0">
                           <a:solidFill>
                             <a:srgbClr val="000000"/>
                           </a:solidFill>
@@ -3437,7 +3574,7 @@
                         </a:rPr>
                         <a:t>Apr 2026</a:t>
                       </a:r>
-                      <a:endParaRPr lang="en-US" sz="850" dirty="0">
+                      <a:endParaRPr lang="en-US" sz="800" dirty="0">
                         <a:latin typeface="Times New Roman" charset="0"/>
                         <a:ea typeface="Times New Roman" charset="0"/>
                         <a:cs typeface="Times New Roman" charset="0"/>
@@ -3495,7 +3632,7 @@
                         <a:buNone/>
                       </a:pPr>
                       <a:r>
-                        <a:rPr lang="en-US" sz="850" dirty="0">
+                        <a:rPr lang="en-US" sz="800" dirty="0">
                           <a:solidFill>
                             <a:srgbClr val="000000"/>
                           </a:solidFill>
@@ -3505,7 +3642,7 @@
                         </a:rPr>
                         <a:t>~$14bn</a:t>
                       </a:r>
-                      <a:endParaRPr lang="en-US" sz="850" dirty="0">
+                      <a:endParaRPr lang="en-US" sz="800" dirty="0">
                         <a:latin typeface="Times New Roman" charset="0"/>
                         <a:ea typeface="Times New Roman" charset="0"/>
                         <a:cs typeface="Times New Roman" charset="0"/>
@@ -3563,7 +3700,7 @@
                         <a:buNone/>
                       </a:pPr>
                       <a:r>
-                        <a:rPr lang="en-US" sz="850" dirty="0">
+                        <a:rPr lang="en-US" sz="800" dirty="0">
                           <a:solidFill>
                             <a:srgbClr val="000000"/>
                           </a:solidFill>
@@ -3571,9 +3708,9 @@
                           <a:ea typeface="Times New Roman" pitchFamily="34" charset="-122"/>
                           <a:cs typeface="Times New Roman" pitchFamily="34" charset="-120"/>
                         </a:rPr>
-                        <a:t>Not public</a:t>
+                        <a:t>Not disclosed</a:t>
                       </a:r>
-                      <a:endParaRPr lang="en-US" sz="850" dirty="0">
+                      <a:endParaRPr lang="en-US" sz="800" dirty="0">
                         <a:latin typeface="Times New Roman" charset="0"/>
                         <a:ea typeface="Times New Roman" charset="0"/>
                         <a:cs typeface="Times New Roman" charset="0"/>
@@ -3631,7 +3768,7 @@
                         <a:buNone/>
                       </a:pPr>
                       <a:r>
-                        <a:rPr lang="en-US" sz="850" dirty="0">
+                        <a:rPr lang="en-US" sz="800" dirty="0">
                           <a:solidFill>
                             <a:srgbClr val="000000"/>
                           </a:solidFill>
@@ -3639,9 +3776,9 @@
                           <a:ea typeface="Times New Roman" pitchFamily="34" charset="-122"/>
                           <a:cs typeface="Times New Roman" pitchFamily="34" charset="-120"/>
                         </a:rPr>
-                        <a:t>Guided ~7.5%</a:t>
+                        <a:t>7.5% at 98.75</a:t>
                       </a:r>
-                      <a:endParaRPr lang="en-US" sz="850" dirty="0">
+                      <a:endParaRPr lang="en-US" sz="800" dirty="0">
                         <a:latin typeface="Times New Roman" charset="0"/>
                         <a:ea typeface="Times New Roman" charset="0"/>
                         <a:cs typeface="Times New Roman" charset="0"/>
@@ -3699,7 +3836,75 @@
                         <a:buNone/>
                       </a:pPr>
                       <a:r>
-                        <a:rPr lang="en-US" sz="850" dirty="0">
+                        <a:rPr lang="en-US" sz="800" dirty="0">
+                          <a:solidFill>
+                            <a:srgbClr val="000000"/>
+                          </a:solidFill>
+                          <a:latin typeface="Times New Roman" pitchFamily="34" charset="0"/>
+                          <a:ea typeface="Times New Roman" pitchFamily="34" charset="-122"/>
+                          <a:cs typeface="Times New Roman" pitchFamily="34" charset="-120"/>
+                        </a:rPr>
+                        <a:t>2045</a:t>
+                      </a:r>
+                      <a:endParaRPr lang="en-US" sz="800" dirty="0">
+                        <a:latin typeface="Times New Roman" charset="0"/>
+                        <a:ea typeface="Times New Roman" charset="0"/>
+                        <a:cs typeface="Times New Roman" charset="0"/>
+                      </a:endParaRPr>
+                    </a:p>
+                  </a:txBody>
+                  <a:tcPr marL="38100" marR="38100" marT="12700" marB="12700" anchor="ctr">
+                    <a:lnL w="6350" cap="flat" cmpd="sng" algn="ctr">
+                      <a:solidFill>
+                        <a:srgbClr val="C9B3B0"/>
+                      </a:solidFill>
+                      <a:prstDash val="solid"/>
+                      <a:round/>
+                      <a:headEnd type="none" w="med" len="med"/>
+                      <a:tailEnd type="none" w="med" len="med"/>
+                    </a:lnL>
+                    <a:lnR w="6350" cap="flat" cmpd="sng" algn="ctr">
+                      <a:solidFill>
+                        <a:srgbClr val="C9B3B0"/>
+                      </a:solidFill>
+                      <a:prstDash val="solid"/>
+                      <a:round/>
+                      <a:headEnd type="none" w="med" len="med"/>
+                      <a:tailEnd type="none" w="med" len="med"/>
+                    </a:lnR>
+                    <a:lnT w="6350" cap="flat" cmpd="sng" algn="ctr">
+                      <a:solidFill>
+                        <a:srgbClr val="C9B3B0"/>
+                      </a:solidFill>
+                      <a:prstDash val="solid"/>
+                      <a:round/>
+                      <a:headEnd type="none" w="med" len="med"/>
+                      <a:tailEnd type="none" w="med" len="med"/>
+                    </a:lnT>
+                    <a:lnB w="6350" cap="flat" cmpd="sng" algn="ctr">
+                      <a:solidFill>
+                        <a:srgbClr val="C9B3B0"/>
+                      </a:solidFill>
+                      <a:prstDash val="solid"/>
+                      <a:round/>
+                      <a:headEnd type="none" w="med" len="med"/>
+                      <a:tailEnd type="none" w="med" len="med"/>
+                    </a:lnB>
+                    <a:solidFill>
+                      <a:srgbClr val="EDE4DF"/>
+                    </a:solidFill>
+                  </a:tcPr>
+                </a:tc>
+                <a:tc>
+                  <a:txBody>
+                    <a:bodyPr/>
+                    <a:lstStyle/>
+                    <a:p>
+                      <a:pPr algn="ctr" indent="0" marL="0">
+                        <a:buNone/>
+                      </a:pPr>
+                      <a:r>
+                        <a:rPr lang="en-US" sz="800" dirty="0">
                           <a:solidFill>
                             <a:srgbClr val="000000"/>
                           </a:solidFill>
@@ -3709,7 +3914,7 @@
                         </a:rPr>
                         <a:t>~85% LTC (derived)</a:t>
                       </a:r>
-                      <a:endParaRPr lang="en-US" sz="850" dirty="0">
+                      <a:endParaRPr lang="en-US" sz="800" dirty="0">
                         <a:latin typeface="Times New Roman" charset="0"/>
                         <a:ea typeface="Times New Roman" charset="0"/>
                         <a:cs typeface="Times New Roman" charset="0"/>
@@ -3759,7 +3964,7 @@
                   </a:tcPr>
                 </a:tc>
               </a:tr>
-              <a:tr h="274320">
+              <a:tr h="256032">
                 <a:tc>
                   <a:txBody>
                     <a:bodyPr/>
@@ -3769,7 +3974,7 @@
                         <a:buNone/>
                       </a:pPr>
                       <a:r>
-                        <a:rPr lang="en-US" sz="850" b="1" dirty="0">
+                        <a:rPr lang="en-US" sz="800" b="1" dirty="0">
                           <a:solidFill>
                             <a:srgbClr val="000000"/>
                           </a:solidFill>
@@ -3779,7 +3984,7 @@
                         </a:rPr>
                         <a:t>Meta Hyperion SPV bonds</a:t>
                       </a:r>
-                      <a:endParaRPr lang="en-US" sz="850" dirty="0">
+                      <a:endParaRPr lang="en-US" sz="800" dirty="0">
                         <a:latin typeface="Times New Roman" charset="0"/>
                         <a:ea typeface="Times New Roman" charset="0"/>
                         <a:cs typeface="Times New Roman" charset="0"/>
@@ -3837,7 +4042,7 @@
                         <a:buNone/>
                       </a:pPr>
                       <a:r>
-                        <a:rPr lang="en-US" sz="850" dirty="0">
+                        <a:rPr lang="en-US" sz="800" dirty="0">
                           <a:solidFill>
                             <a:srgbClr val="000000"/>
                           </a:solidFill>
@@ -3847,7 +4052,7 @@
                         </a:rPr>
                         <a:t>Oct 2025</a:t>
                       </a:r>
-                      <a:endParaRPr lang="en-US" sz="850" dirty="0">
+                      <a:endParaRPr lang="en-US" sz="800" dirty="0">
                         <a:latin typeface="Times New Roman" charset="0"/>
                         <a:ea typeface="Times New Roman" charset="0"/>
                         <a:cs typeface="Times New Roman" charset="0"/>
@@ -3905,7 +4110,7 @@
                         <a:buNone/>
                       </a:pPr>
                       <a:r>
-                        <a:rPr lang="en-US" sz="850" dirty="0">
+                        <a:rPr lang="en-US" sz="800" dirty="0">
                           <a:solidFill>
                             <a:srgbClr val="000000"/>
                           </a:solidFill>
@@ -3915,7 +4120,7 @@
                         </a:rPr>
                         <a:t>$27.3bn</a:t>
                       </a:r>
-                      <a:endParaRPr lang="en-US" sz="850" dirty="0">
+                      <a:endParaRPr lang="en-US" sz="800" dirty="0">
                         <a:latin typeface="Times New Roman" charset="0"/>
                         <a:ea typeface="Times New Roman" charset="0"/>
                         <a:cs typeface="Times New Roman" charset="0"/>
@@ -3973,7 +4178,7 @@
                         <a:buNone/>
                       </a:pPr>
                       <a:r>
-                        <a:rPr lang="en-US" sz="850" dirty="0">
+                        <a:rPr lang="en-US" sz="800" dirty="0">
                           <a:solidFill>
                             <a:srgbClr val="000000"/>
                           </a:solidFill>
@@ -3983,7 +4188,7 @@
                         </a:rPr>
                         <a:t>A+</a:t>
                       </a:r>
-                      <a:endParaRPr lang="en-US" sz="850" dirty="0">
+                      <a:endParaRPr lang="en-US" sz="800" dirty="0">
                         <a:latin typeface="Times New Roman" charset="0"/>
                         <a:ea typeface="Times New Roman" charset="0"/>
                         <a:cs typeface="Times New Roman" charset="0"/>
@@ -4041,7 +4246,7 @@
                         <a:buNone/>
                       </a:pPr>
                       <a:r>
-                        <a:rPr lang="en-US" sz="850" dirty="0">
+                        <a:rPr lang="en-US" sz="800" dirty="0">
                           <a:solidFill>
                             <a:srgbClr val="000000"/>
                           </a:solidFill>
@@ -4051,7 +4256,7 @@
                         </a:rPr>
                         <a:t>6.581%, T+225</a:t>
                       </a:r>
-                      <a:endParaRPr lang="en-US" sz="850" dirty="0">
+                      <a:endParaRPr lang="en-US" sz="800" dirty="0">
                         <a:latin typeface="Times New Roman" charset="0"/>
                         <a:ea typeface="Times New Roman" charset="0"/>
                         <a:cs typeface="Times New Roman" charset="0"/>
@@ -4109,7 +4314,7 @@
                         <a:buNone/>
                       </a:pPr>
                       <a:r>
-                        <a:rPr lang="en-US" sz="850" dirty="0">
+                        <a:rPr lang="en-US" sz="800" dirty="0">
                           <a:solidFill>
                             <a:srgbClr val="000000"/>
                           </a:solidFill>
@@ -4117,9 +4322,9 @@
                           <a:ea typeface="Times New Roman" pitchFamily="34" charset="-122"/>
                           <a:cs typeface="Times New Roman" pitchFamily="34" charset="-120"/>
                         </a:rPr>
-                        <a:t>Meta lease and RVG</a:t>
+                        <a:t>2049</a:t>
                       </a:r>
-                      <a:endParaRPr lang="en-US" sz="850" dirty="0">
+                      <a:endParaRPr lang="en-US" sz="800" dirty="0">
                         <a:latin typeface="Times New Roman" charset="0"/>
                         <a:ea typeface="Times New Roman" charset="0"/>
                         <a:cs typeface="Times New Roman" charset="0"/>
@@ -4168,8 +4373,76 @@
                     </a:solidFill>
                   </a:tcPr>
                 </a:tc>
+                <a:tc>
+                  <a:txBody>
+                    <a:bodyPr/>
+                    <a:lstStyle/>
+                    <a:p>
+                      <a:pPr algn="ctr" indent="0" marL="0">
+                        <a:buNone/>
+                      </a:pPr>
+                      <a:r>
+                        <a:rPr lang="en-US" sz="800" dirty="0">
+                          <a:solidFill>
+                            <a:srgbClr val="000000"/>
+                          </a:solidFill>
+                          <a:latin typeface="Times New Roman" pitchFamily="34" charset="0"/>
+                          <a:ea typeface="Times New Roman" pitchFamily="34" charset="-122"/>
+                          <a:cs typeface="Times New Roman" pitchFamily="34" charset="-120"/>
+                        </a:rPr>
+                        <a:t>Lease, ~$28bn RVG</a:t>
+                      </a:r>
+                      <a:endParaRPr lang="en-US" sz="800" dirty="0">
+                        <a:latin typeface="Times New Roman" charset="0"/>
+                        <a:ea typeface="Times New Roman" charset="0"/>
+                        <a:cs typeface="Times New Roman" charset="0"/>
+                      </a:endParaRPr>
+                    </a:p>
+                  </a:txBody>
+                  <a:tcPr marL="38100" marR="38100" marT="12700" marB="12700" anchor="ctr">
+                    <a:lnL w="6350" cap="flat" cmpd="sng" algn="ctr">
+                      <a:solidFill>
+                        <a:srgbClr val="C9B3B0"/>
+                      </a:solidFill>
+                      <a:prstDash val="solid"/>
+                      <a:round/>
+                      <a:headEnd type="none" w="med" len="med"/>
+                      <a:tailEnd type="none" w="med" len="med"/>
+                    </a:lnL>
+                    <a:lnR w="6350" cap="flat" cmpd="sng" algn="ctr">
+                      <a:solidFill>
+                        <a:srgbClr val="C9B3B0"/>
+                      </a:solidFill>
+                      <a:prstDash val="solid"/>
+                      <a:round/>
+                      <a:headEnd type="none" w="med" len="med"/>
+                      <a:tailEnd type="none" w="med" len="med"/>
+                    </a:lnR>
+                    <a:lnT w="6350" cap="flat" cmpd="sng" algn="ctr">
+                      <a:solidFill>
+                        <a:srgbClr val="C9B3B0"/>
+                      </a:solidFill>
+                      <a:prstDash val="solid"/>
+                      <a:round/>
+                      <a:headEnd type="none" w="med" len="med"/>
+                      <a:tailEnd type="none" w="med" len="med"/>
+                    </a:lnT>
+                    <a:lnB w="6350" cap="flat" cmpd="sng" algn="ctr">
+                      <a:solidFill>
+                        <a:srgbClr val="C9B3B0"/>
+                      </a:solidFill>
+                      <a:prstDash val="solid"/>
+                      <a:round/>
+                      <a:headEnd type="none" w="med" len="med"/>
+                      <a:tailEnd type="none" w="med" len="med"/>
+                    </a:lnB>
+                    <a:solidFill>
+                      <a:srgbClr val="FFFFFF"/>
+                    </a:solidFill>
+                  </a:tcPr>
+                </a:tc>
               </a:tr>
-              <a:tr h="274320">
+              <a:tr h="256032">
                 <a:tc>
                   <a:txBody>
                     <a:bodyPr/>
@@ -4179,7 +4452,7 @@
                         <a:buNone/>
                       </a:pPr>
                       <a:r>
-                        <a:rPr lang="en-US" sz="850" b="1" dirty="0">
+                        <a:rPr lang="en-US" sz="800" b="1" dirty="0">
                           <a:solidFill>
                             <a:srgbClr val="000000"/>
                           </a:solidFill>
@@ -4189,7 +4462,7 @@
                         </a:rPr>
                         <a:t>Meta El Paso SPV bonds</a:t>
                       </a:r>
-                      <a:endParaRPr lang="en-US" sz="850" dirty="0">
+                      <a:endParaRPr lang="en-US" sz="800" dirty="0">
                         <a:latin typeface="Times New Roman" charset="0"/>
                         <a:ea typeface="Times New Roman" charset="0"/>
                         <a:cs typeface="Times New Roman" charset="0"/>
@@ -4247,7 +4520,7 @@
                         <a:buNone/>
                       </a:pPr>
                       <a:r>
-                        <a:rPr lang="en-US" sz="850" dirty="0">
+                        <a:rPr lang="en-US" sz="800" dirty="0">
                           <a:solidFill>
                             <a:srgbClr val="000000"/>
                           </a:solidFill>
@@ -4257,7 +4530,7 @@
                         </a:rPr>
                         <a:t>Jul 2026</a:t>
                       </a:r>
-                      <a:endParaRPr lang="en-US" sz="850" dirty="0">
+                      <a:endParaRPr lang="en-US" sz="800" dirty="0">
                         <a:latin typeface="Times New Roman" charset="0"/>
                         <a:ea typeface="Times New Roman" charset="0"/>
                         <a:cs typeface="Times New Roman" charset="0"/>
@@ -4315,7 +4588,7 @@
                         <a:buNone/>
                       </a:pPr>
                       <a:r>
-                        <a:rPr lang="en-US" sz="850" dirty="0">
+                        <a:rPr lang="en-US" sz="800" dirty="0">
                           <a:solidFill>
                             <a:srgbClr val="000000"/>
                           </a:solidFill>
@@ -4325,7 +4598,7 @@
                         </a:rPr>
                         <a:t>$12.5bn</a:t>
                       </a:r>
-                      <a:endParaRPr lang="en-US" sz="850" dirty="0">
+                      <a:endParaRPr lang="en-US" sz="800" dirty="0">
                         <a:latin typeface="Times New Roman" charset="0"/>
                         <a:ea typeface="Times New Roman" charset="0"/>
                         <a:cs typeface="Times New Roman" charset="0"/>
@@ -4383,7 +4656,7 @@
                         <a:buNone/>
                       </a:pPr>
                       <a:r>
-                        <a:rPr lang="en-US" sz="850" dirty="0">
+                        <a:rPr lang="en-US" sz="800" dirty="0">
                           <a:solidFill>
                             <a:srgbClr val="000000"/>
                           </a:solidFill>
@@ -4393,7 +4666,7 @@
                         </a:rPr>
                         <a:t>A+ / AA-</a:t>
                       </a:r>
-                      <a:endParaRPr lang="en-US" sz="850" dirty="0">
+                      <a:endParaRPr lang="en-US" sz="800" dirty="0">
                         <a:latin typeface="Times New Roman" charset="0"/>
                         <a:ea typeface="Times New Roman" charset="0"/>
                         <a:cs typeface="Times New Roman" charset="0"/>
@@ -4451,7 +4724,7 @@
                         <a:buNone/>
                       </a:pPr>
                       <a:r>
-                        <a:rPr lang="en-US" sz="850" dirty="0">
+                        <a:rPr lang="en-US" sz="800" dirty="0">
                           <a:solidFill>
                             <a:srgbClr val="000000"/>
                           </a:solidFill>
@@ -4461,7 +4734,7 @@
                         </a:rPr>
                         <a:t>7.534%, T+287.5</a:t>
                       </a:r>
-                      <a:endParaRPr lang="en-US" sz="850" dirty="0">
+                      <a:endParaRPr lang="en-US" sz="800" dirty="0">
                         <a:latin typeface="Times New Roman" charset="0"/>
                         <a:ea typeface="Times New Roman" charset="0"/>
                         <a:cs typeface="Times New Roman" charset="0"/>
@@ -4519,7 +4792,75 @@
                         <a:buNone/>
                       </a:pPr>
                       <a:r>
-                        <a:rPr lang="en-US" sz="850" dirty="0">
+                        <a:rPr lang="en-US" sz="800" dirty="0">
+                          <a:solidFill>
+                            <a:srgbClr val="000000"/>
+                          </a:solidFill>
+                          <a:latin typeface="Times New Roman" pitchFamily="34" charset="0"/>
+                          <a:ea typeface="Times New Roman" pitchFamily="34" charset="-122"/>
+                          <a:cs typeface="Times New Roman" pitchFamily="34" charset="-120"/>
+                        </a:rPr>
+                        <a:t>2048</a:t>
+                      </a:r>
+                      <a:endParaRPr lang="en-US" sz="800" dirty="0">
+                        <a:latin typeface="Times New Roman" charset="0"/>
+                        <a:ea typeface="Times New Roman" charset="0"/>
+                        <a:cs typeface="Times New Roman" charset="0"/>
+                      </a:endParaRPr>
+                    </a:p>
+                  </a:txBody>
+                  <a:tcPr marL="38100" marR="38100" marT="12700" marB="12700" anchor="ctr">
+                    <a:lnL w="6350" cap="flat" cmpd="sng" algn="ctr">
+                      <a:solidFill>
+                        <a:srgbClr val="C9B3B0"/>
+                      </a:solidFill>
+                      <a:prstDash val="solid"/>
+                      <a:round/>
+                      <a:headEnd type="none" w="med" len="med"/>
+                      <a:tailEnd type="none" w="med" len="med"/>
+                    </a:lnL>
+                    <a:lnR w="6350" cap="flat" cmpd="sng" algn="ctr">
+                      <a:solidFill>
+                        <a:srgbClr val="C9B3B0"/>
+                      </a:solidFill>
+                      <a:prstDash val="solid"/>
+                      <a:round/>
+                      <a:headEnd type="none" w="med" len="med"/>
+                      <a:tailEnd type="none" w="med" len="med"/>
+                    </a:lnR>
+                    <a:lnT w="6350" cap="flat" cmpd="sng" algn="ctr">
+                      <a:solidFill>
+                        <a:srgbClr val="C9B3B0"/>
+                      </a:solidFill>
+                      <a:prstDash val="solid"/>
+                      <a:round/>
+                      <a:headEnd type="none" w="med" len="med"/>
+                      <a:tailEnd type="none" w="med" len="med"/>
+                    </a:lnT>
+                    <a:lnB w="6350" cap="flat" cmpd="sng" algn="ctr">
+                      <a:solidFill>
+                        <a:srgbClr val="C9B3B0"/>
+                      </a:solidFill>
+                      <a:prstDash val="solid"/>
+                      <a:round/>
+                      <a:headEnd type="none" w="med" len="med"/>
+                      <a:tailEnd type="none" w="med" len="med"/>
+                    </a:lnB>
+                    <a:solidFill>
+                      <a:srgbClr val="EDE4DF"/>
+                    </a:solidFill>
+                  </a:tcPr>
+                </a:tc>
+                <a:tc>
+                  <a:txBody>
+                    <a:bodyPr/>
+                    <a:lstStyle/>
+                    <a:p>
+                      <a:pPr algn="ctr" indent="0" marL="0">
+                        <a:buNone/>
+                      </a:pPr>
+                      <a:r>
+                        <a:rPr lang="en-US" sz="800" dirty="0">
                           <a:solidFill>
                             <a:srgbClr val="000000"/>
                           </a:solidFill>
@@ -4529,7 +4870,7 @@
                         </a:rPr>
                         <a:t>Meta lease and RVG</a:t>
                       </a:r>
-                      <a:endParaRPr lang="en-US" sz="850" dirty="0">
+                      <a:endParaRPr lang="en-US" sz="800" dirty="0">
                         <a:latin typeface="Times New Roman" charset="0"/>
                         <a:ea typeface="Times New Roman" charset="0"/>
                         <a:cs typeface="Times New Roman" charset="0"/>
@@ -4579,7 +4920,7 @@
                   </a:tcPr>
                 </a:tc>
               </a:tr>
-              <a:tr h="274320">
+              <a:tr h="256032">
                 <a:tc>
                   <a:txBody>
                     <a:bodyPr/>
@@ -4589,7 +4930,7 @@
                         <a:buNone/>
                       </a:pPr>
                       <a:r>
-                        <a:rPr lang="en-US" sz="850" b="1" dirty="0">
+                        <a:rPr lang="en-US" sz="800" b="1" dirty="0">
                           <a:solidFill>
                             <a:srgbClr val="000000"/>
                           </a:solidFill>
@@ -4599,7 +4940,7 @@
                         </a:rPr>
                         <a:t>Digital Drive (CoreWeave)</a:t>
                       </a:r>
-                      <a:endParaRPr lang="en-US" sz="850" dirty="0">
+                      <a:endParaRPr lang="en-US" sz="800" dirty="0">
                         <a:latin typeface="Times New Roman" charset="0"/>
                         <a:ea typeface="Times New Roman" charset="0"/>
                         <a:cs typeface="Times New Roman" charset="0"/>
@@ -4657,7 +4998,7 @@
                         <a:buNone/>
                       </a:pPr>
                       <a:r>
-                        <a:rPr lang="en-US" sz="850" dirty="0">
+                        <a:rPr lang="en-US" sz="800" dirty="0">
                           <a:solidFill>
                             <a:srgbClr val="000000"/>
                           </a:solidFill>
@@ -4667,7 +5008,7 @@
                         </a:rPr>
                         <a:t>Sep 2026</a:t>
                       </a:r>
-                      <a:endParaRPr lang="en-US" sz="850" dirty="0">
+                      <a:endParaRPr lang="en-US" sz="800" dirty="0">
                         <a:latin typeface="Times New Roman" charset="0"/>
                         <a:ea typeface="Times New Roman" charset="0"/>
                         <a:cs typeface="Times New Roman" charset="0"/>
@@ -4725,7 +5066,7 @@
                         <a:buNone/>
                       </a:pPr>
                       <a:r>
-                        <a:rPr lang="en-US" sz="850" dirty="0">
+                        <a:rPr lang="en-US" sz="800" dirty="0">
                           <a:solidFill>
                             <a:srgbClr val="000000"/>
                           </a:solidFill>
@@ -4735,7 +5076,7 @@
                         </a:rPr>
                         <a:t>$1.1bn</a:t>
                       </a:r>
-                      <a:endParaRPr lang="en-US" sz="850" dirty="0">
+                      <a:endParaRPr lang="en-US" sz="800" dirty="0">
                         <a:latin typeface="Times New Roman" charset="0"/>
                         <a:ea typeface="Times New Roman" charset="0"/>
                         <a:cs typeface="Times New Roman" charset="0"/>
@@ -4793,7 +5134,7 @@
                         <a:buNone/>
                       </a:pPr>
                       <a:r>
-                        <a:rPr lang="en-US" sz="850" dirty="0">
+                        <a:rPr lang="en-US" sz="800" dirty="0">
                           <a:solidFill>
                             <a:srgbClr val="000000"/>
                           </a:solidFill>
@@ -4803,7 +5144,7 @@
                         </a:rPr>
                         <a:t>BB-</a:t>
                       </a:r>
-                      <a:endParaRPr lang="en-US" sz="850" dirty="0">
+                      <a:endParaRPr lang="en-US" sz="800" dirty="0">
                         <a:latin typeface="Times New Roman" charset="0"/>
                         <a:ea typeface="Times New Roman" charset="0"/>
                         <a:cs typeface="Times New Roman" charset="0"/>
@@ -4861,7 +5202,7 @@
                         <a:buNone/>
                       </a:pPr>
                       <a:r>
-                        <a:rPr lang="en-US" sz="850" dirty="0">
+                        <a:rPr lang="en-US" sz="800" dirty="0">
                           <a:solidFill>
                             <a:srgbClr val="000000"/>
                           </a:solidFill>
@@ -4871,7 +5212,7 @@
                         </a:rPr>
                         <a:t>9.25% yield</a:t>
                       </a:r>
-                      <a:endParaRPr lang="en-US" sz="850" dirty="0">
+                      <a:endParaRPr lang="en-US" sz="800" dirty="0">
                         <a:latin typeface="Times New Roman" charset="0"/>
                         <a:ea typeface="Times New Roman" charset="0"/>
                         <a:cs typeface="Times New Roman" charset="0"/>
@@ -4929,7 +5270,7 @@
                         <a:buNone/>
                       </a:pPr>
                       <a:r>
-                        <a:rPr lang="en-US" sz="850" dirty="0">
+                        <a:rPr lang="en-US" sz="800" dirty="0">
                           <a:solidFill>
                             <a:srgbClr val="000000"/>
                           </a:solidFill>
@@ -4937,9 +5278,9 @@
                           <a:ea typeface="Times New Roman" pitchFamily="34" charset="-122"/>
                           <a:cs typeface="Times New Roman" pitchFamily="34" charset="-120"/>
                         </a:rPr>
-                        <a:t>15 yr CoreWeave lease</a:t>
+                        <a:t>5 yr</a:t>
                       </a:r>
-                      <a:endParaRPr lang="en-US" sz="850" dirty="0">
+                      <a:endParaRPr lang="en-US" sz="800" dirty="0">
                         <a:latin typeface="Times New Roman" charset="0"/>
                         <a:ea typeface="Times New Roman" charset="0"/>
                         <a:cs typeface="Times New Roman" charset="0"/>
@@ -4988,8 +5329,76 @@
                     </a:solidFill>
                   </a:tcPr>
                 </a:tc>
+                <a:tc>
+                  <a:txBody>
+                    <a:bodyPr/>
+                    <a:lstStyle/>
+                    <a:p>
+                      <a:pPr algn="ctr" indent="0" marL="0">
+                        <a:buNone/>
+                      </a:pPr>
+                      <a:r>
+                        <a:rPr lang="en-US" sz="800" dirty="0">
+                          <a:solidFill>
+                            <a:srgbClr val="000000"/>
+                          </a:solidFill>
+                          <a:latin typeface="Times New Roman" pitchFamily="34" charset="0"/>
+                          <a:ea typeface="Times New Roman" pitchFamily="34" charset="-122"/>
+                          <a:cs typeface="Times New Roman" pitchFamily="34" charset="-120"/>
+                        </a:rPr>
+                        <a:t>CoreWeave lease</a:t>
+                      </a:r>
+                      <a:endParaRPr lang="en-US" sz="800" dirty="0">
+                        <a:latin typeface="Times New Roman" charset="0"/>
+                        <a:ea typeface="Times New Roman" charset="0"/>
+                        <a:cs typeface="Times New Roman" charset="0"/>
+                      </a:endParaRPr>
+                    </a:p>
+                  </a:txBody>
+                  <a:tcPr marL="38100" marR="38100" marT="12700" marB="12700" anchor="ctr">
+                    <a:lnL w="6350" cap="flat" cmpd="sng" algn="ctr">
+                      <a:solidFill>
+                        <a:srgbClr val="C9B3B0"/>
+                      </a:solidFill>
+                      <a:prstDash val="solid"/>
+                      <a:round/>
+                      <a:headEnd type="none" w="med" len="med"/>
+                      <a:tailEnd type="none" w="med" len="med"/>
+                    </a:lnL>
+                    <a:lnR w="6350" cap="flat" cmpd="sng" algn="ctr">
+                      <a:solidFill>
+                        <a:srgbClr val="C9B3B0"/>
+                      </a:solidFill>
+                      <a:prstDash val="solid"/>
+                      <a:round/>
+                      <a:headEnd type="none" w="med" len="med"/>
+                      <a:tailEnd type="none" w="med" len="med"/>
+                    </a:lnR>
+                    <a:lnT w="6350" cap="flat" cmpd="sng" algn="ctr">
+                      <a:solidFill>
+                        <a:srgbClr val="C9B3B0"/>
+                      </a:solidFill>
+                      <a:prstDash val="solid"/>
+                      <a:round/>
+                      <a:headEnd type="none" w="med" len="med"/>
+                      <a:tailEnd type="none" w="med" len="med"/>
+                    </a:lnT>
+                    <a:lnB w="6350" cap="flat" cmpd="sng" algn="ctr">
+                      <a:solidFill>
+                        <a:srgbClr val="C9B3B0"/>
+                      </a:solidFill>
+                      <a:prstDash val="solid"/>
+                      <a:round/>
+                      <a:headEnd type="none" w="med" len="med"/>
+                      <a:tailEnd type="none" w="med" len="med"/>
+                    </a:lnB>
+                    <a:solidFill>
+                      <a:srgbClr val="FFFFFF"/>
+                    </a:solidFill>
+                  </a:tcPr>
+                </a:tc>
               </a:tr>
-              <a:tr h="274320">
+              <a:tr h="256032">
                 <a:tc>
                   <a:txBody>
                     <a:bodyPr/>
@@ -4999,7 +5408,7 @@
                         <a:buNone/>
                       </a:pPr>
                       <a:r>
-                        <a:rPr lang="en-US" sz="850" b="1" dirty="0">
+                        <a:rPr lang="en-US" sz="800" b="1" dirty="0">
                           <a:solidFill>
                             <a:srgbClr val="000000"/>
                           </a:solidFill>
@@ -5009,7 +5418,7 @@
                         </a:rPr>
                         <a:t>Aligned data center ABS</a:t>
                       </a:r>
-                      <a:endParaRPr lang="en-US" sz="850" dirty="0">
+                      <a:endParaRPr lang="en-US" sz="800" dirty="0">
                         <a:latin typeface="Times New Roman" charset="0"/>
                         <a:ea typeface="Times New Roman" charset="0"/>
                         <a:cs typeface="Times New Roman" charset="0"/>
@@ -5067,7 +5476,7 @@
                         <a:buNone/>
                       </a:pPr>
                       <a:r>
-                        <a:rPr lang="en-US" sz="850" dirty="0">
+                        <a:rPr lang="en-US" sz="800" dirty="0">
                           <a:solidFill>
                             <a:srgbClr val="000000"/>
                           </a:solidFill>
@@ -5077,7 +5486,7 @@
                         </a:rPr>
                         <a:t>Jul 2026</a:t>
                       </a:r>
-                      <a:endParaRPr lang="en-US" sz="850" dirty="0">
+                      <a:endParaRPr lang="en-US" sz="800" dirty="0">
                         <a:latin typeface="Times New Roman" charset="0"/>
                         <a:ea typeface="Times New Roman" charset="0"/>
                         <a:cs typeface="Times New Roman" charset="0"/>
@@ -5135,7 +5544,7 @@
                         <a:buNone/>
                       </a:pPr>
                       <a:r>
-                        <a:rPr lang="en-US" sz="850" dirty="0">
+                        <a:rPr lang="en-US" sz="800" dirty="0">
                           <a:solidFill>
                             <a:srgbClr val="000000"/>
                           </a:solidFill>
@@ -5145,7 +5554,7 @@
                         </a:rPr>
                         <a:t>$1.18bn</a:t>
                       </a:r>
-                      <a:endParaRPr lang="en-US" sz="850" dirty="0">
+                      <a:endParaRPr lang="en-US" sz="800" dirty="0">
                         <a:latin typeface="Times New Roman" charset="0"/>
                         <a:ea typeface="Times New Roman" charset="0"/>
                         <a:cs typeface="Times New Roman" charset="0"/>
@@ -5203,7 +5612,7 @@
                         <a:buNone/>
                       </a:pPr>
                       <a:r>
-                        <a:rPr lang="en-US" sz="850" dirty="0">
+                        <a:rPr lang="en-US" sz="800" dirty="0">
                           <a:solidFill>
                             <a:srgbClr val="000000"/>
                           </a:solidFill>
@@ -5213,7 +5622,7 @@
                         </a:rPr>
                         <a:t>A- senior</a:t>
                       </a:r>
-                      <a:endParaRPr lang="en-US" sz="850" dirty="0">
+                      <a:endParaRPr lang="en-US" sz="800" dirty="0">
                         <a:latin typeface="Times New Roman" charset="0"/>
                         <a:ea typeface="Times New Roman" charset="0"/>
                         <a:cs typeface="Times New Roman" charset="0"/>
@@ -5271,7 +5680,7 @@
                         <a:buNone/>
                       </a:pPr>
                       <a:r>
-                        <a:rPr lang="en-US" sz="850" dirty="0">
+                        <a:rPr lang="en-US" sz="800" dirty="0">
                           <a:solidFill>
                             <a:srgbClr val="000000"/>
                           </a:solidFill>
@@ -5281,7 +5690,7 @@
                         </a:rPr>
                         <a:t>Not disclosed</a:t>
                       </a:r>
-                      <a:endParaRPr lang="en-US" sz="850" dirty="0">
+                      <a:endParaRPr lang="en-US" sz="800" dirty="0">
                         <a:latin typeface="Times New Roman" charset="0"/>
                         <a:ea typeface="Times New Roman" charset="0"/>
                         <a:cs typeface="Times New Roman" charset="0"/>
@@ -5339,7 +5748,7 @@
                         <a:buNone/>
                       </a:pPr>
                       <a:r>
-                        <a:rPr lang="en-US" sz="850" dirty="0">
+                        <a:rPr lang="en-US" sz="800" dirty="0">
                           <a:solidFill>
                             <a:srgbClr val="000000"/>
                           </a:solidFill>
@@ -5347,9 +5756,9 @@
                           <a:ea typeface="Times New Roman" pitchFamily="34" charset="-122"/>
                           <a:cs typeface="Times New Roman" pitchFamily="34" charset="-120"/>
                         </a:rPr>
-                        <a:t>70% LTV</a:t>
+                        <a:t>5 yr ARD</a:t>
                       </a:r>
-                      <a:endParaRPr lang="en-US" sz="850" dirty="0">
+                      <a:endParaRPr lang="en-US" sz="800" dirty="0">
                         <a:latin typeface="Times New Roman" charset="0"/>
                         <a:ea typeface="Times New Roman" charset="0"/>
                         <a:cs typeface="Times New Roman" charset="0"/>
@@ -5398,8 +5807,76 @@
                     </a:solidFill>
                   </a:tcPr>
                 </a:tc>
+                <a:tc>
+                  <a:txBody>
+                    <a:bodyPr/>
+                    <a:lstStyle/>
+                    <a:p>
+                      <a:pPr algn="ctr" indent="0" marL="0">
+                        <a:buNone/>
+                      </a:pPr>
+                      <a:r>
+                        <a:rPr lang="en-US" sz="800" dirty="0">
+                          <a:solidFill>
+                            <a:srgbClr val="000000"/>
+                          </a:solidFill>
+                          <a:latin typeface="Times New Roman" pitchFamily="34" charset="0"/>
+                          <a:ea typeface="Times New Roman" pitchFamily="34" charset="-122"/>
+                          <a:cs typeface="Times New Roman" pitchFamily="34" charset="-120"/>
+                        </a:rPr>
+                        <a:t>70% LTV cap</a:t>
+                      </a:r>
+                      <a:endParaRPr lang="en-US" sz="800" dirty="0">
+                        <a:latin typeface="Times New Roman" charset="0"/>
+                        <a:ea typeface="Times New Roman" charset="0"/>
+                        <a:cs typeface="Times New Roman" charset="0"/>
+                      </a:endParaRPr>
+                    </a:p>
+                  </a:txBody>
+                  <a:tcPr marL="38100" marR="38100" marT="12700" marB="12700" anchor="ctr">
+                    <a:lnL w="6350" cap="flat" cmpd="sng" algn="ctr">
+                      <a:solidFill>
+                        <a:srgbClr val="C9B3B0"/>
+                      </a:solidFill>
+                      <a:prstDash val="solid"/>
+                      <a:round/>
+                      <a:headEnd type="none" w="med" len="med"/>
+                      <a:tailEnd type="none" w="med" len="med"/>
+                    </a:lnL>
+                    <a:lnR w="6350" cap="flat" cmpd="sng" algn="ctr">
+                      <a:solidFill>
+                        <a:srgbClr val="C9B3B0"/>
+                      </a:solidFill>
+                      <a:prstDash val="solid"/>
+                      <a:round/>
+                      <a:headEnd type="none" w="med" len="med"/>
+                      <a:tailEnd type="none" w="med" len="med"/>
+                    </a:lnR>
+                    <a:lnT w="6350" cap="flat" cmpd="sng" algn="ctr">
+                      <a:solidFill>
+                        <a:srgbClr val="C9B3B0"/>
+                      </a:solidFill>
+                      <a:prstDash val="solid"/>
+                      <a:round/>
+                      <a:headEnd type="none" w="med" len="med"/>
+                      <a:tailEnd type="none" w="med" len="med"/>
+                    </a:lnT>
+                    <a:lnB w="6350" cap="flat" cmpd="sng" algn="ctr">
+                      <a:solidFill>
+                        <a:srgbClr val="C9B3B0"/>
+                      </a:solidFill>
+                      <a:prstDash val="solid"/>
+                      <a:round/>
+                      <a:headEnd type="none" w="med" len="med"/>
+                      <a:tailEnd type="none" w="med" len="med"/>
+                    </a:lnB>
+                    <a:solidFill>
+                      <a:srgbClr val="EDE4DF"/>
+                    </a:solidFill>
+                  </a:tcPr>
+                </a:tc>
               </a:tr>
-              <a:tr h="274320">
+              <a:tr h="256032">
                 <a:tc>
                   <a:txBody>
                     <a:bodyPr/>
@@ -5409,7 +5886,7 @@
                         <a:buNone/>
                       </a:pPr>
                       <a:r>
-                        <a:rPr lang="en-US" sz="850" b="1" dirty="0">
+                        <a:rPr lang="en-US" sz="800" b="1" dirty="0">
                           <a:solidFill>
                             <a:srgbClr val="000000"/>
                           </a:solidFill>
@@ -5419,7 +5896,7 @@
                         </a:rPr>
                         <a:t>BX 2026 VLT10 CMBS</a:t>
                       </a:r>
-                      <a:endParaRPr lang="en-US" sz="850" dirty="0">
+                      <a:endParaRPr lang="en-US" sz="800" dirty="0">
                         <a:latin typeface="Times New Roman" charset="0"/>
                         <a:ea typeface="Times New Roman" charset="0"/>
                         <a:cs typeface="Times New Roman" charset="0"/>
@@ -5477,7 +5954,7 @@
                         <a:buNone/>
                       </a:pPr>
                       <a:r>
-                        <a:rPr lang="en-US" sz="850" dirty="0">
+                        <a:rPr lang="en-US" sz="800" dirty="0">
                           <a:solidFill>
                             <a:srgbClr val="000000"/>
                           </a:solidFill>
@@ -5487,7 +5964,7 @@
                         </a:rPr>
                         <a:t>Jun 2026</a:t>
                       </a:r>
-                      <a:endParaRPr lang="en-US" sz="850" dirty="0">
+                      <a:endParaRPr lang="en-US" sz="800" dirty="0">
                         <a:latin typeface="Times New Roman" charset="0"/>
                         <a:ea typeface="Times New Roman" charset="0"/>
                         <a:cs typeface="Times New Roman" charset="0"/>
@@ -5545,7 +6022,7 @@
                         <a:buNone/>
                       </a:pPr>
                       <a:r>
-                        <a:rPr lang="en-US" sz="850" dirty="0">
+                        <a:rPr lang="en-US" sz="800" dirty="0">
                           <a:solidFill>
                             <a:srgbClr val="000000"/>
                           </a:solidFill>
@@ -5555,7 +6032,7 @@
                         </a:rPr>
                         <a:t>$1.26bn</a:t>
                       </a:r>
-                      <a:endParaRPr lang="en-US" sz="850" dirty="0">
+                      <a:endParaRPr lang="en-US" sz="800" dirty="0">
                         <a:latin typeface="Times New Roman" charset="0"/>
                         <a:ea typeface="Times New Roman" charset="0"/>
                         <a:cs typeface="Times New Roman" charset="0"/>
@@ -5613,7 +6090,7 @@
                         <a:buNone/>
                       </a:pPr>
                       <a:r>
-                        <a:rPr lang="en-US" sz="850" dirty="0">
+                        <a:rPr lang="en-US" sz="800" dirty="0">
                           <a:solidFill>
                             <a:srgbClr val="000000"/>
                           </a:solidFill>
@@ -5623,7 +6100,7 @@
                         </a:rPr>
                         <a:t>KBRA rated</a:t>
                       </a:r>
-                      <a:endParaRPr lang="en-US" sz="850" dirty="0">
+                      <a:endParaRPr lang="en-US" sz="800" dirty="0">
                         <a:latin typeface="Times New Roman" charset="0"/>
                         <a:ea typeface="Times New Roman" charset="0"/>
                         <a:cs typeface="Times New Roman" charset="0"/>
@@ -5681,7 +6158,7 @@
                         <a:buNone/>
                       </a:pPr>
                       <a:r>
-                        <a:rPr lang="en-US" sz="850" dirty="0">
+                        <a:rPr lang="en-US" sz="800" dirty="0">
                           <a:solidFill>
                             <a:srgbClr val="000000"/>
                           </a:solidFill>
@@ -5691,7 +6168,7 @@
                         </a:rPr>
                         <a:t>Not disclosed</a:t>
                       </a:r>
-                      <a:endParaRPr lang="en-US" sz="850" dirty="0">
+                      <a:endParaRPr lang="en-US" sz="800" dirty="0">
                         <a:latin typeface="Times New Roman" charset="0"/>
                         <a:ea typeface="Times New Roman" charset="0"/>
                         <a:cs typeface="Times New Roman" charset="0"/>
@@ -5749,7 +6226,75 @@
                         <a:buNone/>
                       </a:pPr>
                       <a:r>
-                        <a:rPr lang="en-US" sz="850" dirty="0">
+                        <a:rPr lang="en-US" sz="800" dirty="0">
+                          <a:solidFill>
+                            <a:srgbClr val="000000"/>
+                          </a:solidFill>
+                          <a:latin typeface="Times New Roman" pitchFamily="34" charset="0"/>
+                          <a:ea typeface="Times New Roman" pitchFamily="34" charset="-122"/>
+                          <a:cs typeface="Times New Roman" pitchFamily="34" charset="-120"/>
+                        </a:rPr>
+                        <a:t>10 yr ARD</a:t>
+                      </a:r>
+                      <a:endParaRPr lang="en-US" sz="800" dirty="0">
+                        <a:latin typeface="Times New Roman" charset="0"/>
+                        <a:ea typeface="Times New Roman" charset="0"/>
+                        <a:cs typeface="Times New Roman" charset="0"/>
+                      </a:endParaRPr>
+                    </a:p>
+                  </a:txBody>
+                  <a:tcPr marL="38100" marR="38100" marT="12700" marB="12700" anchor="ctr">
+                    <a:lnL w="6350" cap="flat" cmpd="sng" algn="ctr">
+                      <a:solidFill>
+                        <a:srgbClr val="C9B3B0"/>
+                      </a:solidFill>
+                      <a:prstDash val="solid"/>
+                      <a:round/>
+                      <a:headEnd type="none" w="med" len="med"/>
+                      <a:tailEnd type="none" w="med" len="med"/>
+                    </a:lnL>
+                    <a:lnR w="6350" cap="flat" cmpd="sng" algn="ctr">
+                      <a:solidFill>
+                        <a:srgbClr val="C9B3B0"/>
+                      </a:solidFill>
+                      <a:prstDash val="solid"/>
+                      <a:round/>
+                      <a:headEnd type="none" w="med" len="med"/>
+                      <a:tailEnd type="none" w="med" len="med"/>
+                    </a:lnR>
+                    <a:lnT w="6350" cap="flat" cmpd="sng" algn="ctr">
+                      <a:solidFill>
+                        <a:srgbClr val="C9B3B0"/>
+                      </a:solidFill>
+                      <a:prstDash val="solid"/>
+                      <a:round/>
+                      <a:headEnd type="none" w="med" len="med"/>
+                      <a:tailEnd type="none" w="med" len="med"/>
+                    </a:lnT>
+                    <a:lnB w="6350" cap="flat" cmpd="sng" algn="ctr">
+                      <a:solidFill>
+                        <a:srgbClr val="C9B3B0"/>
+                      </a:solidFill>
+                      <a:prstDash val="solid"/>
+                      <a:round/>
+                      <a:headEnd type="none" w="med" len="med"/>
+                      <a:tailEnd type="none" w="med" len="med"/>
+                    </a:lnB>
+                    <a:solidFill>
+                      <a:srgbClr val="FFFFFF"/>
+                    </a:solidFill>
+                  </a:tcPr>
+                </a:tc>
+                <a:tc>
+                  <a:txBody>
+                    <a:bodyPr/>
+                    <a:lstStyle/>
+                    <a:p>
+                      <a:pPr algn="ctr" indent="0" marL="0">
+                        <a:buNone/>
+                      </a:pPr>
+                      <a:r>
+                        <a:rPr lang="en-US" sz="800" dirty="0">
                           <a:solidFill>
                             <a:srgbClr val="000000"/>
                           </a:solidFill>
@@ -5759,7 +6304,7 @@
                         </a:rPr>
                         <a:t>108% KBRA LTV</a:t>
                       </a:r>
-                      <a:endParaRPr lang="en-US" sz="850" dirty="0">
+                      <a:endParaRPr lang="en-US" sz="800" dirty="0">
                         <a:latin typeface="Times New Roman" charset="0"/>
                         <a:ea typeface="Times New Roman" charset="0"/>
                         <a:cs typeface="Times New Roman" charset="0"/>
@@ -5809,7 +6354,7 @@
                   </a:tcPr>
                 </a:tc>
               </a:tr>
-              <a:tr h="274320">
+              <a:tr h="256032">
                 <a:tc>
                   <a:txBody>
                     <a:bodyPr/>
@@ -5819,7 +6364,7 @@
                         <a:buNone/>
                       </a:pPr>
                       <a:r>
-                        <a:rPr lang="en-US" sz="850" b="1" dirty="0">
+                        <a:rPr lang="en-US" sz="800" b="1" dirty="0">
                           <a:solidFill>
                             <a:srgbClr val="000000"/>
                           </a:solidFill>
@@ -5829,7 +6374,7 @@
                         </a:rPr>
                         <a:t>CoreWeave DDTL 4.0</a:t>
                       </a:r>
-                      <a:endParaRPr lang="en-US" sz="850" dirty="0">
+                      <a:endParaRPr lang="en-US" sz="800" dirty="0">
                         <a:latin typeface="Times New Roman" charset="0"/>
                         <a:ea typeface="Times New Roman" charset="0"/>
                         <a:cs typeface="Times New Roman" charset="0"/>
@@ -5887,7 +6432,7 @@
                         <a:buNone/>
                       </a:pPr>
                       <a:r>
-                        <a:rPr lang="en-US" sz="850" dirty="0">
+                        <a:rPr lang="en-US" sz="800" dirty="0">
                           <a:solidFill>
                             <a:srgbClr val="000000"/>
                           </a:solidFill>
@@ -5897,7 +6442,7 @@
                         </a:rPr>
                         <a:t>Mar 2026</a:t>
                       </a:r>
-                      <a:endParaRPr lang="en-US" sz="850" dirty="0">
+                      <a:endParaRPr lang="en-US" sz="800" dirty="0">
                         <a:latin typeface="Times New Roman" charset="0"/>
                         <a:ea typeface="Times New Roman" charset="0"/>
                         <a:cs typeface="Times New Roman" charset="0"/>
@@ -5955,7 +6500,7 @@
                         <a:buNone/>
                       </a:pPr>
                       <a:r>
-                        <a:rPr lang="en-US" sz="850" dirty="0">
+                        <a:rPr lang="en-US" sz="800" dirty="0">
                           <a:solidFill>
                             <a:srgbClr val="000000"/>
                           </a:solidFill>
@@ -5965,7 +6510,7 @@
                         </a:rPr>
                         <a:t>$8.5bn</a:t>
                       </a:r>
-                      <a:endParaRPr lang="en-US" sz="850" dirty="0">
+                      <a:endParaRPr lang="en-US" sz="800" dirty="0">
                         <a:latin typeface="Times New Roman" charset="0"/>
                         <a:ea typeface="Times New Roman" charset="0"/>
                         <a:cs typeface="Times New Roman" charset="0"/>
@@ -6023,7 +6568,7 @@
                         <a:buNone/>
                       </a:pPr>
                       <a:r>
-                        <a:rPr lang="en-US" sz="850" dirty="0">
+                        <a:rPr lang="en-US" sz="800" dirty="0">
                           <a:solidFill>
                             <a:srgbClr val="000000"/>
                           </a:solidFill>
@@ -6033,7 +6578,7 @@
                         </a:rPr>
                         <a:t>A3</a:t>
                       </a:r>
-                      <a:endParaRPr lang="en-US" sz="850" dirty="0">
+                      <a:endParaRPr lang="en-US" sz="800" dirty="0">
                         <a:latin typeface="Times New Roman" charset="0"/>
                         <a:ea typeface="Times New Roman" charset="0"/>
                         <a:cs typeface="Times New Roman" charset="0"/>
@@ -6091,7 +6636,7 @@
                         <a:buNone/>
                       </a:pPr>
                       <a:r>
-                        <a:rPr lang="en-US" sz="850" dirty="0">
+                        <a:rPr lang="en-US" sz="800" dirty="0">
                           <a:solidFill>
                             <a:srgbClr val="000000"/>
                           </a:solidFill>
@@ -6101,7 +6646,7 @@
                         </a:rPr>
                         <a:t>SOFR+225</a:t>
                       </a:r>
-                      <a:endParaRPr lang="en-US" sz="850" dirty="0">
+                      <a:endParaRPr lang="en-US" sz="800" dirty="0">
                         <a:latin typeface="Times New Roman" charset="0"/>
                         <a:ea typeface="Times New Roman" charset="0"/>
                         <a:cs typeface="Times New Roman" charset="0"/>
@@ -6159,7 +6704,75 @@
                         <a:buNone/>
                       </a:pPr>
                       <a:r>
-                        <a:rPr lang="en-US" sz="850" dirty="0">
+                        <a:rPr lang="en-US" sz="800" dirty="0">
+                          <a:solidFill>
+                            <a:srgbClr val="000000"/>
+                          </a:solidFill>
+                          <a:latin typeface="Times New Roman" pitchFamily="34" charset="0"/>
+                          <a:ea typeface="Times New Roman" pitchFamily="34" charset="-122"/>
+                          <a:cs typeface="Times New Roman" pitchFamily="34" charset="-120"/>
+                        </a:rPr>
+                        <a:t>2032</a:t>
+                      </a:r>
+                      <a:endParaRPr lang="en-US" sz="800" dirty="0">
+                        <a:latin typeface="Times New Roman" charset="0"/>
+                        <a:ea typeface="Times New Roman" charset="0"/>
+                        <a:cs typeface="Times New Roman" charset="0"/>
+                      </a:endParaRPr>
+                    </a:p>
+                  </a:txBody>
+                  <a:tcPr marL="38100" marR="38100" marT="12700" marB="12700" anchor="ctr">
+                    <a:lnL w="6350" cap="flat" cmpd="sng" algn="ctr">
+                      <a:solidFill>
+                        <a:srgbClr val="C9B3B0"/>
+                      </a:solidFill>
+                      <a:prstDash val="solid"/>
+                      <a:round/>
+                      <a:headEnd type="none" w="med" len="med"/>
+                      <a:tailEnd type="none" w="med" len="med"/>
+                    </a:lnL>
+                    <a:lnR w="6350" cap="flat" cmpd="sng" algn="ctr">
+                      <a:solidFill>
+                        <a:srgbClr val="C9B3B0"/>
+                      </a:solidFill>
+                      <a:prstDash val="solid"/>
+                      <a:round/>
+                      <a:headEnd type="none" w="med" len="med"/>
+                      <a:tailEnd type="none" w="med" len="med"/>
+                    </a:lnR>
+                    <a:lnT w="6350" cap="flat" cmpd="sng" algn="ctr">
+                      <a:solidFill>
+                        <a:srgbClr val="C9B3B0"/>
+                      </a:solidFill>
+                      <a:prstDash val="solid"/>
+                      <a:round/>
+                      <a:headEnd type="none" w="med" len="med"/>
+                      <a:tailEnd type="none" w="med" len="med"/>
+                    </a:lnT>
+                    <a:lnB w="6350" cap="flat" cmpd="sng" algn="ctr">
+                      <a:solidFill>
+                        <a:srgbClr val="C9B3B0"/>
+                      </a:solidFill>
+                      <a:prstDash val="solid"/>
+                      <a:round/>
+                      <a:headEnd type="none" w="med" len="med"/>
+                      <a:tailEnd type="none" w="med" len="med"/>
+                    </a:lnB>
+                    <a:solidFill>
+                      <a:srgbClr val="EDE4DF"/>
+                    </a:solidFill>
+                  </a:tcPr>
+                </a:tc>
+                <a:tc>
+                  <a:txBody>
+                    <a:bodyPr/>
+                    <a:lstStyle/>
+                    <a:p>
+                      <a:pPr algn="ctr" indent="0" marL="0">
+                        <a:buNone/>
+                      </a:pPr>
+                      <a:r>
+                        <a:rPr lang="en-US" sz="800" dirty="0">
                           <a:solidFill>
                             <a:srgbClr val="000000"/>
                           </a:solidFill>
@@ -6169,7 +6782,7 @@
                         </a:rPr>
                         <a:t>GPUs, Meta contract</a:t>
                       </a:r>
-                      <a:endParaRPr lang="en-US" sz="850" dirty="0">
+                      <a:endParaRPr lang="en-US" sz="800" dirty="0">
                         <a:latin typeface="Times New Roman" charset="0"/>
                         <a:ea typeface="Times New Roman" charset="0"/>
                         <a:cs typeface="Times New Roman" charset="0"/>
@@ -6219,7 +6832,7 @@
                   </a:tcPr>
                 </a:tc>
               </a:tr>
-              <a:tr h="274320">
+              <a:tr h="256032">
                 <a:tc>
                   <a:txBody>
                     <a:bodyPr/>
@@ -6229,7 +6842,7 @@
                         <a:buNone/>
                       </a:pPr>
                       <a:r>
-                        <a:rPr lang="en-US" sz="850" b="1" dirty="0">
+                        <a:rPr lang="en-US" sz="800" b="1" dirty="0">
                           <a:solidFill>
                             <a:srgbClr val="000000"/>
                           </a:solidFill>
@@ -6239,7 +6852,7 @@
                         </a:rPr>
                         <a:t>CoreWeave DDTL 5.5</a:t>
                       </a:r>
-                      <a:endParaRPr lang="en-US" sz="850" dirty="0">
+                      <a:endParaRPr lang="en-US" sz="800" dirty="0">
                         <a:latin typeface="Times New Roman" charset="0"/>
                         <a:ea typeface="Times New Roman" charset="0"/>
                         <a:cs typeface="Times New Roman" charset="0"/>
@@ -6297,7 +6910,7 @@
                         <a:buNone/>
                       </a:pPr>
                       <a:r>
-                        <a:rPr lang="en-US" sz="850" dirty="0">
+                        <a:rPr lang="en-US" sz="800" dirty="0">
                           <a:solidFill>
                             <a:srgbClr val="000000"/>
                           </a:solidFill>
@@ -6307,7 +6920,7 @@
                         </a:rPr>
                         <a:t>Aug 2026</a:t>
                       </a:r>
-                      <a:endParaRPr lang="en-US" sz="850" dirty="0">
+                      <a:endParaRPr lang="en-US" sz="800" dirty="0">
                         <a:latin typeface="Times New Roman" charset="0"/>
                         <a:ea typeface="Times New Roman" charset="0"/>
                         <a:cs typeface="Times New Roman" charset="0"/>
@@ -6365,7 +6978,7 @@
                         <a:buNone/>
                       </a:pPr>
                       <a:r>
-                        <a:rPr lang="en-US" sz="850" dirty="0">
+                        <a:rPr lang="en-US" sz="800" dirty="0">
                           <a:solidFill>
                             <a:srgbClr val="000000"/>
                           </a:solidFill>
@@ -6375,7 +6988,7 @@
                         </a:rPr>
                         <a:t>$2.6bn</a:t>
                       </a:r>
-                      <a:endParaRPr lang="en-US" sz="850" dirty="0">
+                      <a:endParaRPr lang="en-US" sz="800" dirty="0">
                         <a:latin typeface="Times New Roman" charset="0"/>
                         <a:ea typeface="Times New Roman" charset="0"/>
                         <a:cs typeface="Times New Roman" charset="0"/>
@@ -6433,7 +7046,7 @@
                         <a:buNone/>
                       </a:pPr>
                       <a:r>
-                        <a:rPr lang="en-US" sz="850" dirty="0">
+                        <a:rPr lang="en-US" sz="800" dirty="0">
                           <a:solidFill>
                             <a:srgbClr val="000000"/>
                           </a:solidFill>
@@ -6443,7 +7056,7 @@
                         </a:rPr>
                         <a:t>Ba2 / BB+</a:t>
                       </a:r>
-                      <a:endParaRPr lang="en-US" sz="850" dirty="0">
+                      <a:endParaRPr lang="en-US" sz="800" dirty="0">
                         <a:latin typeface="Times New Roman" charset="0"/>
                         <a:ea typeface="Times New Roman" charset="0"/>
                         <a:cs typeface="Times New Roman" charset="0"/>
@@ -6501,7 +7114,7 @@
                         <a:buNone/>
                       </a:pPr>
                       <a:r>
-                        <a:rPr lang="en-US" sz="850" dirty="0">
+                        <a:rPr lang="en-US" sz="800" dirty="0">
                           <a:solidFill>
                             <a:srgbClr val="000000"/>
                           </a:solidFill>
@@ -6511,7 +7124,7 @@
                         </a:rPr>
                         <a:t>SOFR+550</a:t>
                       </a:r>
-                      <a:endParaRPr lang="en-US" sz="850" dirty="0">
+                      <a:endParaRPr lang="en-US" sz="800" dirty="0">
                         <a:latin typeface="Times New Roman" charset="0"/>
                         <a:ea typeface="Times New Roman" charset="0"/>
                         <a:cs typeface="Times New Roman" charset="0"/>
@@ -6569,7 +7182,75 @@
                         <a:buNone/>
                       </a:pPr>
                       <a:r>
-                        <a:rPr lang="en-US" sz="850" dirty="0">
+                        <a:rPr lang="en-US" sz="800" dirty="0">
+                          <a:solidFill>
+                            <a:srgbClr val="000000"/>
+                          </a:solidFill>
+                          <a:latin typeface="Times New Roman" pitchFamily="34" charset="0"/>
+                          <a:ea typeface="Times New Roman" pitchFamily="34" charset="-122"/>
+                          <a:cs typeface="Times New Roman" pitchFamily="34" charset="-120"/>
+                        </a:rPr>
+                        <a:t>2031</a:t>
+                      </a:r>
+                      <a:endParaRPr lang="en-US" sz="800" dirty="0">
+                        <a:latin typeface="Times New Roman" charset="0"/>
+                        <a:ea typeface="Times New Roman" charset="0"/>
+                        <a:cs typeface="Times New Roman" charset="0"/>
+                      </a:endParaRPr>
+                    </a:p>
+                  </a:txBody>
+                  <a:tcPr marL="38100" marR="38100" marT="12700" marB="12700" anchor="ctr">
+                    <a:lnL w="6350" cap="flat" cmpd="sng" algn="ctr">
+                      <a:solidFill>
+                        <a:srgbClr val="C9B3B0"/>
+                      </a:solidFill>
+                      <a:prstDash val="solid"/>
+                      <a:round/>
+                      <a:headEnd type="none" w="med" len="med"/>
+                      <a:tailEnd type="none" w="med" len="med"/>
+                    </a:lnL>
+                    <a:lnR w="6350" cap="flat" cmpd="sng" algn="ctr">
+                      <a:solidFill>
+                        <a:srgbClr val="C9B3B0"/>
+                      </a:solidFill>
+                      <a:prstDash val="solid"/>
+                      <a:round/>
+                      <a:headEnd type="none" w="med" len="med"/>
+                      <a:tailEnd type="none" w="med" len="med"/>
+                    </a:lnR>
+                    <a:lnT w="6350" cap="flat" cmpd="sng" algn="ctr">
+                      <a:solidFill>
+                        <a:srgbClr val="C9B3B0"/>
+                      </a:solidFill>
+                      <a:prstDash val="solid"/>
+                      <a:round/>
+                      <a:headEnd type="none" w="med" len="med"/>
+                      <a:tailEnd type="none" w="med" len="med"/>
+                    </a:lnT>
+                    <a:lnB w="6350" cap="flat" cmpd="sng" algn="ctr">
+                      <a:solidFill>
+                        <a:srgbClr val="C9B3B0"/>
+                      </a:solidFill>
+                      <a:prstDash val="solid"/>
+                      <a:round/>
+                      <a:headEnd type="none" w="med" len="med"/>
+                      <a:tailEnd type="none" w="med" len="med"/>
+                    </a:lnB>
+                    <a:solidFill>
+                      <a:srgbClr val="FFFFFF"/>
+                    </a:solidFill>
+                  </a:tcPr>
+                </a:tc>
+                <a:tc>
+                  <a:txBody>
+                    <a:bodyPr/>
+                    <a:lstStyle/>
+                    <a:p>
+                      <a:pPr algn="ctr" indent="0" marL="0">
+                        <a:buNone/>
+                      </a:pPr>
+                      <a:r>
+                        <a:rPr lang="en-US" sz="800" dirty="0">
                           <a:solidFill>
                             <a:srgbClr val="000000"/>
                           </a:solidFill>
@@ -6579,7 +7260,7 @@
                         </a:rPr>
                         <a:t>GPUs, ~3 yr contracts</a:t>
                       </a:r>
-                      <a:endParaRPr lang="en-US" sz="850" dirty="0">
+                      <a:endParaRPr lang="en-US" sz="800" dirty="0">
                         <a:latin typeface="Times New Roman" charset="0"/>
                         <a:ea typeface="Times New Roman" charset="0"/>
                         <a:cs typeface="Times New Roman" charset="0"/>
@@ -6629,7 +7310,7 @@
                   </a:tcPr>
                 </a:tc>
               </a:tr>
-              <a:tr h="274320">
+              <a:tr h="256032">
                 <a:tc>
                   <a:txBody>
                     <a:bodyPr/>
@@ -6639,7 +7320,7 @@
                         <a:buNone/>
                       </a:pPr>
                       <a:r>
-                        <a:rPr lang="en-US" sz="850" b="1" dirty="0">
+                        <a:rPr lang="en-US" sz="800" b="1" dirty="0">
                           <a:solidFill>
                             <a:srgbClr val="000000"/>
                           </a:solidFill>
@@ -6649,7 +7330,7 @@
                         </a:rPr>
                         <a:t>Lambda term loan B</a:t>
                       </a:r>
-                      <a:endParaRPr lang="en-US" sz="850" dirty="0">
+                      <a:endParaRPr lang="en-US" sz="800" dirty="0">
                         <a:latin typeface="Times New Roman" charset="0"/>
                         <a:ea typeface="Times New Roman" charset="0"/>
                         <a:cs typeface="Times New Roman" charset="0"/>
@@ -6707,7 +7388,7 @@
                         <a:buNone/>
                       </a:pPr>
                       <a:r>
-                        <a:rPr lang="en-US" sz="850" dirty="0">
+                        <a:rPr lang="en-US" sz="800" dirty="0">
                           <a:solidFill>
                             <a:srgbClr val="000000"/>
                           </a:solidFill>
@@ -6717,7 +7398,7 @@
                         </a:rPr>
                         <a:t>Aug 2026</a:t>
                       </a:r>
-                      <a:endParaRPr lang="en-US" sz="850" dirty="0">
+                      <a:endParaRPr lang="en-US" sz="800" dirty="0">
                         <a:latin typeface="Times New Roman" charset="0"/>
                         <a:ea typeface="Times New Roman" charset="0"/>
                         <a:cs typeface="Times New Roman" charset="0"/>
@@ -6775,7 +7456,7 @@
                         <a:buNone/>
                       </a:pPr>
                       <a:r>
-                        <a:rPr lang="en-US" sz="850" dirty="0">
+                        <a:rPr lang="en-US" sz="800" dirty="0">
                           <a:solidFill>
                             <a:srgbClr val="000000"/>
                           </a:solidFill>
@@ -6785,7 +7466,7 @@
                         </a:rPr>
                         <a:t>$926m</a:t>
                       </a:r>
-                      <a:endParaRPr lang="en-US" sz="850" dirty="0">
+                      <a:endParaRPr lang="en-US" sz="800" dirty="0">
                         <a:latin typeface="Times New Roman" charset="0"/>
                         <a:ea typeface="Times New Roman" charset="0"/>
                         <a:cs typeface="Times New Roman" charset="0"/>
@@ -6843,7 +7524,7 @@
                         <a:buNone/>
                       </a:pPr>
                       <a:r>
-                        <a:rPr lang="en-US" sz="850" dirty="0">
+                        <a:rPr lang="en-US" sz="800" dirty="0">
                           <a:solidFill>
                             <a:srgbClr val="000000"/>
                           </a:solidFill>
@@ -6853,7 +7534,7 @@
                         </a:rPr>
                         <a:t>Baa2</a:t>
                       </a:r>
-                      <a:endParaRPr lang="en-US" sz="850" dirty="0">
+                      <a:endParaRPr lang="en-US" sz="800" dirty="0">
                         <a:latin typeface="Times New Roman" charset="0"/>
                         <a:ea typeface="Times New Roman" charset="0"/>
                         <a:cs typeface="Times New Roman" charset="0"/>
@@ -6911,7 +7592,7 @@
                         <a:buNone/>
                       </a:pPr>
                       <a:r>
-                        <a:rPr lang="en-US" sz="850" dirty="0">
+                        <a:rPr lang="en-US" sz="800" dirty="0">
                           <a:solidFill>
                             <a:srgbClr val="000000"/>
                           </a:solidFill>
@@ -6921,7 +7602,7 @@
                         </a:rPr>
                         <a:t>SOFR+300</a:t>
                       </a:r>
-                      <a:endParaRPr lang="en-US" sz="850" dirty="0">
+                      <a:endParaRPr lang="en-US" sz="800" dirty="0">
                         <a:latin typeface="Times New Roman" charset="0"/>
                         <a:ea typeface="Times New Roman" charset="0"/>
                         <a:cs typeface="Times New Roman" charset="0"/>
@@ -6979,7 +7660,75 @@
                         <a:buNone/>
                       </a:pPr>
                       <a:r>
-                        <a:rPr lang="en-US" sz="850" dirty="0">
+                        <a:rPr lang="en-US" sz="800" dirty="0">
+                          <a:solidFill>
+                            <a:srgbClr val="000000"/>
+                          </a:solidFill>
+                          <a:latin typeface="Times New Roman" pitchFamily="34" charset="0"/>
+                          <a:ea typeface="Times New Roman" pitchFamily="34" charset="-122"/>
+                          <a:cs typeface="Times New Roman" pitchFamily="34" charset="-120"/>
+                        </a:rPr>
+                        <a:t>2030</a:t>
+                      </a:r>
+                      <a:endParaRPr lang="en-US" sz="800" dirty="0">
+                        <a:latin typeface="Times New Roman" charset="0"/>
+                        <a:ea typeface="Times New Roman" charset="0"/>
+                        <a:cs typeface="Times New Roman" charset="0"/>
+                      </a:endParaRPr>
+                    </a:p>
+                  </a:txBody>
+                  <a:tcPr marL="38100" marR="38100" marT="12700" marB="12700" anchor="ctr">
+                    <a:lnL w="6350" cap="flat" cmpd="sng" algn="ctr">
+                      <a:solidFill>
+                        <a:srgbClr val="C9B3B0"/>
+                      </a:solidFill>
+                      <a:prstDash val="solid"/>
+                      <a:round/>
+                      <a:headEnd type="none" w="med" len="med"/>
+                      <a:tailEnd type="none" w="med" len="med"/>
+                    </a:lnL>
+                    <a:lnR w="6350" cap="flat" cmpd="sng" algn="ctr">
+                      <a:solidFill>
+                        <a:srgbClr val="C9B3B0"/>
+                      </a:solidFill>
+                      <a:prstDash val="solid"/>
+                      <a:round/>
+                      <a:headEnd type="none" w="med" len="med"/>
+                      <a:tailEnd type="none" w="med" len="med"/>
+                    </a:lnR>
+                    <a:lnT w="6350" cap="flat" cmpd="sng" algn="ctr">
+                      <a:solidFill>
+                        <a:srgbClr val="C9B3B0"/>
+                      </a:solidFill>
+                      <a:prstDash val="solid"/>
+                      <a:round/>
+                      <a:headEnd type="none" w="med" len="med"/>
+                      <a:tailEnd type="none" w="med" len="med"/>
+                    </a:lnT>
+                    <a:lnB w="6350" cap="flat" cmpd="sng" algn="ctr">
+                      <a:solidFill>
+                        <a:srgbClr val="C9B3B0"/>
+                      </a:solidFill>
+                      <a:prstDash val="solid"/>
+                      <a:round/>
+                      <a:headEnd type="none" w="med" len="med"/>
+                      <a:tailEnd type="none" w="med" len="med"/>
+                    </a:lnB>
+                    <a:solidFill>
+                      <a:srgbClr val="EDE4DF"/>
+                    </a:solidFill>
+                  </a:tcPr>
+                </a:tc>
+                <a:tc>
+                  <a:txBody>
+                    <a:bodyPr/>
+                    <a:lstStyle/>
+                    <a:p>
+                      <a:pPr algn="ctr" indent="0" marL="0">
+                        <a:buNone/>
+                      </a:pPr>
+                      <a:r>
+                        <a:rPr lang="en-US" sz="800" dirty="0">
                           <a:solidFill>
                             <a:srgbClr val="000000"/>
                           </a:solidFill>
@@ -6989,7 +7738,7 @@
                         </a:rPr>
                         <a:t>GPUs, IG offtaker</a:t>
                       </a:r>
-                      <a:endParaRPr lang="en-US" sz="850" dirty="0">
+                      <a:endParaRPr lang="en-US" sz="800" dirty="0">
                         <a:latin typeface="Times New Roman" charset="0"/>
                         <a:ea typeface="Times New Roman" charset="0"/>
                         <a:cs typeface="Times New Roman" charset="0"/>
@@ -7039,7 +7788,7 @@
                   </a:tcPr>
                 </a:tc>
               </a:tr>
-              <a:tr h="274320">
+              <a:tr h="256032">
                 <a:tc>
                   <a:txBody>
                     <a:bodyPr/>
@@ -7049,7 +7798,7 @@
                         <a:buNone/>
                       </a:pPr>
                       <a:r>
-                        <a:rPr lang="en-US" sz="850" b="1" dirty="0">
+                        <a:rPr lang="en-US" sz="800" b="1" dirty="0">
                           <a:solidFill>
                             <a:srgbClr val="000000"/>
                           </a:solidFill>
@@ -7059,7 +7808,7 @@
                         </a:rPr>
                         <a:t>Oracle Jupiter loan</a:t>
                       </a:r>
-                      <a:endParaRPr lang="en-US" sz="850" dirty="0">
+                      <a:endParaRPr lang="en-US" sz="800" dirty="0">
                         <a:latin typeface="Times New Roman" charset="0"/>
                         <a:ea typeface="Times New Roman" charset="0"/>
                         <a:cs typeface="Times New Roman" charset="0"/>
@@ -7117,7 +7866,7 @@
                         <a:buNone/>
                       </a:pPr>
                       <a:r>
-                        <a:rPr lang="en-US" sz="850" dirty="0">
+                        <a:rPr lang="en-US" sz="800" dirty="0">
                           <a:solidFill>
                             <a:srgbClr val="000000"/>
                           </a:solidFill>
@@ -7127,7 +7876,7 @@
                         </a:rPr>
                         <a:t>Late 2025</a:t>
                       </a:r>
-                      <a:endParaRPr lang="en-US" sz="850" dirty="0">
+                      <a:endParaRPr lang="en-US" sz="800" dirty="0">
                         <a:latin typeface="Times New Roman" charset="0"/>
                         <a:ea typeface="Times New Roman" charset="0"/>
                         <a:cs typeface="Times New Roman" charset="0"/>
@@ -7185,7 +7934,7 @@
                         <a:buNone/>
                       </a:pPr>
                       <a:r>
-                        <a:rPr lang="en-US" sz="850" dirty="0">
+                        <a:rPr lang="en-US" sz="800" dirty="0">
                           <a:solidFill>
                             <a:srgbClr val="000000"/>
                           </a:solidFill>
@@ -7195,7 +7944,7 @@
                         </a:rPr>
                         <a:t>~$18bn</a:t>
                       </a:r>
-                      <a:endParaRPr lang="en-US" sz="850" dirty="0">
+                      <a:endParaRPr lang="en-US" sz="800" dirty="0">
                         <a:latin typeface="Times New Roman" charset="0"/>
                         <a:ea typeface="Times New Roman" charset="0"/>
                         <a:cs typeface="Times New Roman" charset="0"/>
@@ -7253,7 +8002,7 @@
                         <a:buNone/>
                       </a:pPr>
                       <a:r>
-                        <a:rPr lang="en-US" sz="850" dirty="0">
+                        <a:rPr lang="en-US" sz="800" dirty="0">
                           <a:solidFill>
                             <a:srgbClr val="000000"/>
                           </a:solidFill>
@@ -7261,9 +8010,9 @@
                           <a:ea typeface="Times New Roman" pitchFamily="34" charset="-122"/>
                           <a:cs typeface="Times New Roman" pitchFamily="34" charset="-120"/>
                         </a:rPr>
-                        <a:t>Unrated</a:t>
+                        <a:t>Not disclosed</a:t>
                       </a:r>
-                      <a:endParaRPr lang="en-US" sz="850" dirty="0">
+                      <a:endParaRPr lang="en-US" sz="800" dirty="0">
                         <a:latin typeface="Times New Roman" charset="0"/>
                         <a:ea typeface="Times New Roman" charset="0"/>
                         <a:cs typeface="Times New Roman" charset="0"/>
@@ -7321,7 +8070,7 @@
                         <a:buNone/>
                       </a:pPr>
                       <a:r>
-                        <a:rPr lang="en-US" sz="850" dirty="0">
+                        <a:rPr lang="en-US" sz="800" dirty="0">
                           <a:solidFill>
                             <a:srgbClr val="000000"/>
                           </a:solidFill>
@@ -7331,7 +8080,7 @@
                         </a:rPr>
                         <a:t>Quoted 89 to 91</a:t>
                       </a:r>
-                      <a:endParaRPr lang="en-US" sz="850" dirty="0">
+                      <a:endParaRPr lang="en-US" sz="800" dirty="0">
                         <a:latin typeface="Times New Roman" charset="0"/>
                         <a:ea typeface="Times New Roman" charset="0"/>
                         <a:cs typeface="Times New Roman" charset="0"/>
@@ -7389,7 +8138,75 @@
                         <a:buNone/>
                       </a:pPr>
                       <a:r>
-                        <a:rPr lang="en-US" sz="850" dirty="0">
+                        <a:rPr lang="en-US" sz="800" dirty="0">
+                          <a:solidFill>
+                            <a:srgbClr val="000000"/>
+                          </a:solidFill>
+                          <a:latin typeface="Times New Roman" pitchFamily="34" charset="0"/>
+                          <a:ea typeface="Times New Roman" pitchFamily="34" charset="-122"/>
+                          <a:cs typeface="Times New Roman" pitchFamily="34" charset="-120"/>
+                        </a:rPr>
+                        <a:t>n/a</a:t>
+                      </a:r>
+                      <a:endParaRPr lang="en-US" sz="800" dirty="0">
+                        <a:latin typeface="Times New Roman" charset="0"/>
+                        <a:ea typeface="Times New Roman" charset="0"/>
+                        <a:cs typeface="Times New Roman" charset="0"/>
+                      </a:endParaRPr>
+                    </a:p>
+                  </a:txBody>
+                  <a:tcPr marL="38100" marR="38100" marT="12700" marB="12700" anchor="ctr">
+                    <a:lnL w="6350" cap="flat" cmpd="sng" algn="ctr">
+                      <a:solidFill>
+                        <a:srgbClr val="C9B3B0"/>
+                      </a:solidFill>
+                      <a:prstDash val="solid"/>
+                      <a:round/>
+                      <a:headEnd type="none" w="med" len="med"/>
+                      <a:tailEnd type="none" w="med" len="med"/>
+                    </a:lnL>
+                    <a:lnR w="6350" cap="flat" cmpd="sng" algn="ctr">
+                      <a:solidFill>
+                        <a:srgbClr val="C9B3B0"/>
+                      </a:solidFill>
+                      <a:prstDash val="solid"/>
+                      <a:round/>
+                      <a:headEnd type="none" w="med" len="med"/>
+                      <a:tailEnd type="none" w="med" len="med"/>
+                    </a:lnR>
+                    <a:lnT w="6350" cap="flat" cmpd="sng" algn="ctr">
+                      <a:solidFill>
+                        <a:srgbClr val="C9B3B0"/>
+                      </a:solidFill>
+                      <a:prstDash val="solid"/>
+                      <a:round/>
+                      <a:headEnd type="none" w="med" len="med"/>
+                      <a:tailEnd type="none" w="med" len="med"/>
+                    </a:lnT>
+                    <a:lnB w="6350" cap="flat" cmpd="sng" algn="ctr">
+                      <a:solidFill>
+                        <a:srgbClr val="C9B3B0"/>
+                      </a:solidFill>
+                      <a:prstDash val="solid"/>
+                      <a:round/>
+                      <a:headEnd type="none" w="med" len="med"/>
+                      <a:tailEnd type="none" w="med" len="med"/>
+                    </a:lnB>
+                    <a:solidFill>
+                      <a:srgbClr val="FFFFFF"/>
+                    </a:solidFill>
+                  </a:tcPr>
+                </a:tc>
+                <a:tc>
+                  <a:txBody>
+                    <a:bodyPr/>
+                    <a:lstStyle/>
+                    <a:p>
+                      <a:pPr algn="ctr" indent="0" marL="0">
+                        <a:buNone/>
+                      </a:pPr>
+                      <a:r>
+                        <a:rPr lang="en-US" sz="800" dirty="0">
                           <a:solidFill>
                             <a:srgbClr val="000000"/>
                           </a:solidFill>
@@ -7399,7 +8216,7 @@
                         </a:rPr>
                         <a:t>Oracle lease (BBB-)</a:t>
                       </a:r>
-                      <a:endParaRPr lang="en-US" sz="850" dirty="0">
+                      <a:endParaRPr lang="en-US" sz="800" dirty="0">
                         <a:latin typeface="Times New Roman" charset="0"/>
                         <a:ea typeface="Times New Roman" charset="0"/>
                         <a:cs typeface="Times New Roman" charset="0"/>
@@ -7461,7 +8278,7 @@
         </p:nvSpPr>
         <p:spPr>
           <a:xfrm>
-            <a:off x="557784" y="6592824"/>
+            <a:off x="557784" y="6373368"/>
             <a:ext cx="5742432" cy="237744"/>
           </a:xfrm>
           <a:prstGeom prst="rect">
@@ -7486,7 +8303,7 @@
                 <a:ea typeface="Times New Roman" pitchFamily="34" charset="-122"/>
                 <a:cs typeface="Times New Roman" pitchFamily="34" charset="-120"/>
               </a:rPr>
-              <a:t>LTC is loan to cost and LTV is loan to value. Ratings are S&amp;P, Moody's, Fitch or KBRA as reported. Saline pricing is guidance and its LTC is derived from the reported 15% equity.</a:t>
+              <a:t>LTC is loan to cost and LTV is loan to value. Ratings are S&amp;P, Moody's, Fitch or KBRA as reported, and El Paso shows S&amp;P then Fitch. Saline LTC is derived from the reported 15% equity.</a:t>
             </a:r>
             <a:endParaRPr lang="en-US" sz="700" dirty="0"/>
           </a:p>
@@ -7500,7 +8317,7 @@
         </p:nvSpPr>
         <p:spPr>
           <a:xfrm>
-            <a:off x="557784" y="6903720"/>
+            <a:off x="557784" y="6684264"/>
             <a:ext cx="5742432" cy="347472"/>
           </a:xfrm>
           <a:prstGeom prst="rect">
@@ -7539,7 +8356,7 @@
         </p:nvSpPr>
         <p:spPr>
           <a:xfrm>
-            <a:off x="557784" y="7269480"/>
+            <a:off x="557784" y="7050024"/>
             <a:ext cx="5742432" cy="1828800"/>
           </a:xfrm>
           <a:prstGeom prst="rect">
@@ -7567,7 +8384,7 @@
                 <a:ea typeface="Times New Roman" pitchFamily="34" charset="-122"/>
                 <a:cs typeface="Times New Roman" pitchFamily="34" charset="-120"/>
               </a:rPr>
-              <a:t>The table shows that pricing tracks the lease counterparty more than the asset. Beacon Point, with a tenant rated AA- or better, priced at T+165 despite 95% leverage, while El Paso, with an A+ rating on Meta's lease, needed T+287.5 nine months after Hyperion priced at T+225. Below investment grade the step is larger, and CoreWeave linked paper now clears near 9.25% even on a secured basis. Hyperscaler corporate bonds are repricing as well. Amazon paid a new issue concession of 10 to 12bps on its $25bn July deal against a 2026 average near 4bps, and Meta's April deal priced its 2066 bonds at T+147 against T+110 for its October 2025 deal, on a book of $96bn versus $125bn. Oracle's $25bn February deal drew a record $129bn book, yet its 10 year priced near T+145 against roughly T+95 for BBB peers. The divergence is between steady demand for the largest tickets and a rising price for every notch of tenant risk.</a:t>
+              <a:t>The table shows that the tenant sets the starting point and tenor and timing set the rest. Beacon Point, with a tenant rated AA- or better and bonds that amortize to 2042, priced at T+165 despite 95% leverage. El Paso, with A+ rated notes backed by Meta's lease and a 2048 final maturity, needed T+287.5 nine months after Hyperion, by which time order books for hyperscaler debt had thinned. Below investment grade the step is larger, and CoreWeave linked paper now clears near 9.25% even on a secured basis. Hyperscaler corporate bonds are repricing as well. Amazon paid a new issue concession of 10 to 12bps on its $25bn July deal against a 2026 average near 4bps, and Meta's $25bn April deal drew a $96bn book against $125bn for its October 2025 deal. Oracle's $25bn February deal drew a $129bn book, yet its 10 year priced near T+145 while the US BBB index traded around T+95. The divergence is between steady demand for the largest tickets and a rising price for every notch of tenant risk.</a:t>
             </a:r>
             <a:endParaRPr lang="en-US" sz="1050" dirty="0"/>
           </a:p>
@@ -7817,7 +8634,7 @@
                 <a:ea typeface="Times New Roman" pitchFamily="34" charset="-122"/>
                 <a:cs typeface="Times New Roman" pitchFamily="34" charset="-120"/>
               </a:rPr>
-              <a:t>Oracle is the clearest test of what happens when the tenant weakens. S&amp;P cut Oracle to BBB- on July 9, citing OpenAI as about half of its contracted backlog and a projected fiscal 2027 free operating cash flow deficit of about $42bn. Oracle's September 10 results showed remaining performance obligations of $664bn, quarterly capex of $28.5bn against $8.5bn a year earlier, negative free cash flow of $5.4bn, and fiscal 2027 capex guidance of $90bn to $95bn. The strain has reached project debt. The $18bn construction loan on Project Jupiter, a 2.45 gigawatt campus in New Mexico developed by a Blue Owl unit and leased to Oracle, was quoted at 89 to 91 cents as banks struggled to sell it down. On September 24 Oracle sent the developer a force majeure notice after a gas pipeline slipped to February 2027, which could let it defer rent for up to three years. Oracle's long bonds yielded above 8% for the first time.</a:t>
+              <a:t>Oracle is the clearest test of what happens when the tenant weakens. S&amp;P cut Oracle to BBB- on July 9, citing OpenAI as about half of its contracted backlog and a projected fiscal 2027 free operating cash flow deficit of about $42bn, and said another downgrade is possible if leverage stays above 4.5x. Oracle's September 10 results showed remaining performance obligations of $664bn, quarterly capex of $28.5bn, and fiscal 2027 capex guidance of $90bn to $95bn. The strain has reached project debt. The $18bn construction loan on Project Jupiter, a 2.45 gigawatt New Mexico campus developed by a Blue Owl unit and leased to Oracle, was quoted at 89 to 91 cents in September, with syndicate banks holding more of it than planned. On September 24 Oracle sent the developer a force majeure notice after a gas pipeline slipped to February 2027, which could let it defer rent for up to three years. Oracle says the project is on schedule.</a:t>
             </a:r>
             <a:endParaRPr lang="en-US" sz="1050" dirty="0"/>
           </a:p>
@@ -7831,7 +8648,7 @@
         </p:nvSpPr>
         <p:spPr>
           <a:xfrm>
-            <a:off x="557784" y="3310128"/>
+            <a:off x="557784" y="3200400"/>
             <a:ext cx="2798064" cy="256032"/>
           </a:xfrm>
           <a:prstGeom prst="rect">
@@ -7870,8 +8687,8 @@
         </p:nvSpPr>
         <p:spPr>
           <a:xfrm>
-            <a:off x="557784" y="3602736"/>
-            <a:ext cx="2798064" cy="1581912"/>
+            <a:off x="557784" y="3493008"/>
+            <a:ext cx="2798064" cy="1645920"/>
           </a:xfrm>
           <a:prstGeom prst="rect">
             <a:avLst/>
@@ -7897,8 +8714,8 @@
         </p:nvSpPr>
         <p:spPr>
           <a:xfrm>
-            <a:off x="694944" y="3602736"/>
-            <a:ext cx="2523744" cy="1581912"/>
+            <a:off x="694944" y="3493008"/>
+            <a:ext cx="2523744" cy="1645920"/>
           </a:xfrm>
           <a:prstGeom prst="rect">
             <a:avLst/>
@@ -7953,7 +8770,7 @@
         </p:nvSpPr>
         <p:spPr>
           <a:xfrm>
-            <a:off x="3502152" y="3310128"/>
+            <a:off x="3502152" y="3200400"/>
             <a:ext cx="2798064" cy="256032"/>
           </a:xfrm>
           <a:prstGeom prst="rect">
@@ -7992,8 +8809,8 @@
         </p:nvSpPr>
         <p:spPr>
           <a:xfrm>
-            <a:off x="3502152" y="3602736"/>
-            <a:ext cx="2798064" cy="1581912"/>
+            <a:off x="3502152" y="3493008"/>
+            <a:ext cx="2798064" cy="1645920"/>
           </a:xfrm>
           <a:prstGeom prst="rect">
             <a:avLst/>
@@ -8019,8 +8836,8 @@
         </p:nvSpPr>
         <p:spPr>
           <a:xfrm>
-            <a:off x="3639312" y="3602736"/>
-            <a:ext cx="2523744" cy="1581912"/>
+            <a:off x="3639312" y="3493008"/>
+            <a:ext cx="2523744" cy="1645920"/>
           </a:xfrm>
           <a:prstGeom prst="rect">
             <a:avLst/>
@@ -8142,7 +8959,7 @@
                 <a:ea typeface="Times New Roman" pitchFamily="34" charset="-122"/>
                 <a:cs typeface="Times New Roman" pitchFamily="34" charset="-120"/>
               </a:rPr>
-              <a:t>Three risks sit beneath the pricing. Duration is the first, since four year initial leases support bonds amortizing over more than 20 years, and CoreWeave's August facility runs about five years against customer contracts averaging about three. Construction is the second, because rent does not begin until a campus is finished, leaving lenders exposed to power, permitting, and local opposition. Concentration is the third, with OpenAI behind about half of Oracle's backlog and OpenAI contracts backing two of CoreWeave's GPU facilities, so one counterparty links bank loans, project bonds, and GPU debt. The key divergence is that structures rated on a strong tenant now carry spreads that price a weaker one.</a:t>
+              <a:t>Three risks sit beneath the pricing. Duration is the first, since four year initial leases support bonds amortizing over more than 20 years, and CoreWeave's August facility runs about five years against customer contracts averaging about three. Construction is the second, because rent does not begin until a campus is finished, leaving lenders exposed to power, permitting, and local opposition. Concentration is the third, with OpenAI behind about half of Oracle's backlog and an OpenAI contract backing one of CoreWeave's GPU facilities, so one counterparty links bank loans, project bonds, and GPU debt. The key divergence is that structures rated on a strong tenant now carry spreads that price a weaker one.</a:t>
             </a:r>
             <a:endParaRPr lang="en-US" sz="1050" dirty="0"/>
           </a:p>
@@ -8262,7 +9079,7 @@
                 <a:ea typeface="Times New Roman" pitchFamily="34" charset="-122"/>
                 <a:cs typeface="Times New Roman" pitchFamily="34" charset="-120"/>
               </a:rPr>
-              <a:t>Meta's two joint ventures share one template, a four year initial lease, a capped residual value guarantee covering 16 years, and A+ rated amortizing bonds. Hyperion priced $27.3bn at 6.581%, or T+225, in October 2025. El Paso priced $12.5bn at 7.534%, or T+287.5, in July, with Fitch one notch higher at AA-. By late September Hyperion was trading in the low 90s, near T+230. Holders took a loss of close to ten points on paper whose credit never changed, which shows that long lease backed bonds carry rate and spread risk even when the tenant is strong.</a:t>
+              <a:t>Meta's two joint ventures share one template, a four year initial lease, a residual value guarantee covering the first 16 years, and A+ rated amortizing bonds. On Hyperion the guarantee totals about $28bn against $27.3bn of bonds, and rent begins in June 2029. Hyperion priced at 6.581%, or T+225, in October 2025. El Paso priced $12.5bn at 7.534%, or T+287.5, in July, with Fitch one notch higher at AA-. The 62.5bps wider spread on the same tenant shows that investors now price supply, structure, and timing on top of Meta's credit.</a:t>
             </a:r>
             <a:endParaRPr lang="en-US" sz="1050" dirty="0"/>
           </a:p>
@@ -8304,7 +9121,7 @@
                 <a:ea typeface="Times New Roman" pitchFamily="34" charset="-122"/>
                 <a:cs typeface="Times New Roman" pitchFamily="34" charset="-120"/>
               </a:rPr>
-              <a:t>CoreWeave borrows across the credit spectrum, and its pricing depends on who pays. Its $8.5bn DDTL 4.0, backed by GPUs serving Meta, is rated A3 by Moody's and priced at SOFR plus 225. DDTL 3.0, tied to OpenAI, priced at SOFR plus 400. The $3.1bn DDTL 5.0 in May priced at SOFR plus 450 with Ba2 and BB+ ratings, and the $2.6bn DDTL 5.5 in August priced at SOFR plus 550 at the same ratings. The company itself is rated B+ by S&amp;P. The 325bps gap between its best and worst secured loans is the market's price for counterparty risk.</a:t>
+              <a:t>CoreWeave's pricing depends on who pays. Its $8.5bn DDTL 4.0, backed by GPUs serving Meta, is rated A3 by Moody's and priced at SOFR plus 225. DDTL 3.0, tied to OpenAI, priced at SOFR plus 400. The $3.1bn DDTL 5.0 in May priced at SOFR plus 450 with Ba2 and BB+ ratings, and the $2.6bn DDTL 5.5 in August priced at SOFR plus 550 at the same ratings. The company itself is rated B+ by S&amp;P. The 325bps gap between its A3 and Ba2 facilities mostly prices counterparty risk, though the 100bps move between May and August shows timing matters too.</a:t>
             </a:r>
             <a:endParaRPr lang="en-US" sz="1050" dirty="0"/>
           </a:p>

</xml_diff>

<commit_message>
Committee v2 round 2: chart data update (A and C verified), footnote style fixes
Co-Authored-By: Claude Opus 5.5 <noreply@anthropic.com>
Claude-Session: https://claude.ai/code/session_011SJZihQQoizcK7ApWgRNEa
</commit_message>
<xml_diff>
--- a/outputs/LLC_AI_Infrastructure_Case_Study.pptx
+++ b/outputs/LLC_AI_Infrastructure_Case_Study.pptx
@@ -108,6 +108,581 @@
     </a:lvl9pPr>
   </p:defaultTextStyle>
 </p:presentation>
+</file>
+
+<file path=ppt/charts/chart1.xml><?xml version="1.0" encoding="utf-8"?>
+<c:chartSpace xmlns:c="http://schemas.openxmlformats.org/drawingml/2006/chart" xmlns:a="http://schemas.openxmlformats.org/drawingml/2006/main" xmlns:r="http://schemas.openxmlformats.org/officeDocument/2006/relationships">
+  <c:date1904 val="0"/>
+  <c:roundedCorners val="1"/>
+  <c:chart>
+    <c:autoTitleDeleted val="1"/>
+    <c:plotArea>
+      <c:layout/>
+      <c:barChart>
+        <c:barDir val="bar"/>
+        <c:grouping val="clustered"/>
+        <c:varyColors val="0"/>
+        <c:ser>
+          <c:idx val="0"/>
+          <c:order val="0"/>
+          <c:tx>
+            <c:strRef>
+              <c:f>Sheet1!$B$1</c:f>
+              <c:strCache>
+                <c:ptCount val="1"/>
+                <c:pt idx="0">
+                  <c:v>Project Bond Yields by Tenant (%)</c:v>
+                </c:pt>
+              </c:strCache>
+            </c:strRef>
+          </c:tx>
+          <c:spPr>
+            <a:solidFill>
+              <a:srgbClr val="9A3839"/>
+            </a:solidFill>
+            <a:effectLst/>
+          </c:spPr>
+          <c:invertIfNegative val="0"/>
+          <c:dLbls>
+            <c:numFmt formatCode="0.00" sourceLinked="0"/>
+            <c:txPr>
+              <a:bodyPr/>
+              <a:lstStyle/>
+              <a:p>
+                <a:pPr>
+                  <a:defRPr b="0" i="0" strike="noStrike" sz="800" u="none">
+                    <a:solidFill>
+                      <a:srgbClr val="000000"/>
+                    </a:solidFill>
+                    <a:latin typeface="Times New Roman"/>
+                  </a:defRPr>
+                </a:pPr>
+              </a:p>
+            </c:txPr>
+            <c:showLegendKey val="0"/>
+            <c:showVal val="1"/>
+            <c:showCatName val="0"/>
+            <c:showSerName val="0"/>
+            <c:showPercent val="0"/>
+            <c:showBubbleSize val="0"/>
+            <c:showLeaderLines val="0"/>
+          </c:dLbls>
+          <c:dPt>
+            <c:idx val="0"/>
+            <c:invertIfNegative val="0"/>
+            <c:bubble3D val="0"/>
+            <c:spPr>
+              <a:solidFill>
+                <a:srgbClr val="9A3839"/>
+              </a:solidFill>
+              <a:effectLst/>
+            </c:spPr>
+          </c:dPt>
+          <c:dPt>
+            <c:idx val="1"/>
+            <c:invertIfNegative val="0"/>
+            <c:bubble3D val="0"/>
+            <c:spPr>
+              <a:solidFill>
+                <a:srgbClr val="4F1D1B"/>
+              </a:solidFill>
+              <a:effectLst/>
+            </c:spPr>
+          </c:dPt>
+          <c:dPt>
+            <c:idx val="2"/>
+            <c:invertIfNegative val="0"/>
+            <c:bubble3D val="0"/>
+            <c:spPr>
+              <a:solidFill>
+                <a:srgbClr val="CD6661"/>
+              </a:solidFill>
+              <a:effectLst/>
+            </c:spPr>
+          </c:dPt>
+          <c:dPt>
+            <c:idx val="3"/>
+            <c:invertIfNegative val="0"/>
+            <c:bubble3D val="0"/>
+            <c:spPr>
+              <a:solidFill>
+                <a:srgbClr val="E0BCBC"/>
+              </a:solidFill>
+              <a:effectLst/>
+            </c:spPr>
+          </c:dPt>
+          <c:cat>
+            <c:multiLvlStrRef>
+              <c:f>Sheet1!$A$2:$A$5</c:f>
+              <c:multiLvlStrCache>
+                <c:ptCount val="4"/>
+                <c:lvl>
+                  <c:pt idx="0">
+                    <c:v>Beacon Point, AA- tenant (Jun 2026)</c:v>
+                  </c:pt>
+                  <c:pt idx="1">
+                    <c:v>Hyperion, Meta (Oct 2025)</c:v>
+                  </c:pt>
+                  <c:pt idx="2">
+                    <c:v>El Paso, Meta (Jul 2026)</c:v>
+                  </c:pt>
+                  <c:pt idx="3">
+                    <c:v>Digital Drive, CoreWeave (Sep 2026)</c:v>
+                  </c:pt>
+                </c:lvl>
+              </c:multiLvlStrCache>
+            </c:multiLvlStrRef>
+          </c:cat>
+          <c:val>
+            <c:numRef>
+              <c:f>Sheet1!$B$2:$B$5</c:f>
+              <c:numCache>
+                <c:formatCode>General</c:formatCode>
+                <c:ptCount val="4"/>
+                <c:pt idx="0">
+                  <c:v>6.129</c:v>
+                </c:pt>
+                <c:pt idx="1">
+                  <c:v>6.581</c:v>
+                </c:pt>
+                <c:pt idx="2">
+                  <c:v>7.534</c:v>
+                </c:pt>
+                <c:pt idx="3">
+                  <c:v>9.25</c:v>
+                </c:pt>
+              </c:numCache>
+            </c:numRef>
+          </c:val>
+        </c:ser>
+        <c:dLbls>
+          <c:numFmt formatCode="0.00" sourceLinked="0"/>
+          <c:txPr>
+            <a:bodyPr/>
+            <a:lstStyle/>
+            <a:p>
+              <a:pPr>
+                <a:defRPr b="0" i="0" strike="noStrike" sz="800" u="none">
+                  <a:solidFill>
+                    <a:srgbClr val="000000"/>
+                  </a:solidFill>
+                  <a:latin typeface="Times New Roman"/>
+                </a:defRPr>
+              </a:pPr>
+            </a:p>
+          </c:txPr>
+          <c:showLegendKey val="0"/>
+          <c:showVal val="1"/>
+          <c:showCatName val="0"/>
+          <c:showSerName val="0"/>
+          <c:showPercent val="0"/>
+          <c:showBubbleSize val="0"/>
+          <c:showLeaderLines val="0"/>
+        </c:dLbls>
+        <c:gapWidth val="60"/>
+        <c:overlap val="0"/>
+        <c:axId val="2094734554"/>
+        <c:axId val="2094734552"/>
+        <c:axId val="2094734556"/>
+      </c:barChart>
+      <c:catAx>
+        <c:axId val="2094734554"/>
+        <c:scaling>
+          <c:orientation val="maxMin"/>
+        </c:scaling>
+        <c:delete val="0"/>
+        <c:axPos val="l"/>
+        <c:numFmt formatCode="General" sourceLinked="1"/>
+        <c:majorTickMark val="out"/>
+        <c:minorTickMark val="none"/>
+        <c:tickLblPos val="nextTo"/>
+        <c:spPr>
+          <a:ln w="12700" cap="flat">
+            <a:solidFill>
+              <a:srgbClr val="888888"/>
+            </a:solidFill>
+            <a:prstDash val="solid"/>
+            <a:round/>
+          </a:ln>
+        </c:spPr>
+        <c:txPr>
+          <a:bodyPr/>
+          <a:lstStyle/>
+          <a:p>
+            <a:pPr>
+              <a:defRPr sz="800" b="0" i="0" u="none" strike="noStrike">
+                <a:solidFill>
+                  <a:srgbClr val="000000"/>
+                </a:solidFill>
+                <a:latin typeface="Times New Roman"/>
+              </a:defRPr>
+            </a:pPr>
+            <a:endParaRPr lang="en-US"/>
+          </a:p>
+        </c:txPr>
+        <c:crossAx val="2094734552"/>
+        <c:crosses val="autoZero"/>
+        <c:auto val="1"/>
+        <c:lblAlgn val="ctr"/>
+        <c:noMultiLvlLbl val="1"/>
+      </c:catAx>
+      <c:valAx>
+        <c:axId val="2094734552"/>
+        <c:scaling>
+          <c:orientation val="minMax"/>
+        </c:scaling>
+        <c:delete val="1"/>
+        <c:axPos val="b"/>
+        <c:numFmt formatCode="General" sourceLinked="0"/>
+        <c:majorTickMark val="out"/>
+        <c:minorTickMark val="none"/>
+        <c:tickLblPos val="low"/>
+        <c:spPr>
+          <a:ln w="12700" cap="flat">
+            <a:solidFill>
+              <a:srgbClr val="888888"/>
+            </a:solidFill>
+            <a:prstDash val="solid"/>
+            <a:round/>
+          </a:ln>
+        </c:spPr>
+        <c:txPr>
+          <a:bodyPr/>
+          <a:lstStyle/>
+          <a:p>
+            <a:pPr>
+              <a:defRPr sz="800" b="0" i="0" u="none" strike="noStrike">
+                <a:solidFill>
+                  <a:srgbClr val="000000"/>
+                </a:solidFill>
+                <a:latin typeface="Times New Roman"/>
+              </a:defRPr>
+            </a:pPr>
+            <a:endParaRPr lang="en-US"/>
+          </a:p>
+        </c:txPr>
+        <c:crossAx val="2094734554"/>
+        <c:crosses val="autoZero"/>
+        <c:crossBetween val="between"/>
+      </c:valAx>
+      <c:spPr>
+        <a:noFill/>
+        <a:ln>
+          <a:noFill/>
+        </a:ln>
+        <a:effectLst/>
+      </c:spPr>
+    </c:plotArea>
+    <c:plotVisOnly val="1"/>
+    <c:dispBlanksAs val="span"/>
+  </c:chart>
+  <c:spPr>
+    <a:noFill/>
+    <a:ln>
+      <a:noFill/>
+    </a:ln>
+    <a:effectLst/>
+  </c:spPr>
+  <c:externalData r:id="rId1">
+    <c:autoUpdate val="0"/>
+  </c:externalData>
+</c:chartSpace>
+</file>
+
+<file path=ppt/charts/chart2.xml><?xml version="1.0" encoding="utf-8"?>
+<c:chartSpace xmlns:c="http://schemas.openxmlformats.org/drawingml/2006/chart" xmlns:a="http://schemas.openxmlformats.org/drawingml/2006/main" xmlns:r="http://schemas.openxmlformats.org/officeDocument/2006/relationships">
+  <c:date1904 val="0"/>
+  <c:roundedCorners val="1"/>
+  <c:chart>
+    <c:autoTitleDeleted val="1"/>
+    <c:plotArea>
+      <c:layout/>
+      <c:barChart>
+        <c:barDir val="bar"/>
+        <c:grouping val="clustered"/>
+        <c:varyColors val="0"/>
+        <c:ser>
+          <c:idx val="0"/>
+          <c:order val="0"/>
+          <c:tx>
+            <c:strRef>
+              <c:f>Sheet1!$B$1</c:f>
+              <c:strCache>
+                <c:ptCount val="1"/>
+                <c:pt idx="0">
+                  <c:v>GPU Loan Spreads (bps over SOFR)</c:v>
+                </c:pt>
+              </c:strCache>
+            </c:strRef>
+          </c:tx>
+          <c:spPr>
+            <a:solidFill>
+              <a:srgbClr val="9A3839"/>
+            </a:solidFill>
+            <a:effectLst/>
+          </c:spPr>
+          <c:invertIfNegative val="0"/>
+          <c:dLbls>
+            <c:numFmt formatCode="0" sourceLinked="0"/>
+            <c:txPr>
+              <a:bodyPr/>
+              <a:lstStyle/>
+              <a:p>
+                <a:pPr>
+                  <a:defRPr b="0" i="0" strike="noStrike" sz="800" u="none">
+                    <a:solidFill>
+                      <a:srgbClr val="000000"/>
+                    </a:solidFill>
+                    <a:latin typeface="Times New Roman"/>
+                  </a:defRPr>
+                </a:pPr>
+              </a:p>
+            </c:txPr>
+            <c:showLegendKey val="0"/>
+            <c:showVal val="1"/>
+            <c:showCatName val="0"/>
+            <c:showSerName val="0"/>
+            <c:showPercent val="0"/>
+            <c:showBubbleSize val="0"/>
+            <c:showLeaderLines val="0"/>
+          </c:dLbls>
+          <c:dPt>
+            <c:idx val="0"/>
+            <c:invertIfNegative val="0"/>
+            <c:bubble3D val="0"/>
+            <c:spPr>
+              <a:solidFill>
+                <a:srgbClr val="9A3839"/>
+              </a:solidFill>
+              <a:effectLst/>
+            </c:spPr>
+          </c:dPt>
+          <c:dPt>
+            <c:idx val="1"/>
+            <c:invertIfNegative val="0"/>
+            <c:bubble3D val="0"/>
+            <c:spPr>
+              <a:solidFill>
+                <a:srgbClr val="4F1D1B"/>
+              </a:solidFill>
+              <a:effectLst/>
+            </c:spPr>
+          </c:dPt>
+          <c:dPt>
+            <c:idx val="2"/>
+            <c:invertIfNegative val="0"/>
+            <c:bubble3D val="0"/>
+            <c:spPr>
+              <a:solidFill>
+                <a:srgbClr val="CD6661"/>
+              </a:solidFill>
+              <a:effectLst/>
+            </c:spPr>
+          </c:dPt>
+          <c:dPt>
+            <c:idx val="3"/>
+            <c:invertIfNegative val="0"/>
+            <c:bubble3D val="0"/>
+            <c:spPr>
+              <a:solidFill>
+                <a:srgbClr val="E0BCBC"/>
+              </a:solidFill>
+              <a:effectLst/>
+            </c:spPr>
+          </c:dPt>
+          <c:dPt>
+            <c:idx val="4"/>
+            <c:invertIfNegative val="0"/>
+            <c:bubble3D val="0"/>
+            <c:spPr>
+              <a:solidFill>
+                <a:srgbClr val="7A2A28"/>
+              </a:solidFill>
+              <a:effectLst/>
+            </c:spPr>
+          </c:dPt>
+          <c:cat>
+            <c:multiLvlStrRef>
+              <c:f>Sheet1!$A$2:$A$6</c:f>
+              <c:multiLvlStrCache>
+                <c:ptCount val="5"/>
+                <c:lvl>
+                  <c:pt idx="0">
+                    <c:v>CoreWeave DDTL 4.0, Meta (A3)</c:v>
+                  </c:pt>
+                  <c:pt idx="1">
+                    <c:v>Lambda TLB, IG offtaker (Baa2)</c:v>
+                  </c:pt>
+                  <c:pt idx="2">
+                    <c:v>CoreWeave DDTL 3.0, OpenAI</c:v>
+                  </c:pt>
+                  <c:pt idx="3">
+                    <c:v>CoreWeave DDTL 5.0 (Ba2)</c:v>
+                  </c:pt>
+                  <c:pt idx="4">
+                    <c:v>CoreWeave DDTL 5.5 (Ba2)</c:v>
+                  </c:pt>
+                </c:lvl>
+              </c:multiLvlStrCache>
+            </c:multiLvlStrRef>
+          </c:cat>
+          <c:val>
+            <c:numRef>
+              <c:f>Sheet1!$B$2:$B$6</c:f>
+              <c:numCache>
+                <c:formatCode>General</c:formatCode>
+                <c:ptCount val="5"/>
+                <c:pt idx="0">
+                  <c:v>225</c:v>
+                </c:pt>
+                <c:pt idx="1">
+                  <c:v>300</c:v>
+                </c:pt>
+                <c:pt idx="2">
+                  <c:v>400</c:v>
+                </c:pt>
+                <c:pt idx="3">
+                  <c:v>450</c:v>
+                </c:pt>
+                <c:pt idx="4">
+                  <c:v>550</c:v>
+                </c:pt>
+              </c:numCache>
+            </c:numRef>
+          </c:val>
+        </c:ser>
+        <c:dLbls>
+          <c:numFmt formatCode="0" sourceLinked="0"/>
+          <c:txPr>
+            <a:bodyPr/>
+            <a:lstStyle/>
+            <a:p>
+              <a:pPr>
+                <a:defRPr b="0" i="0" strike="noStrike" sz="800" u="none">
+                  <a:solidFill>
+                    <a:srgbClr val="000000"/>
+                  </a:solidFill>
+                  <a:latin typeface="Times New Roman"/>
+                </a:defRPr>
+              </a:pPr>
+            </a:p>
+          </c:txPr>
+          <c:showLegendKey val="0"/>
+          <c:showVal val="1"/>
+          <c:showCatName val="0"/>
+          <c:showSerName val="0"/>
+          <c:showPercent val="0"/>
+          <c:showBubbleSize val="0"/>
+          <c:showLeaderLines val="0"/>
+        </c:dLbls>
+        <c:gapWidth val="60"/>
+        <c:overlap val="0"/>
+        <c:axId val="2094734554"/>
+        <c:axId val="2094734552"/>
+        <c:axId val="2094734556"/>
+      </c:barChart>
+      <c:catAx>
+        <c:axId val="2094734554"/>
+        <c:scaling>
+          <c:orientation val="maxMin"/>
+        </c:scaling>
+        <c:delete val="0"/>
+        <c:axPos val="l"/>
+        <c:numFmt formatCode="General" sourceLinked="1"/>
+        <c:majorTickMark val="out"/>
+        <c:minorTickMark val="none"/>
+        <c:tickLblPos val="nextTo"/>
+        <c:spPr>
+          <a:ln w="12700" cap="flat">
+            <a:solidFill>
+              <a:srgbClr val="888888"/>
+            </a:solidFill>
+            <a:prstDash val="solid"/>
+            <a:round/>
+          </a:ln>
+        </c:spPr>
+        <c:txPr>
+          <a:bodyPr/>
+          <a:lstStyle/>
+          <a:p>
+            <a:pPr>
+              <a:defRPr sz="800" b="0" i="0" u="none" strike="noStrike">
+                <a:solidFill>
+                  <a:srgbClr val="000000"/>
+                </a:solidFill>
+                <a:latin typeface="Times New Roman"/>
+              </a:defRPr>
+            </a:pPr>
+            <a:endParaRPr lang="en-US"/>
+          </a:p>
+        </c:txPr>
+        <c:crossAx val="2094734552"/>
+        <c:crosses val="autoZero"/>
+        <c:auto val="1"/>
+        <c:lblAlgn val="ctr"/>
+        <c:noMultiLvlLbl val="1"/>
+      </c:catAx>
+      <c:valAx>
+        <c:axId val="2094734552"/>
+        <c:scaling>
+          <c:orientation val="minMax"/>
+        </c:scaling>
+        <c:delete val="1"/>
+        <c:axPos val="b"/>
+        <c:numFmt formatCode="General" sourceLinked="0"/>
+        <c:majorTickMark val="out"/>
+        <c:minorTickMark val="none"/>
+        <c:tickLblPos val="low"/>
+        <c:spPr>
+          <a:ln w="12700" cap="flat">
+            <a:solidFill>
+              <a:srgbClr val="888888"/>
+            </a:solidFill>
+            <a:prstDash val="solid"/>
+            <a:round/>
+          </a:ln>
+        </c:spPr>
+        <c:txPr>
+          <a:bodyPr/>
+          <a:lstStyle/>
+          <a:p>
+            <a:pPr>
+              <a:defRPr sz="800" b="0" i="0" u="none" strike="noStrike">
+                <a:solidFill>
+                  <a:srgbClr val="000000"/>
+                </a:solidFill>
+                <a:latin typeface="Times New Roman"/>
+              </a:defRPr>
+            </a:pPr>
+            <a:endParaRPr lang="en-US"/>
+          </a:p>
+        </c:txPr>
+        <c:crossAx val="2094734554"/>
+        <c:crosses val="autoZero"/>
+        <c:crossBetween val="between"/>
+      </c:valAx>
+      <c:spPr>
+        <a:noFill/>
+        <a:ln>
+          <a:noFill/>
+        </a:ln>
+        <a:effectLst/>
+      </c:spPr>
+    </c:plotArea>
+    <c:plotVisOnly val="1"/>
+    <c:dispBlanksAs val="span"/>
+  </c:chart>
+  <c:spPr>
+    <a:noFill/>
+    <a:ln>
+      <a:noFill/>
+    </a:ln>
+    <a:effectLst/>
+  </c:spPr>
+  <c:externalData r:id="rId1">
+    <c:autoUpdate val="0"/>
+  </c:externalData>
+</c:chartSpace>
 </file>
 
 <file path=ppt/notesMasters/notesMaster1.xml><?xml version="1.0" encoding="utf-8"?>
@@ -8679,43 +9254,32 @@
           </a:p>
         </p:txBody>
       </p:sp>
+      <p:graphicFrame>
+        <p:nvGraphicFramePr>
+          <p:cNvPr id="8" name="Chart 0" descr=""/>
+          <p:cNvGraphicFramePr/>
+          <p:nvPr/>
+        </p:nvGraphicFramePr>
+        <p:xfrm>
+          <a:off x="557784" y="3493008"/>
+          <a:ext cx="2798064" cy="1371600"/>
+        </p:xfrm>
+        <a:graphic xmlns:a="http://schemas.openxmlformats.org/drawingml/2006/main">
+          <a:graphicData uri="http://schemas.openxmlformats.org/drawingml/2006/chart">
+            <c:chart xmlns:c="http://schemas.openxmlformats.org/drawingml/2006/chart" r:id="rId1"/>
+          </a:graphicData>
+        </a:graphic>
+      </p:graphicFrame>
       <p:sp>
         <p:nvSpPr>
-          <p:cNvPr id="8" name="Chart placeholder C"/>
-          <p:cNvSpPr/>
-          <p:nvPr/>
-        </p:nvSpPr>
-        <p:spPr>
-          <a:xfrm>
-            <a:off x="557784" y="3493008"/>
-            <a:ext cx="2798064" cy="1645920"/>
-          </a:xfrm>
-          <a:prstGeom prst="rect">
-            <a:avLst/>
-          </a:prstGeom>
-          <a:solidFill>
-            <a:srgbClr val="FFFFFF">
-              <a:alpha val="65000"/>
-            </a:srgbClr>
-          </a:solidFill>
-          <a:ln w="12700">
-            <a:solidFill>
-              <a:srgbClr val="9B3739"/>
-            </a:solidFill>
-            <a:prstDash val="dash"/>
-          </a:ln>
-        </p:spPr>
-      </p:sp>
-      <p:sp>
-        <p:nvSpPr>
-          <p:cNvPr id="9" name="Chart placeholder text C"/>
+          <p:cNvPr id="9" name="Chart footnote C"/>
           <p:cNvSpPr txBox="1"/>
           <p:nvPr/>
         </p:nvSpPr>
         <p:spPr>
           <a:xfrm>
-            <a:off x="694944" y="3493008"/>
-            <a:ext cx="2523744" cy="1645920"/>
+            <a:off x="557784" y="4882896"/>
+            <a:ext cx="2798064" cy="237744"/>
           </a:xfrm>
           <a:prstGeom prst="rect">
             <a:avLst/>
@@ -8724,41 +9288,24 @@
           <a:ln/>
         </p:spPr>
         <p:txBody>
-          <a:bodyPr wrap="square" lIns="0" tIns="0" rIns="0" bIns="0" rtlCol="0" anchor="ctr"/>
+          <a:bodyPr wrap="square" lIns="0" tIns="0" rIns="0" bIns="0" rtlCol="0" anchor="t"/>
           <a:lstStyle/>
           <a:p>
-            <a:pPr algn="ctr" indent="0" marL="0">
+            <a:pPr indent="0" marL="0">
               <a:buNone/>
             </a:pPr>
             <a:r>
-              <a:rPr lang="en-US" sz="1100" b="1" dirty="0">
+              <a:rPr lang="en-US" sz="700" i="1" dirty="0">
                 <a:solidFill>
-                  <a:srgbClr val="9B3739"/>
+                  <a:srgbClr val="000000"/>
                 </a:solidFill>
                 <a:latin typeface="Times New Roman" pitchFamily="34" charset="0"/>
                 <a:ea typeface="Times New Roman" pitchFamily="34" charset="-122"/>
                 <a:cs typeface="Times New Roman" pitchFamily="34" charset="-120"/>
               </a:rPr>
-              <a:t>Insert chart</a:t>
+              <a:t>Yield at issue. Spreads were T+165, T+225 and T+287.5 for the first three. Yields span Oct 2025 to Sep 2026 and Treasury yields moved in between (the 10 year rose about a point), so spreads are the fair comparison.</a:t>
             </a:r>
-            <a:endParaRPr lang="en-US" sz="1100" dirty="0"/>
-          </a:p>
-          <a:p>
-            <a:pPr algn="ctr" indent="0" marL="0">
-              <a:buNone/>
-            </a:pPr>
-            <a:r>
-              <a:rPr lang="en-US" sz="900" i="1" dirty="0">
-                <a:solidFill>
-                  <a:srgbClr val="9B3739"/>
-                </a:solidFill>
-                <a:latin typeface="Times New Roman" pitchFamily="34" charset="0"/>
-                <a:ea typeface="Times New Roman" pitchFamily="34" charset="-122"/>
-                <a:cs typeface="Times New Roman" pitchFamily="34" charset="-120"/>
-              </a:rPr>
-              <a:t>Beacon Point, Hyperion, El Paso, Digital Drive</a:t>
-            </a:r>
-            <a:endParaRPr lang="en-US" sz="1100" dirty="0"/>
+            <a:endParaRPr lang="en-US" sz="700" dirty="0"/>
           </a:p>
         </p:txBody>
       </p:sp>
@@ -8801,43 +9348,32 @@
           </a:p>
         </p:txBody>
       </p:sp>
+      <p:graphicFrame>
+        <p:nvGraphicFramePr>
+          <p:cNvPr id="11" name="Chart 1" descr=""/>
+          <p:cNvGraphicFramePr/>
+          <p:nvPr/>
+        </p:nvGraphicFramePr>
+        <p:xfrm>
+          <a:off x="3502152" y="3493008"/>
+          <a:ext cx="2798064" cy="1371600"/>
+        </p:xfrm>
+        <a:graphic xmlns:a="http://schemas.openxmlformats.org/drawingml/2006/main">
+          <a:graphicData uri="http://schemas.openxmlformats.org/drawingml/2006/chart">
+            <c:chart xmlns:c="http://schemas.openxmlformats.org/drawingml/2006/chart" r:id="rId2"/>
+          </a:graphicData>
+        </a:graphic>
+      </p:graphicFrame>
       <p:sp>
         <p:nvSpPr>
-          <p:cNvPr id="11" name="Chart placeholder A"/>
-          <p:cNvSpPr/>
-          <p:nvPr/>
-        </p:nvSpPr>
-        <p:spPr>
-          <a:xfrm>
-            <a:off x="3502152" y="3493008"/>
-            <a:ext cx="2798064" cy="1645920"/>
-          </a:xfrm>
-          <a:prstGeom prst="rect">
-            <a:avLst/>
-          </a:prstGeom>
-          <a:solidFill>
-            <a:srgbClr val="FFFFFF">
-              <a:alpha val="65000"/>
-            </a:srgbClr>
-          </a:solidFill>
-          <a:ln w="12700">
-            <a:solidFill>
-              <a:srgbClr val="9B3739"/>
-            </a:solidFill>
-            <a:prstDash val="dash"/>
-          </a:ln>
-        </p:spPr>
-      </p:sp>
-      <p:sp>
-        <p:nvSpPr>
-          <p:cNvPr id="12" name="Chart placeholder text A"/>
+          <p:cNvPr id="12" name="Chart footnote A"/>
           <p:cNvSpPr txBox="1"/>
           <p:nvPr/>
         </p:nvSpPr>
         <p:spPr>
           <a:xfrm>
-            <a:off x="3639312" y="3493008"/>
-            <a:ext cx="2523744" cy="1645920"/>
+            <a:off x="3502152" y="4882896"/>
+            <a:ext cx="2798064" cy="237744"/>
           </a:xfrm>
           <a:prstGeom prst="rect">
             <a:avLst/>
@@ -8846,41 +9382,24 @@
           <a:ln/>
         </p:spPr>
         <p:txBody>
-          <a:bodyPr wrap="square" lIns="0" tIns="0" rIns="0" bIns="0" rtlCol="0" anchor="ctr"/>
+          <a:bodyPr wrap="square" lIns="0" tIns="0" rIns="0" bIns="0" rtlCol="0" anchor="t"/>
           <a:lstStyle/>
           <a:p>
-            <a:pPr algn="ctr" indent="0" marL="0">
+            <a:pPr indent="0" marL="0">
               <a:buNone/>
             </a:pPr>
             <a:r>
-              <a:rPr lang="en-US" sz="1100" b="1" dirty="0">
+              <a:rPr lang="en-US" sz="700" i="1" dirty="0">
                 <a:solidFill>
-                  <a:srgbClr val="9B3739"/>
+                  <a:srgbClr val="000000"/>
                 </a:solidFill>
                 <a:latin typeface="Times New Roman" pitchFamily="34" charset="0"/>
                 <a:ea typeface="Times New Roman" pitchFamily="34" charset="-122"/>
                 <a:cs typeface="Times New Roman" pitchFamily="34" charset="-120"/>
               </a:rPr>
-              <a:t>Insert chart</a:t>
+              <a:t>Margin over SOFR at closing.</a:t>
             </a:r>
-            <a:endParaRPr lang="en-US" sz="1100" dirty="0"/>
-          </a:p>
-          <a:p>
-            <a:pPr algn="ctr" indent="0" marL="0">
-              <a:buNone/>
-            </a:pPr>
-            <a:r>
-              <a:rPr lang="en-US" sz="900" i="1" dirty="0">
-                <a:solidFill>
-                  <a:srgbClr val="9B3739"/>
-                </a:solidFill>
-                <a:latin typeface="Times New Roman" pitchFamily="34" charset="0"/>
-                <a:ea typeface="Times New Roman" pitchFamily="34" charset="-122"/>
-                <a:cs typeface="Times New Roman" pitchFamily="34" charset="-120"/>
-              </a:rPr>
-              <a:t>CoreWeave DDTL 4.0, Lambda, DDTL 3.0, 5.0, 5.5</a:t>
-            </a:r>
-            <a:endParaRPr lang="en-US" sz="1100" dirty="0"/>
+            <a:endParaRPr lang="en-US" sz="700" dirty="0"/>
           </a:p>
         </p:txBody>
       </p:sp>

</xml_diff>

<commit_message>
Committee v2 round 2: apply style redlines and rebuild
Co-Authored-By: Claude Opus 5.5 <noreply@anthropic.com>
Claude-Session: https://claude.ai/code/session_011SJZihQQoizcK7ApWgRNEa
</commit_message>
<xml_diff>
--- a/outputs/LLC_AI_Infrastructure_Case_Study.pptx
+++ b/outputs/LLC_AI_Infrastructure_Case_Study.pptx
@@ -2373,7 +2373,7 @@
                 <a:ea typeface="Times New Roman" pitchFamily="34" charset="-122"/>
                 <a:cs typeface="Times New Roman" pitchFamily="34" charset="-120"/>
               </a:rPr>
-              <a:t>AI infrastructure financing is the debt raised to build data centers and the computing equipment inside them, and in 2026 it has become one of the largest sources of new supply in credit. Lenders reach the same assets through five routes. Hyperscalers borrow directly in the investment grade market. Joint ventures issue project bonds secured by a lease to a hyperscaler, as with Meta's $27.3bn Hyperion financing, where Blue Owl owns 80% of the vehicle and the A+ rated bonds amortize to 2049. Developers take construction loans against leases to Oracle and OpenAI. Neoclouds such as CoreWeave borrow against GPUs and the customer contracts that pay for them. Stabilized campuses are refinanced through data center ABS and CMBS. In every route the lender is underwriting the tenant, and agencies start from the tenant's rating and subtract notches for construction, lease length, and operator risk.</a:t>
+              <a:t>AI infrastructure financing is the debt raised to build data centers and the computing equipment inside them, and in 2026 it has become one of the largest sources of new supply in credit. Lenders reach the same assets through five routes. Hyperscalers borrow directly in the investment grade market on their corporate ratings. Joint ventures issue project bonds secured by a lease to a hyperscaler, as with Meta's $27.3bn Hyperion financing, where Blue Owl owns 80% of the vehicle and the A+ rated bonds amortize to 2049. Developers take construction loans against leases to Oracle and OpenAI, before any rent is paid. Neoclouds such as CoreWeave borrow against GPUs and the customer contracts that pay for them. Stabilized campuses are refinanced through data center ABS and CMBS once rent is flowing. In every route the lender is underwriting the tenant, and agencies start from the tenant's rating and subtract notches for construction, lease length, and operator risk.</a:t>
             </a:r>
             <a:endParaRPr lang="en-US" sz="1050" dirty="0"/>
           </a:p>
@@ -2454,7 +2454,7 @@
                 <a:ea typeface="Times New Roman" pitchFamily="34" charset="-122"/>
                 <a:cs typeface="Times New Roman" pitchFamily="34" charset="-120"/>
               </a:rPr>
-              <a:t>Lease backed debt is sized so that contracted rent covers debt service with a thin cushion and the bonds amortize before the lease and its renewals run out, so leverage rises with the strength of the tenant. Hut 8's $4.25bn Beacon Point bonds, backed by a tenant rated AA- or better, financed 95% of project cost at T+165, which Hut 8 calls the highest loan to cost for an HPC data center bond. Oracle's Saline Township campus in Michigan raised about $14bn of bonds against $16.3bn of cost, leaving roughly 15% equity. Stabilized campuses are sized on appraised value, and Aligned's ABS master trust, which added $1.18bn in July, caps its senior notes at 70% of appraised value. GPU lenders lend less because the collateral depreciates, and Apollo's $3.5bn for the vehicle that leases chips to xAI equals about 65% of a $5.4bn purchase. Agencies stress all of these. KBRA cut the cash flow on the single tenant Ohio campus behind BX 2026 VLT10 to 18.9% below the issuer's figure and its value to 27.2% below appraisal, lifting leverage on the $1.26bn loan to 108.4%.</a:t>
+              <a:t>Lease backed debt is sized so contracted rent covers debt service with a thin cushion and bonds amortize before the lease and its renewals run out, so leverage rises with tenant strength. Hut 8's $4.25bn Beacon Point bonds, backed by a tenant rated AA- or better, financed 95% of project cost at T+165, which Hut 8 calls the highest loan to cost for an HPC data center bond. Oracle's Saline Township campus in Michigan raised about $14bn of bonds against $16.3bn of cost, or roughly 15% equity. Stabilized campuses are sized on value, and Aligned's ABS master trust, which added $1.18bn in July, caps senior notes at 70% of appraised value. GPU lenders lend less against depreciating collateral, and Apollo's $3.5bn for the xAI chip leasing vehicle equals about 65% of a $5.4bn purchase. KBRA cut the cash flow on the single tenant Ohio campus behind BX 2026 VLT10 to 18.9% below the issuer's figure and its value to 27.2% below appraisal, lifting leverage on the $1.26bn loan to 108.4%.</a:t>
             </a:r>
             <a:endParaRPr lang="en-US" sz="1050" dirty="0"/>
           </a:p>
@@ -2535,7 +2535,7 @@
                 <a:ea typeface="Times New Roman" pitchFamily="34" charset="-122"/>
                 <a:cs typeface="Times New Roman" pitchFamily="34" charset="-120"/>
               </a:rPr>
-              <a:t>The debt is only as long as the lease behind it, and hyperscaler leases are short. Hyperion and El Paso both carry four year initial terms against bonds amortizing to 2049 and 2048, and Meta's residual value guarantee on Hyperion, about $28bn and covering the first 16 years, is what bridges the gap. Moody's counted $662bn of hyperscaler data center leases not yet commenced at the end of 2025, held off balance sheet and equal to 113% of their adjusted debt, and says it will treat part of them as debt, while S&amp;P accepted Hyperion as off balance sheet for Meta. The divergence is that one obligation is a lease to one agency and debt to another, and any tenant downgrade passes straight through to the structures built on it.</a:t>
+              <a:t>The debt is only as long as the lease behind it, and hyperscaler leases are short. Hyperion and El Paso both carry four year initial terms against bonds amortizing to 2049 and 2048, and Meta's residual value guarantee on Hyperion, about $28bn and covering the first 16 years, bridges the gap. Moody's counted $662bn of hyperscaler data center leases not yet commenced at the end of 2025, held off balance sheet and equal to 113% of their adjusted debt, and says it will treat part as debt, while S&amp;P accepted Hyperion as off balance sheet for Meta. The divergence is that one obligation is a lease to one agency and debt to another, so a tenant downgrade passes straight through.</a:t>
             </a:r>
             <a:endParaRPr lang="en-US" sz="1050" dirty="0"/>
           </a:p>
@@ -3029,7 +3029,7 @@
                 <a:ea typeface="Times New Roman" pitchFamily="34" charset="-122"/>
                 <a:cs typeface="Times New Roman" pitchFamily="34" charset="-120"/>
               </a:rPr>
-              <a:t>Investors are still funding the buildout, but they are charging more for it. Apollo estimates that order cover on hyperscaler bonds fell from about five times in February to below two times by July. Meta's El Paso joint venture priced $12.5bn of A+ rated amortizing notes on July 27 at 7.534%, or T+287.5, with orders peaking near $20bn, about 1.6 times the deal, while the average bond sale this year drew close to four times. That was 62.5bps wider than Hyperion's T+225 in October 2025 on the same tenant, rating, and template. On September 23 a Blue Owl affiliated campus in Virginia leased to CoreWeave sold $1.1bn of BB- rated five year notes at 98.5 to yield 9.25%, about 270bps above similarly rated debt. GPU loans show the same split. CoreWeave borrowed at SOFR plus 225 in March on an A3 rated facility backed by its Meta contract, then paid SOFR plus 550 in August on a Ba2 facility, 100bps wider than its May loan at the same ratings.</a:t>
+              <a:t>Investors keep funding the buildout but charging more for it. Apollo estimates order cover on hyperscaler bonds fell from about five times in February to below two times by July. Meta's El Paso joint venture priced $12.5bn of A+ rated amortizing notes on July 27 at 7.534%, or T+287.5, with orders peaking near $20bn, about 1.6 times the deal, while the average bond sale this year drew close to four times. That was 62.5bps wider than Hyperion's T+225 in October 2025 on the same tenant, rating, and template. On September 23 a Blue Owl affiliated campus in Virginia leased to CoreWeave sold $1.1bn of BB- rated five year notes at 98.5 to yield 9.25%, about 270bps above similarly rated debt. GPU loans split the same way. CoreWeave borrowed at SOFR plus 225 in March on an A3 rated facility backed by its Meta contract, then paid SOFR plus 550 in August on a Ba2 facility, 100bps wider than its May loan at the same ratings.</a:t>
             </a:r>
             <a:endParaRPr lang="en-US" sz="1050" dirty="0"/>
           </a:p>
@@ -8959,7 +8959,7 @@
                 <a:ea typeface="Times New Roman" pitchFamily="34" charset="-122"/>
                 <a:cs typeface="Times New Roman" pitchFamily="34" charset="-120"/>
               </a:rPr>
-              <a:t>The table shows that the tenant sets the starting point and tenor and timing set the rest. Beacon Point, with a tenant rated AA- or better and bonds that amortize to 2042, priced at T+165 despite 95% leverage. El Paso, with A+ rated notes backed by Meta's lease and a 2048 final maturity, needed T+287.5 nine months after Hyperion, by which time order books for hyperscaler debt had thinned. Below investment grade the step is larger, and CoreWeave linked paper now clears near 9.25% even on a secured basis. Hyperscaler corporate bonds are repricing as well. Amazon paid a new issue concession of 10 to 12bps on its $25bn July deal against a 2026 average near 4bps, and Meta's $25bn April deal drew a $96bn book against $125bn for its October 2025 deal. Oracle's $25bn February deal drew a $129bn book, yet its 10 year priced near T+145 while the US BBB index traded around T+95. The divergence is between steady demand for the largest tickets and a rising price for every notch of tenant risk.</a:t>
+              <a:t>The tenant sets the starting point, and tenor and timing set the rest. Beacon Point, with a tenant rated AA- or better and bonds amortizing to 2042, priced at T+165 despite 95% leverage. El Paso, with A+ rated notes backed by Meta's lease and a 2048 final maturity, needed T+287.5 nine months after Hyperion, as order books thinned. Below investment grade the step is larger, and CoreWeave linked paper clears near 9.25% even on a secured basis. Hyperscaler corporate bonds are repricing as well. Amazon paid a new issue concession of 10 to 12bps on its $25bn July deal against a 2026 average near 4bps, and Meta's $25bn April deal drew a $96bn book against $125bn for its October 2025 deal. Oracle's $25bn February deal drew a $129bn book, yet its 10 year priced near T+145 while the US BBB index traded around T+95. The divergence is between steady demand for the largest tickets and a rising price for every notch of tenant risk.</a:t>
             </a:r>
             <a:endParaRPr lang="en-US" sz="1050" dirty="0"/>
           </a:p>
@@ -9303,7 +9303,7 @@
                 <a:ea typeface="Times New Roman" pitchFamily="34" charset="-122"/>
                 <a:cs typeface="Times New Roman" pitchFamily="34" charset="-120"/>
               </a:rPr>
-              <a:t>Yield at issue. Spreads were T+165, T+225 and T+287.5 for the first three. Yields span Oct 2025 to Sep 2026 and Treasury yields moved in between (the 10 year rose about a point), so spreads are the fair comparison.</a:t>
+              <a:t>Yield at issue, Oct 2025 to Sep 2026. Treasury yields moved over the period, so the spreads of T+165, T+225 and T+287.5 are the fair comparison.</a:t>
             </a:r>
             <a:endParaRPr lang="en-US" sz="700" dirty="0"/>
           </a:p>

</xml_diff>

<commit_message>
Committee v2 round 2: layout QA fixes
Co-Authored-By: Claude Opus 5.5 <noreply@anthropic.com>
Claude-Session: https://claude.ai/code/session_011SJZihQQoizcK7ApWgRNEa
</commit_message>
<xml_diff>
--- a/outputs/LLC_AI_Infrastructure_Case_Study.pptx
+++ b/outputs/LLC_AI_Infrastructure_Case_Study.pptx
@@ -2387,7 +2387,7 @@
         </p:nvSpPr>
         <p:spPr>
           <a:xfrm>
-            <a:off x="557784" y="2852928"/>
+            <a:off x="557784" y="3035808"/>
             <a:ext cx="5742432" cy="347472"/>
           </a:xfrm>
           <a:prstGeom prst="rect">
@@ -2426,8 +2426,8 @@
         </p:nvSpPr>
         <p:spPr>
           <a:xfrm>
-            <a:off x="557784" y="3218688"/>
-            <a:ext cx="5742432" cy="1783080"/>
+            <a:off x="557784" y="3401568"/>
+            <a:ext cx="5742432" cy="1691640"/>
           </a:xfrm>
           <a:prstGeom prst="rect">
             <a:avLst/>
@@ -2468,7 +2468,7 @@
         </p:nvSpPr>
         <p:spPr>
           <a:xfrm>
-            <a:off x="557784" y="5074920"/>
+            <a:off x="557784" y="5138928"/>
             <a:ext cx="5742432" cy="347472"/>
           </a:xfrm>
           <a:prstGeom prst="rect">
@@ -2507,8 +2507,8 @@
         </p:nvSpPr>
         <p:spPr>
           <a:xfrm>
-            <a:off x="557784" y="5440680"/>
-            <a:ext cx="5742432" cy="1234440"/>
+            <a:off x="557784" y="5504688"/>
+            <a:ext cx="5742432" cy="1188720"/>
           </a:xfrm>
           <a:prstGeom prst="rect">
             <a:avLst/>
@@ -3105,7 +3105,7 @@
                 <a:gridCol w="566928"/>
                 <a:gridCol w="1078992"/>
               </a:tblGrid>
-              <a:tr h="256032">
+              <a:tr h="283464">
                 <a:tc>
                   <a:txBody>
                     <a:bodyPr/>
@@ -3583,7 +3583,7 @@
                   </a:tcPr>
                 </a:tc>
               </a:tr>
-              <a:tr h="256032">
+              <a:tr h="283464">
                 <a:tc>
                   <a:txBody>
                     <a:bodyPr/>
@@ -4061,7 +4061,7 @@
                   </a:tcPr>
                 </a:tc>
               </a:tr>
-              <a:tr h="256032">
+              <a:tr h="283464">
                 <a:tc>
                   <a:txBody>
                     <a:bodyPr/>
@@ -4539,7 +4539,7 @@
                   </a:tcPr>
                 </a:tc>
               </a:tr>
-              <a:tr h="256032">
+              <a:tr h="283464">
                 <a:tc>
                   <a:txBody>
                     <a:bodyPr/>
@@ -5017,7 +5017,7 @@
                   </a:tcPr>
                 </a:tc>
               </a:tr>
-              <a:tr h="256032">
+              <a:tr h="283464">
                 <a:tc>
                   <a:txBody>
                     <a:bodyPr/>
@@ -5495,7 +5495,7 @@
                   </a:tcPr>
                 </a:tc>
               </a:tr>
-              <a:tr h="256032">
+              <a:tr h="283464">
                 <a:tc>
                   <a:txBody>
                     <a:bodyPr/>
@@ -5973,7 +5973,7 @@
                   </a:tcPr>
                 </a:tc>
               </a:tr>
-              <a:tr h="256032">
+              <a:tr h="283464">
                 <a:tc>
                   <a:txBody>
                     <a:bodyPr/>
@@ -6451,7 +6451,7 @@
                   </a:tcPr>
                 </a:tc>
               </a:tr>
-              <a:tr h="256032">
+              <a:tr h="283464">
                 <a:tc>
                   <a:txBody>
                     <a:bodyPr/>
@@ -6929,7 +6929,7 @@
                   </a:tcPr>
                 </a:tc>
               </a:tr>
-              <a:tr h="256032">
+              <a:tr h="283464">
                 <a:tc>
                   <a:txBody>
                     <a:bodyPr/>
@@ -7407,7 +7407,7 @@
                   </a:tcPr>
                 </a:tc>
               </a:tr>
-              <a:tr h="256032">
+              <a:tr h="283464">
                 <a:tc>
                   <a:txBody>
                     <a:bodyPr/>
@@ -7885,7 +7885,7 @@
                   </a:tcPr>
                 </a:tc>
               </a:tr>
-              <a:tr h="256032">
+              <a:tr h="283464">
                 <a:tc>
                   <a:txBody>
                     <a:bodyPr/>
@@ -8363,7 +8363,7 @@
                   </a:tcPr>
                 </a:tc>
               </a:tr>
-              <a:tr h="256032">
+              <a:tr h="283464">
                 <a:tc>
                   <a:txBody>
                     <a:bodyPr/>
@@ -8853,7 +8853,7 @@
         </p:nvSpPr>
         <p:spPr>
           <a:xfrm>
-            <a:off x="557784" y="6373368"/>
+            <a:off x="557784" y="6702552"/>
             <a:ext cx="5742432" cy="237744"/>
           </a:xfrm>
           <a:prstGeom prst="rect">
@@ -8892,7 +8892,7 @@
         </p:nvSpPr>
         <p:spPr>
           <a:xfrm>
-            <a:off x="557784" y="6684264"/>
+            <a:off x="557784" y="7077456"/>
             <a:ext cx="5742432" cy="347472"/>
           </a:xfrm>
           <a:prstGeom prst="rect">
@@ -8931,7 +8931,7 @@
         </p:nvSpPr>
         <p:spPr>
           <a:xfrm>
-            <a:off x="557784" y="7050024"/>
+            <a:off x="557784" y="7443216"/>
             <a:ext cx="5742432" cy="1828800"/>
           </a:xfrm>
           <a:prstGeom prst="rect">
@@ -9223,7 +9223,7 @@
         </p:nvSpPr>
         <p:spPr>
           <a:xfrm>
-            <a:off x="557784" y="3200400"/>
+            <a:off x="557784" y="3063240"/>
             <a:ext cx="2798064" cy="256032"/>
           </a:xfrm>
           <a:prstGeom prst="rect">
@@ -9261,7 +9261,7 @@
           <p:nvPr/>
         </p:nvGraphicFramePr>
         <p:xfrm>
-          <a:off x="557784" y="3493008"/>
+          <a:off x="557784" y="3355848"/>
           <a:ext cx="2798064" cy="1371600"/>
         </p:xfrm>
         <a:graphic xmlns:a="http://schemas.openxmlformats.org/drawingml/2006/main">
@@ -9278,7 +9278,7 @@
         </p:nvSpPr>
         <p:spPr>
           <a:xfrm>
-            <a:off x="557784" y="4882896"/>
+            <a:off x="557784" y="4745736"/>
             <a:ext cx="2798064" cy="237744"/>
           </a:xfrm>
           <a:prstGeom prst="rect">
@@ -9317,7 +9317,7 @@
         </p:nvSpPr>
         <p:spPr>
           <a:xfrm>
-            <a:off x="3502152" y="3200400"/>
+            <a:off x="3502152" y="3063240"/>
             <a:ext cx="2798064" cy="256032"/>
           </a:xfrm>
           <a:prstGeom prst="rect">
@@ -9355,7 +9355,7 @@
           <p:nvPr/>
         </p:nvGraphicFramePr>
         <p:xfrm>
-          <a:off x="3502152" y="3493008"/>
+          <a:off x="3502152" y="3355848"/>
           <a:ext cx="2798064" cy="1371600"/>
         </p:xfrm>
         <a:graphic xmlns:a="http://schemas.openxmlformats.org/drawingml/2006/main">
@@ -9372,7 +9372,7 @@
         </p:nvSpPr>
         <p:spPr>
           <a:xfrm>
-            <a:off x="3502152" y="4882896"/>
+            <a:off x="3502152" y="4745736"/>
             <a:ext cx="2798064" cy="237744"/>
           </a:xfrm>
           <a:prstGeom prst="rect">
@@ -9411,7 +9411,7 @@
         </p:nvSpPr>
         <p:spPr>
           <a:xfrm>
-            <a:off x="557784" y="5230368"/>
+            <a:off x="557784" y="5093208"/>
             <a:ext cx="5742432" cy="347472"/>
           </a:xfrm>
           <a:prstGeom prst="rect">
@@ -9450,7 +9450,7 @@
         </p:nvSpPr>
         <p:spPr>
           <a:xfrm>
-            <a:off x="557784" y="5596128"/>
+            <a:off x="557784" y="5458968"/>
             <a:ext cx="5742432" cy="1280160"/>
           </a:xfrm>
           <a:prstGeom prst="rect">
@@ -9492,7 +9492,7 @@
         </p:nvSpPr>
         <p:spPr>
           <a:xfrm>
-            <a:off x="557784" y="6967728"/>
+            <a:off x="557784" y="6830568"/>
             <a:ext cx="2743200" cy="347472"/>
           </a:xfrm>
           <a:prstGeom prst="rect">
@@ -9531,7 +9531,7 @@
         </p:nvSpPr>
         <p:spPr>
           <a:xfrm>
-            <a:off x="3557016" y="6967728"/>
+            <a:off x="3557016" y="6830568"/>
             <a:ext cx="2743200" cy="347472"/>
           </a:xfrm>
           <a:prstGeom prst="rect">
@@ -9570,8 +9570,8 @@
         </p:nvSpPr>
         <p:spPr>
           <a:xfrm>
-            <a:off x="557784" y="7333488"/>
-            <a:ext cx="2743200" cy="1965960"/>
+            <a:off x="557784" y="7196328"/>
+            <a:ext cx="2743200" cy="2057400"/>
           </a:xfrm>
           <a:prstGeom prst="rect">
             <a:avLst/>
@@ -9612,8 +9612,8 @@
         </p:nvSpPr>
         <p:spPr>
           <a:xfrm>
-            <a:off x="3557016" y="7333488"/>
-            <a:ext cx="2743200" cy="1965960"/>
+            <a:off x="3557016" y="7196328"/>
+            <a:ext cx="2743200" cy="2057400"/>
           </a:xfrm>
           <a:prstGeom prst="rect">
             <a:avLst/>

</xml_diff>

<commit_message>
Committee v2 final: 2 rounds complete on the three page rewrite
Round count: 2 (round 1 fact check, skeptic and continuity with chair
merge; round 2 style, charts, build, layout QA; fact checker rerun with
final fixes). Charts A and C verified; B and D held pending sources.

Co-Authored-By: Claude Opus 5.5 <noreply@anthropic.com>
Claude-Session: https://claude.ai/code/session_011SJZihQQoizcK7ApWgRNEa
</commit_message>
<xml_diff>
--- a/outputs/LLC_AI_Infrastructure_Case_Study.pptx
+++ b/outputs/LLC_AI_Infrastructure_Case_Study.pptx
@@ -1175,7 +1175,7 @@
 Horizontal bar, maroon shades, highest leverage on top
   Hut 8 Beacon Point bonds, loan to cost  |  95  |  Hut 8 and counsel via press
   Oracle Saline SPV bonds, loan to cost  |  about 85 (derived from 15% equity)  |  Related Digital and Blackstone releases
-  Aligned data center ABS, loan to value  |  70.0  |  Aligned release, S&amp;P presale
+  Aligned ABS master trust, senior LTV  |  about 70 (S&amp;P wording on past series)  |  S&amp;P via trade press
   xAI chip vehicle, advance on purchase  |  about 65 (derived, $3.5bn of $5.4bn)  |  Apollo release
   Stargate Abilene bank loans, loan to cost  |  about 64 (derived, $9.6bn of about $15bn)  |  Trade press
 Three of five bars are derived. Keep the footnote that says so, or swap them for bars with a stated ratio (for example Vantage UK ABS at 53.6% LTV).
@@ -1395,7 +1395,7 @@
   CoreWeave DDTL 3.0, OpenAI contract  |  400  |  CoreWeave release
   CoreWeave DDTL 5.0, Ba2 and BB+  |  450  |  CoreWeave release
   CoreWeave DDTL 5.5, Ba2 and BB+  |  550  |  CoreWeave 8-K exhibit
-DDTL 4.0's SOFR plus 225 appears in the company release per the research notes, but one research pass rated it aggregator only. Confirm in the release before verifying.
+All five margins confirmed against company releases and filings in reviews/fact-check-v2.md. DDTL 5.5 also reflects shorter customer contracts, not only timing.
   DDTL 3.0 https://investors.coreweave.com/news/news-details/2025/CoreWeave-Closes-2-6-Billion-Secured-Debt-Financing-Facility-Strengthening-Market-Position-as-AI-Cloud-Leader/default.aspx
   DDTL 4.0 https://investors.coreweave.com/news/news-details/2026/CoreWeave-Closes-Landmark-8-5-Billion-Financing-Facility-Achieving-First-Investment-Grade-Rated-GPU-backed-Financing/default.aspx
   DDTL 5.0 https://www.businesswire.com/news/home/20260518337916/en/
@@ -2454,7 +2454,7 @@
                 <a:ea typeface="Times New Roman" pitchFamily="34" charset="-122"/>
                 <a:cs typeface="Times New Roman" pitchFamily="34" charset="-120"/>
               </a:rPr>
-              <a:t>Lease backed debt is sized so contracted rent covers debt service with a thin cushion and bonds amortize before the lease and its renewals run out, so leverage rises with tenant strength. Hut 8's $4.25bn Beacon Point bonds, backed by a tenant rated AA- or better, financed 95% of project cost at T+165, which Hut 8 calls the highest loan to cost for an HPC data center bond. Oracle's Saline Township campus in Michigan raised about $14bn of bonds against $16.3bn of cost, or roughly 15% equity. Stabilized campuses are sized on value, and Aligned's ABS master trust, which added $1.18bn in July, caps senior notes at 70% of appraised value. GPU lenders lend less against depreciating collateral, and Apollo's $3.5bn for the xAI chip leasing vehicle equals about 65% of a $5.4bn purchase. KBRA cut the cash flow on the single tenant Ohio campus behind BX 2026 VLT10 to 18.9% below the issuer's figure and its value to 27.2% below appraisal, lifting leverage on the $1.26bn loan to 108.4%.</a:t>
+              <a:t>Lease backed debt is sized so contracted rent covers debt service and bonds amortize before the lease and its renewals run out, so leverage rises with tenant strength. Hut 8's $4.25bn Beacon Point bonds, backed by a tenant rated AA- or better, financed 95% of project cost at T+165, which Hut 8 calls the highest loan to cost for an HPC data center bond. Oracle's Saline Township campus raised about $14bn of bonds against $16.3bn of cost, or roughly 15% equity. Stabilized campuses are sized on value, and S&amp;P has put senior notes in Aligned's ABS master trust, which added $1.18bn in July, at about 70% of appraised value in past series. GPU lenders lend less against depreciating collateral, and Apollo's $3.5bn for the xAI chip leasing vehicle equals about 65% of a $5.4bn purchase. KBRA cut the cash flow on the single tenant campus behind BX 2026 VLT10 to 18.9% below the issuer's figure and its value to 27.2% below appraisal, lifting leverage on the $1.26bn loan to 108.4%.</a:t>
             </a:r>
             <a:endParaRPr lang="en-US" sz="1050" dirty="0"/>
           </a:p>
@@ -2535,7 +2535,7 @@
                 <a:ea typeface="Times New Roman" pitchFamily="34" charset="-122"/>
                 <a:cs typeface="Times New Roman" pitchFamily="34" charset="-120"/>
               </a:rPr>
-              <a:t>The debt is only as long as the lease behind it, and hyperscaler leases are short. Hyperion and El Paso both carry four year initial terms against bonds amortizing to 2049 and 2048, and Meta's residual value guarantee on Hyperion, about $28bn and covering the first 16 years, bridges the gap. Moody's counted $662bn of hyperscaler data center leases not yet commenced at the end of 2025, held off balance sheet and equal to 113% of their adjusted debt, and says it will treat part as debt, while S&amp;P accepted Hyperion as off balance sheet for Meta. The divergence is that one obligation is a lease to one agency and debt to another, so a tenant downgrade passes straight through.</a:t>
+              <a:t>The debt is only as long as the lease behind it, and hyperscaler leases are short. Hyperion and El Paso carry four year initial terms against bonds amortizing to 2049 and 2048, and Meta's residual value guarantee on Hyperion, capped at about $28bn and covering the first 16 years, bridges most of the gap. Moody's counted $662bn of hyperscaler data center leases not yet commenced at end 2025, held off balance sheet and equal to 113% of their adjusted debt, and says it will treat part as debt, while S&amp;P accepted Hyperion as off balance sheet for Meta. The divergence is that one obligation is a lease to one agency and debt to another, so a tenant downgrade passes through.</a:t>
             </a:r>
             <a:endParaRPr lang="en-US" sz="1050" dirty="0"/>
           </a:p>
@@ -6399,7 +6399,7 @@
                           <a:ea typeface="Times New Roman" pitchFamily="34" charset="-122"/>
                           <a:cs typeface="Times New Roman" pitchFamily="34" charset="-120"/>
                         </a:rPr>
-                        <a:t>70% LTV cap</a:t>
+                        <a:t>~70% LTV (past series)</a:t>
                       </a:r>
                       <a:endParaRPr lang="en-US" sz="800" dirty="0">
                         <a:latin typeface="Times New Roman" charset="0"/>
@@ -8878,7 +8878,7 @@
                 <a:ea typeface="Times New Roman" pitchFamily="34" charset="-122"/>
                 <a:cs typeface="Times New Roman" pitchFamily="34" charset="-120"/>
               </a:rPr>
-              <a:t>LTC is loan to cost and LTV is loan to value. Ratings are S&amp;P, Moody's, Fitch or KBRA as reported, and El Paso shows S&amp;P then Fitch. Saline LTC is derived from the reported 15% equity.</a:t>
+              <a:t>LTC is loan to cost and LTV is loan to value. Ratings are S&amp;P, Moody's, Fitch or KBRA as reported, and El Paso shows S&amp;P then Fitch. Saline LTC is derived from $14bn of bonds against $16.3bn of cost.</a:t>
             </a:r>
             <a:endParaRPr lang="en-US" sz="700" dirty="0"/>
           </a:p>
@@ -8959,7 +8959,7 @@
                 <a:ea typeface="Times New Roman" pitchFamily="34" charset="-122"/>
                 <a:cs typeface="Times New Roman" pitchFamily="34" charset="-120"/>
               </a:rPr>
-              <a:t>The tenant sets the starting point, and tenor and timing set the rest. Beacon Point, with a tenant rated AA- or better and bonds amortizing to 2042, priced at T+165 despite 95% leverage. El Paso, with A+ rated notes backed by Meta's lease and a 2048 final maturity, needed T+287.5 nine months after Hyperion, as order books thinned. Below investment grade the step is larger, and CoreWeave linked paper clears near 9.25% even on a secured basis. Hyperscaler corporate bonds are repricing as well. Amazon paid a new issue concession of 10 to 12bps on its $25bn July deal against a 2026 average near 4bps, and Meta's $25bn April deal drew a $96bn book against $125bn for its October 2025 deal. Oracle's $25bn February deal drew a $129bn book, yet its 10 year priced near T+145 while the US BBB index traded around T+95. The divergence is between steady demand for the largest tickets and a rising price for every notch of tenant risk.</a:t>
+              <a:t>The tenant sets the starting point, and tenor and timing set the rest. Beacon Point, with a tenant rated AA- or better and bonds amortizing to 2042, priced at T+165 despite 95% leverage. El Paso, with A+ rated notes backed by Meta's lease and a 2048 final maturity, needed T+287.5 nine months after Hyperion, as order books thinned. Below investment grade the step is larger, and CoreWeave linked paper clears near 9.25% even when secured. Among corporates, Amazon paid a new issue concession of 10 to 12bps on its $25bn July deal against a 2026 average near 4bps, and Meta's $25bn April deal drew a $96bn book against $125bn for its October 2025 deal. Oracle's $25bn February deal drew a $129bn book, yet its 10 year priced near T+145 while TwentyFour Asset Management put the US BBB index near T+95. The divergence is between steady demand for the largest tickets and a rising price for every notch of tenant risk.</a:t>
             </a:r>
             <a:endParaRPr lang="en-US" sz="1050" dirty="0"/>
           </a:p>
@@ -9598,7 +9598,7 @@
                 <a:ea typeface="Times New Roman" pitchFamily="34" charset="-122"/>
                 <a:cs typeface="Times New Roman" pitchFamily="34" charset="-120"/>
               </a:rPr>
-              <a:t>Meta's two joint ventures share one template, a four year initial lease, a residual value guarantee covering the first 16 years, and A+ rated amortizing bonds. On Hyperion the guarantee totals about $28bn against $27.3bn of bonds, and rent begins in June 2029. Hyperion priced at 6.581%, or T+225, in October 2025. El Paso priced $12.5bn at 7.534%, or T+287.5, in July, with Fitch one notch higher at AA-. The 62.5bps wider spread on the same tenant shows that investors now price supply, structure, and timing on top of Meta's credit.</a:t>
+              <a:t>Meta's two joint ventures share one template, a four year initial lease, a residual value guarantee covering the first 16 years, and A+ rated amortizing bonds. On Hyperion the guarantee totals about $28bn against $27.3bn of bonds, and rent begins in 2029. Hyperion priced at 6.581%, or T+225, in October 2025. El Paso priced $12.5bn at 7.534%, or T+287.5, in July, with Fitch one notch higher at AA-. The 62.5bps wider spread on the same tenant suggests that investors now price supply and timing on top of Meta's credit.</a:t>
             </a:r>
             <a:endParaRPr lang="en-US" sz="1050" dirty="0"/>
           </a:p>
@@ -9640,7 +9640,7 @@
                 <a:ea typeface="Times New Roman" pitchFamily="34" charset="-122"/>
                 <a:cs typeface="Times New Roman" pitchFamily="34" charset="-120"/>
               </a:rPr>
-              <a:t>CoreWeave's pricing depends on who pays. Its $8.5bn DDTL 4.0, backed by GPUs serving Meta, is rated A3 by Moody's and priced at SOFR plus 225. DDTL 3.0, tied to OpenAI, priced at SOFR plus 400. The $3.1bn DDTL 5.0 in May priced at SOFR plus 450 with Ba2 and BB+ ratings, and the $2.6bn DDTL 5.5 in August priced at SOFR plus 550 at the same ratings. The company itself is rated B+ by S&amp;P. The 325bps gap between its A3 and Ba2 facilities mostly prices counterparty risk, though the 100bps move between May and August shows timing matters too.</a:t>
+              <a:t>CoreWeave's pricing depends on who pays. Its $8.5bn DDTL 4.0, backed by GPUs serving Meta, is rated A3 by Moody's and priced at SOFR plus 225. DDTL 3.0, tied to OpenAI, priced at SOFR plus 400. The $3.1bn DDTL 5.0 in May priced at SOFR plus 450 with Ba2 and BB+ ratings, and the $2.6bn DDTL 5.5 in August priced at SOFR plus 550 at the same ratings. The 325bps gap between its A3 and Ba2 facilities mostly prices counterparty risk, though the 100bps step from May to August, on shorter customer contracts, shows contract length and timing matter too.</a:t>
             </a:r>
             <a:endParaRPr lang="en-US" sz="1050" dirty="0"/>
           </a:p>

</xml_diff>